<commit_message>
setting up v2 main model builds
</commit_message>
<xml_diff>
--- a/strategy/BBL Fantasy AI v2 Strategy & Planning.pptx
+++ b/strategy/BBL Fantasy AI v2 Strategy & Planning.pptx
@@ -7,6 +7,10 @@
   <p:sldIdLst>
     <p:sldId id="256" r:id="rId2"/>
     <p:sldId id="257" r:id="rId3"/>
+    <p:sldId id="258" r:id="rId4"/>
+    <p:sldId id="259" r:id="rId5"/>
+    <p:sldId id="260" r:id="rId6"/>
+    <p:sldId id="261" r:id="rId7"/>
   </p:sldIdLst>
   <p:sldSz cx="12192000" cy="6858000"/>
   <p:notesSz cx="6858000" cy="9144000"/>
@@ -112,12 +116,446 @@
           <p14:sldIdLst>
             <p14:sldId id="256"/>
             <p14:sldId id="257"/>
+            <p14:sldId id="258"/>
+            <p14:sldId id="259"/>
+            <p14:sldId id="260"/>
+            <p14:sldId id="261"/>
           </p14:sldIdLst>
         </p14:section>
       </p14:sectionLst>
     </p:ext>
+    <p:ext uri="{EFAFB233-063F-42B5-8137-9DF3F51BA10A}">
+      <p15:sldGuideLst xmlns:p15="http://schemas.microsoft.com/office/powerpoint/2012/main">
+        <p15:guide id="1" orient="horz" pos="2160" userDrawn="1">
+          <p15:clr>
+            <a:srgbClr val="A4A3A4"/>
+          </p15:clr>
+        </p15:guide>
+        <p15:guide id="2" pos="3840" userDrawn="1">
+          <p15:clr>
+            <a:srgbClr val="A4A3A4"/>
+          </p15:clr>
+        </p15:guide>
+      </p15:sldGuideLst>
+    </p:ext>
   </p:extLst>
 </p:presentation>
+</file>
+
+<file path=ppt/revisionInfo.xml><?xml version="1.0" encoding="utf-8"?>
+<p1510:revInfo xmlns:a="http://schemas.openxmlformats.org/drawingml/2006/main" xmlns:r="http://schemas.openxmlformats.org/officeDocument/2006/relationships" xmlns:p1510="http://schemas.microsoft.com/office/powerpoint/2015/10/main">
+  <p1510:revLst>
+    <p1510:client id="{B4EA8C78-5629-4CB8-9794-5E1861B660A8}" v="4" dt="2025-06-04T11:46:47.040"/>
+  </p1510:revLst>
+</p1510:revInfo>
+</file>
+
+<file path=ppt/changesInfos/changesInfo1.xml><?xml version="1.0" encoding="utf-8"?>
+<pc:chgInfo xmlns:a="http://schemas.openxmlformats.org/drawingml/2006/main" xmlns:r="http://schemas.openxmlformats.org/officeDocument/2006/relationships" xmlns:ac="http://schemas.microsoft.com/office/drawing/2013/main/command" xmlns:pc="http://schemas.microsoft.com/office/powerpoint/2013/main/command">
+  <pc:docChgLst>
+    <pc:chgData name="Dilan De Silva" userId="579b606d6e18a4ed" providerId="LiveId" clId="{B4EA8C78-5629-4CB8-9794-5E1861B660A8}"/>
+    <pc:docChg chg="undo custSel addSld delSld modSld modSection">
+      <pc:chgData name="Dilan De Silva" userId="579b606d6e18a4ed" providerId="LiveId" clId="{B4EA8C78-5629-4CB8-9794-5E1861B660A8}" dt="2025-06-04T11:53:20.945" v="351" actId="20577"/>
+      <pc:docMkLst>
+        <pc:docMk/>
+      </pc:docMkLst>
+      <pc:sldChg chg="modSp mod">
+        <pc:chgData name="Dilan De Silva" userId="579b606d6e18a4ed" providerId="LiveId" clId="{B4EA8C78-5629-4CB8-9794-5E1861B660A8}" dt="2025-06-04T11:53:20.945" v="351" actId="20577"/>
+        <pc:sldMkLst>
+          <pc:docMk/>
+          <pc:sldMk cId="1969437762" sldId="257"/>
+        </pc:sldMkLst>
+        <pc:spChg chg="mod">
+          <ac:chgData name="Dilan De Silva" userId="579b606d6e18a4ed" providerId="LiveId" clId="{B4EA8C78-5629-4CB8-9794-5E1861B660A8}" dt="2025-06-04T11:53:20.945" v="351" actId="20577"/>
+          <ac:spMkLst>
+            <pc:docMk/>
+            <pc:sldMk cId="1969437762" sldId="257"/>
+            <ac:spMk id="5" creationId="{80194462-8D64-20D4-246C-4E22D630ECE3}"/>
+          </ac:spMkLst>
+        </pc:spChg>
+      </pc:sldChg>
+      <pc:sldChg chg="addSp delSp modSp new mod setBg">
+        <pc:chgData name="Dilan De Silva" userId="579b606d6e18a4ed" providerId="LiveId" clId="{B4EA8C78-5629-4CB8-9794-5E1861B660A8}" dt="2025-06-04T11:50:54.585" v="325" actId="26606"/>
+        <pc:sldMkLst>
+          <pc:docMk/>
+          <pc:sldMk cId="1471337115" sldId="258"/>
+        </pc:sldMkLst>
+        <pc:spChg chg="mod">
+          <ac:chgData name="Dilan De Silva" userId="579b606d6e18a4ed" providerId="LiveId" clId="{B4EA8C78-5629-4CB8-9794-5E1861B660A8}" dt="2025-06-04T11:50:54.585" v="325" actId="26606"/>
+          <ac:spMkLst>
+            <pc:docMk/>
+            <pc:sldMk cId="1471337115" sldId="258"/>
+            <ac:spMk id="2" creationId="{DCD29F56-BA59-FAF6-79C8-A248333FA0BB}"/>
+          </ac:spMkLst>
+        </pc:spChg>
+        <pc:spChg chg="mod">
+          <ac:chgData name="Dilan De Silva" userId="579b606d6e18a4ed" providerId="LiveId" clId="{B4EA8C78-5629-4CB8-9794-5E1861B660A8}" dt="2025-06-04T11:50:54.585" v="325" actId="26606"/>
+          <ac:spMkLst>
+            <pc:docMk/>
+            <pc:sldMk cId="1471337115" sldId="258"/>
+            <ac:spMk id="3" creationId="{6AA0120E-7982-2BE3-3FA1-358B5018E8F7}"/>
+          </ac:spMkLst>
+        </pc:spChg>
+        <pc:spChg chg="add del">
+          <ac:chgData name="Dilan De Silva" userId="579b606d6e18a4ed" providerId="LiveId" clId="{B4EA8C78-5629-4CB8-9794-5E1861B660A8}" dt="2025-06-04T11:50:15.728" v="319" actId="26606"/>
+          <ac:spMkLst>
+            <pc:docMk/>
+            <pc:sldMk cId="1471337115" sldId="258"/>
+            <ac:spMk id="8" creationId="{907EF6B7-1338-4443-8C46-6A318D952DFD}"/>
+          </ac:spMkLst>
+        </pc:spChg>
+        <pc:spChg chg="add del">
+          <ac:chgData name="Dilan De Silva" userId="579b606d6e18a4ed" providerId="LiveId" clId="{B4EA8C78-5629-4CB8-9794-5E1861B660A8}" dt="2025-06-04T11:50:15.728" v="319" actId="26606"/>
+          <ac:spMkLst>
+            <pc:docMk/>
+            <pc:sldMk cId="1471337115" sldId="258"/>
+            <ac:spMk id="10" creationId="{DAAE4CDD-124C-4DCF-9584-B6033B545DD5}"/>
+          </ac:spMkLst>
+        </pc:spChg>
+        <pc:spChg chg="add del">
+          <ac:chgData name="Dilan De Silva" userId="579b606d6e18a4ed" providerId="LiveId" clId="{B4EA8C78-5629-4CB8-9794-5E1861B660A8}" dt="2025-06-04T11:50:15.728" v="319" actId="26606"/>
+          <ac:spMkLst>
+            <pc:docMk/>
+            <pc:sldMk cId="1471337115" sldId="258"/>
+            <ac:spMk id="12" creationId="{081E4A58-353D-44AE-B2FC-2A74E2E400F7}"/>
+          </ac:spMkLst>
+        </pc:spChg>
+        <pc:spChg chg="add del">
+          <ac:chgData name="Dilan De Silva" userId="579b606d6e18a4ed" providerId="LiveId" clId="{B4EA8C78-5629-4CB8-9794-5E1861B660A8}" dt="2025-06-04T11:50:54.585" v="325" actId="26606"/>
+          <ac:spMkLst>
+            <pc:docMk/>
+            <pc:sldMk cId="1471337115" sldId="258"/>
+            <ac:spMk id="14" creationId="{21C9FE86-FCC3-4A31-AA1C-C882262B7FE7}"/>
+          </ac:spMkLst>
+        </pc:spChg>
+        <pc:spChg chg="add del">
+          <ac:chgData name="Dilan De Silva" userId="579b606d6e18a4ed" providerId="LiveId" clId="{B4EA8C78-5629-4CB8-9794-5E1861B660A8}" dt="2025-06-04T11:50:54.585" v="325" actId="26606"/>
+          <ac:spMkLst>
+            <pc:docMk/>
+            <pc:sldMk cId="1471337115" sldId="258"/>
+            <ac:spMk id="15" creationId="{DEE2AD96-B495-4E06-9291-B71706F728CB}"/>
+          </ac:spMkLst>
+        </pc:spChg>
+        <pc:spChg chg="add del">
+          <ac:chgData name="Dilan De Silva" userId="579b606d6e18a4ed" providerId="LiveId" clId="{B4EA8C78-5629-4CB8-9794-5E1861B660A8}" dt="2025-06-04T11:50:54.585" v="325" actId="26606"/>
+          <ac:spMkLst>
+            <pc:docMk/>
+            <pc:sldMk cId="1471337115" sldId="258"/>
+            <ac:spMk id="16" creationId="{7D96243B-ECED-4B71-8E06-AE9A285EAD20}"/>
+          </ac:spMkLst>
+        </pc:spChg>
+        <pc:spChg chg="add del">
+          <ac:chgData name="Dilan De Silva" userId="579b606d6e18a4ed" providerId="LiveId" clId="{B4EA8C78-5629-4CB8-9794-5E1861B660A8}" dt="2025-06-04T11:50:54.585" v="325" actId="26606"/>
+          <ac:spMkLst>
+            <pc:docMk/>
+            <pc:sldMk cId="1471337115" sldId="258"/>
+            <ac:spMk id="17" creationId="{53CF6D67-C5A8-4ADD-9E8E-1E38CA1D3166}"/>
+          </ac:spMkLst>
+        </pc:spChg>
+        <pc:spChg chg="add del">
+          <ac:chgData name="Dilan De Silva" userId="579b606d6e18a4ed" providerId="LiveId" clId="{B4EA8C78-5629-4CB8-9794-5E1861B660A8}" dt="2025-06-04T11:50:54.585" v="325" actId="26606"/>
+          <ac:spMkLst>
+            <pc:docMk/>
+            <pc:sldMk cId="1471337115" sldId="258"/>
+            <ac:spMk id="18" creationId="{A09989E4-EFDC-4A90-A633-E0525FB4139E}"/>
+          </ac:spMkLst>
+        </pc:spChg>
+        <pc:spChg chg="add del">
+          <ac:chgData name="Dilan De Silva" userId="579b606d6e18a4ed" providerId="LiveId" clId="{B4EA8C78-5629-4CB8-9794-5E1861B660A8}" dt="2025-06-04T11:50:54.585" v="325" actId="26606"/>
+          <ac:spMkLst>
+            <pc:docMk/>
+            <pc:sldMk cId="1471337115" sldId="258"/>
+            <ac:spMk id="19" creationId="{86909FA0-B515-4681-B7A8-FA281D133B94}"/>
+          </ac:spMkLst>
+        </pc:spChg>
+        <pc:spChg chg="add del">
+          <ac:chgData name="Dilan De Silva" userId="579b606d6e18a4ed" providerId="LiveId" clId="{B4EA8C78-5629-4CB8-9794-5E1861B660A8}" dt="2025-06-04T11:50:54" v="324" actId="26606"/>
+          <ac:spMkLst>
+            <pc:docMk/>
+            <pc:sldMk cId="1471337115" sldId="258"/>
+            <ac:spMk id="24" creationId="{C2554CA6-288E-4202-BC52-2E5A8F0C0AED}"/>
+          </ac:spMkLst>
+        </pc:spChg>
+        <pc:spChg chg="add del">
+          <ac:chgData name="Dilan De Silva" userId="579b606d6e18a4ed" providerId="LiveId" clId="{B4EA8C78-5629-4CB8-9794-5E1861B660A8}" dt="2025-06-04T11:50:46.650" v="322" actId="26606"/>
+          <ac:spMkLst>
+            <pc:docMk/>
+            <pc:sldMk cId="1471337115" sldId="258"/>
+            <ac:spMk id="25" creationId="{E51BA4DF-2BD4-4EC2-B1DB-B27C8AC71864}"/>
+          </ac:spMkLst>
+        </pc:spChg>
+        <pc:spChg chg="add del">
+          <ac:chgData name="Dilan De Silva" userId="579b606d6e18a4ed" providerId="LiveId" clId="{B4EA8C78-5629-4CB8-9794-5E1861B660A8}" dt="2025-06-04T11:50:54" v="324" actId="26606"/>
+          <ac:spMkLst>
+            <pc:docMk/>
+            <pc:sldMk cId="1471337115" sldId="258"/>
+            <ac:spMk id="26" creationId="{B10BB131-AC8E-4A8E-A5D1-36260F720C3B}"/>
+          </ac:spMkLst>
+        </pc:spChg>
+        <pc:spChg chg="add del">
+          <ac:chgData name="Dilan De Silva" userId="579b606d6e18a4ed" providerId="LiveId" clId="{B4EA8C78-5629-4CB8-9794-5E1861B660A8}" dt="2025-06-04T11:50:54" v="324" actId="26606"/>
+          <ac:spMkLst>
+            <pc:docMk/>
+            <pc:sldMk cId="1471337115" sldId="258"/>
+            <ac:spMk id="28" creationId="{5B7778FC-632E-4DCA-A7CB-0D7731CCF970}"/>
+          </ac:spMkLst>
+        </pc:spChg>
+        <pc:spChg chg="add del">
+          <ac:chgData name="Dilan De Silva" userId="579b606d6e18a4ed" providerId="LiveId" clId="{B4EA8C78-5629-4CB8-9794-5E1861B660A8}" dt="2025-06-04T11:50:54" v="324" actId="26606"/>
+          <ac:spMkLst>
+            <pc:docMk/>
+            <pc:sldMk cId="1471337115" sldId="258"/>
+            <ac:spMk id="30" creationId="{FA23A907-97FB-4A8F-880A-DD77401C4296}"/>
+          </ac:spMkLst>
+        </pc:spChg>
+        <pc:picChg chg="add del">
+          <ac:chgData name="Dilan De Silva" userId="579b606d6e18a4ed" providerId="LiveId" clId="{B4EA8C78-5629-4CB8-9794-5E1861B660A8}" dt="2025-06-04T11:50:46.650" v="322" actId="26606"/>
+          <ac:picMkLst>
+            <pc:docMk/>
+            <pc:sldMk cId="1471337115" sldId="258"/>
+            <ac:picMk id="21" creationId="{177C5153-58F6-5D3A-8D0E-54723CBCC58C}"/>
+          </ac:picMkLst>
+        </pc:picChg>
+      </pc:sldChg>
+      <pc:sldChg chg="addSp delSp modSp add mod setBg">
+        <pc:chgData name="Dilan De Silva" userId="579b606d6e18a4ed" providerId="LiveId" clId="{B4EA8C78-5629-4CB8-9794-5E1861B660A8}" dt="2025-06-04T11:43:17.177" v="278" actId="14100"/>
+        <pc:sldMkLst>
+          <pc:docMk/>
+          <pc:sldMk cId="3689564591" sldId="259"/>
+        </pc:sldMkLst>
+        <pc:spChg chg="mod">
+          <ac:chgData name="Dilan De Silva" userId="579b606d6e18a4ed" providerId="LiveId" clId="{B4EA8C78-5629-4CB8-9794-5E1861B660A8}" dt="2025-06-04T11:41:55.682" v="266" actId="120"/>
+          <ac:spMkLst>
+            <pc:docMk/>
+            <pc:sldMk cId="3689564591" sldId="259"/>
+            <ac:spMk id="2" creationId="{634F4B6D-B859-81E2-585F-115E16516769}"/>
+          </ac:spMkLst>
+        </pc:spChg>
+        <pc:spChg chg="del">
+          <ac:chgData name="Dilan De Silva" userId="579b606d6e18a4ed" providerId="LiveId" clId="{B4EA8C78-5629-4CB8-9794-5E1861B660A8}" dt="2025-06-04T11:39:44.756" v="254" actId="478"/>
+          <ac:spMkLst>
+            <pc:docMk/>
+            <pc:sldMk cId="3689564591" sldId="259"/>
+            <ac:spMk id="3" creationId="{0DF82F1A-9CA6-D0BF-8E13-9118095E8C40}"/>
+          </ac:spMkLst>
+        </pc:spChg>
+        <pc:spChg chg="add del mod">
+          <ac:chgData name="Dilan De Silva" userId="579b606d6e18a4ed" providerId="LiveId" clId="{B4EA8C78-5629-4CB8-9794-5E1861B660A8}" dt="2025-06-04T11:39:46.203" v="255" actId="478"/>
+          <ac:spMkLst>
+            <pc:docMk/>
+            <pc:sldMk cId="3689564591" sldId="259"/>
+            <ac:spMk id="5" creationId="{4C5D2196-DF3C-B032-394F-B89861FD881B}"/>
+          </ac:spMkLst>
+        </pc:spChg>
+        <pc:spChg chg="add">
+          <ac:chgData name="Dilan De Silva" userId="579b606d6e18a4ed" providerId="LiveId" clId="{B4EA8C78-5629-4CB8-9794-5E1861B660A8}" dt="2025-06-04T11:40:49" v="259" actId="26606"/>
+          <ac:spMkLst>
+            <pc:docMk/>
+            <pc:sldMk cId="3689564591" sldId="259"/>
+            <ac:spMk id="12" creationId="{A4AC5506-6312-4701-8D3C-40187889A947}"/>
+          </ac:spMkLst>
+        </pc:spChg>
+        <pc:picChg chg="add mod">
+          <ac:chgData name="Dilan De Silva" userId="579b606d6e18a4ed" providerId="LiveId" clId="{B4EA8C78-5629-4CB8-9794-5E1861B660A8}" dt="2025-06-04T11:42:11.719" v="269" actId="1076"/>
+          <ac:picMkLst>
+            <pc:docMk/>
+            <pc:sldMk cId="3689564591" sldId="259"/>
+            <ac:picMk id="7" creationId="{A158E25A-46C3-E912-DFCF-F3A95F3F1F98}"/>
+          </ac:picMkLst>
+        </pc:picChg>
+        <pc:picChg chg="add mod modCrop">
+          <ac:chgData name="Dilan De Silva" userId="579b606d6e18a4ed" providerId="LiveId" clId="{B4EA8C78-5629-4CB8-9794-5E1861B660A8}" dt="2025-06-04T11:43:17.177" v="278" actId="14100"/>
+          <ac:picMkLst>
+            <pc:docMk/>
+            <pc:sldMk cId="3689564591" sldId="259"/>
+            <ac:picMk id="9" creationId="{18DAAFF2-7EB9-DAD9-DE9F-137C76ED5049}"/>
+          </ac:picMkLst>
+        </pc:picChg>
+        <pc:picChg chg="add mod">
+          <ac:chgData name="Dilan De Silva" userId="579b606d6e18a4ed" providerId="LiveId" clId="{B4EA8C78-5629-4CB8-9794-5E1861B660A8}" dt="2025-06-04T11:42:54.622" v="274" actId="1076"/>
+          <ac:picMkLst>
+            <pc:docMk/>
+            <pc:sldMk cId="3689564591" sldId="259"/>
+            <ac:picMk id="11" creationId="{13BF7B19-1051-10FA-A909-0441C239D5AE}"/>
+          </ac:picMkLst>
+        </pc:picChg>
+      </pc:sldChg>
+      <pc:sldChg chg="delSp add del setBg delDesignElem">
+        <pc:chgData name="Dilan De Silva" userId="579b606d6e18a4ed" providerId="LiveId" clId="{B4EA8C78-5629-4CB8-9794-5E1861B660A8}" dt="2025-06-04T11:43:28.091" v="281" actId="47"/>
+        <pc:sldMkLst>
+          <pc:docMk/>
+          <pc:sldMk cId="3635980319" sldId="260"/>
+        </pc:sldMkLst>
+        <pc:spChg chg="del">
+          <ac:chgData name="Dilan De Silva" userId="579b606d6e18a4ed" providerId="LiveId" clId="{B4EA8C78-5629-4CB8-9794-5E1861B660A8}" dt="2025-06-04T11:43:20.431" v="280"/>
+          <ac:spMkLst>
+            <pc:docMk/>
+            <pc:sldMk cId="3635980319" sldId="260"/>
+            <ac:spMk id="12" creationId="{BD3E3139-69B3-EF75-1D3F-6E80688BF8A1}"/>
+          </ac:spMkLst>
+        </pc:spChg>
+      </pc:sldChg>
+      <pc:sldChg chg="addSp delSp modSp add mod setBg delDesignElem">
+        <pc:chgData name="Dilan De Silva" userId="579b606d6e18a4ed" providerId="LiveId" clId="{B4EA8C78-5629-4CB8-9794-5E1861B660A8}" dt="2025-06-04T11:46:42.393" v="308" actId="14100"/>
+        <pc:sldMkLst>
+          <pc:docMk/>
+          <pc:sldMk cId="4008747595" sldId="260"/>
+        </pc:sldMkLst>
+        <pc:spChg chg="mod">
+          <ac:chgData name="Dilan De Silva" userId="579b606d6e18a4ed" providerId="LiveId" clId="{B4EA8C78-5629-4CB8-9794-5E1861B660A8}" dt="2025-06-04T11:45:12.160" v="298" actId="120"/>
+          <ac:spMkLst>
+            <pc:docMk/>
+            <pc:sldMk cId="4008747595" sldId="260"/>
+            <ac:spMk id="2" creationId="{BEED9832-E790-FEA8-6024-89D616225AB2}"/>
+          </ac:spMkLst>
+        </pc:spChg>
+        <pc:spChg chg="add">
+          <ac:chgData name="Dilan De Silva" userId="579b606d6e18a4ed" providerId="LiveId" clId="{B4EA8C78-5629-4CB8-9794-5E1861B660A8}" dt="2025-06-04T11:45:01.674" v="295" actId="26606"/>
+          <ac:spMkLst>
+            <pc:docMk/>
+            <pc:sldMk cId="4008747595" sldId="260"/>
+            <ac:spMk id="6" creationId="{A4AC5506-6312-4701-8D3C-40187889A947}"/>
+          </ac:spMkLst>
+        </pc:spChg>
+        <pc:spChg chg="del">
+          <ac:chgData name="Dilan De Silva" userId="579b606d6e18a4ed" providerId="LiveId" clId="{B4EA8C78-5629-4CB8-9794-5E1861B660A8}" dt="2025-06-04T11:43:35.442" v="283"/>
+          <ac:spMkLst>
+            <pc:docMk/>
+            <pc:sldMk cId="4008747595" sldId="260"/>
+            <ac:spMk id="12" creationId="{426A7368-99AE-D5EB-011B-646DC6C76C88}"/>
+          </ac:spMkLst>
+        </pc:spChg>
+        <pc:picChg chg="add mod">
+          <ac:chgData name="Dilan De Silva" userId="579b606d6e18a4ed" providerId="LiveId" clId="{B4EA8C78-5629-4CB8-9794-5E1861B660A8}" dt="2025-06-04T11:45:07.352" v="297" actId="1076"/>
+          <ac:picMkLst>
+            <pc:docMk/>
+            <pc:sldMk cId="4008747595" sldId="260"/>
+            <ac:picMk id="4" creationId="{46ADA508-1956-0619-0812-604D6A80AA3D}"/>
+          </ac:picMkLst>
+        </pc:picChg>
+        <pc:picChg chg="del">
+          <ac:chgData name="Dilan De Silva" userId="579b606d6e18a4ed" providerId="LiveId" clId="{B4EA8C78-5629-4CB8-9794-5E1861B660A8}" dt="2025-06-04T11:44:27.829" v="289" actId="478"/>
+          <ac:picMkLst>
+            <pc:docMk/>
+            <pc:sldMk cId="4008747595" sldId="260"/>
+            <ac:picMk id="7" creationId="{B4D6DD62-E031-EFB6-3B5D-98BFAF1D453D}"/>
+          </ac:picMkLst>
+        </pc:picChg>
+        <pc:picChg chg="add mod">
+          <ac:chgData name="Dilan De Silva" userId="579b606d6e18a4ed" providerId="LiveId" clId="{B4EA8C78-5629-4CB8-9794-5E1861B660A8}" dt="2025-06-04T11:45:35.399" v="301" actId="1076"/>
+          <ac:picMkLst>
+            <pc:docMk/>
+            <pc:sldMk cId="4008747595" sldId="260"/>
+            <ac:picMk id="8" creationId="{21BBA2F4-FEC3-3E5E-40AF-06BB3E73DA43}"/>
+          </ac:picMkLst>
+        </pc:picChg>
+        <pc:picChg chg="del">
+          <ac:chgData name="Dilan De Silva" userId="579b606d6e18a4ed" providerId="LiveId" clId="{B4EA8C78-5629-4CB8-9794-5E1861B660A8}" dt="2025-06-04T11:44:32.408" v="291" actId="478"/>
+          <ac:picMkLst>
+            <pc:docMk/>
+            <pc:sldMk cId="4008747595" sldId="260"/>
+            <ac:picMk id="9" creationId="{8E082431-13F4-A59C-C1AD-60F1B4EFF310}"/>
+          </ac:picMkLst>
+        </pc:picChg>
+        <pc:picChg chg="del">
+          <ac:chgData name="Dilan De Silva" userId="579b606d6e18a4ed" providerId="LiveId" clId="{B4EA8C78-5629-4CB8-9794-5E1861B660A8}" dt="2025-06-04T11:44:30.026" v="290" actId="478"/>
+          <ac:picMkLst>
+            <pc:docMk/>
+            <pc:sldMk cId="4008747595" sldId="260"/>
+            <ac:picMk id="11" creationId="{DC3C450D-DA42-6D36-10EE-3A2DDADD55E6}"/>
+          </ac:picMkLst>
+        </pc:picChg>
+        <pc:picChg chg="add mod modCrop">
+          <ac:chgData name="Dilan De Silva" userId="579b606d6e18a4ed" providerId="LiveId" clId="{B4EA8C78-5629-4CB8-9794-5E1861B660A8}" dt="2025-06-04T11:46:42.393" v="308" actId="14100"/>
+          <ac:picMkLst>
+            <pc:docMk/>
+            <pc:sldMk cId="4008747595" sldId="260"/>
+            <ac:picMk id="13" creationId="{F2F1FC21-77D3-F860-F9D5-C4F4D504C51A}"/>
+          </ac:picMkLst>
+        </pc:picChg>
+      </pc:sldChg>
+      <pc:sldChg chg="addSp delSp modSp add mod setBg delDesignElem">
+        <pc:chgData name="Dilan De Silva" userId="579b606d6e18a4ed" providerId="LiveId" clId="{B4EA8C78-5629-4CB8-9794-5E1861B660A8}" dt="2025-06-04T11:52:54.903" v="340" actId="14100"/>
+        <pc:sldMkLst>
+          <pc:docMk/>
+          <pc:sldMk cId="2965452809" sldId="261"/>
+        </pc:sldMkLst>
+        <pc:spChg chg="mod">
+          <ac:chgData name="Dilan De Silva" userId="579b606d6e18a4ed" providerId="LiveId" clId="{B4EA8C78-5629-4CB8-9794-5E1861B660A8}" dt="2025-06-04T11:47:00.578" v="316" actId="120"/>
+          <ac:spMkLst>
+            <pc:docMk/>
+            <pc:sldMk cId="2965452809" sldId="261"/>
+            <ac:spMk id="2" creationId="{C5482A9D-F23B-6B0C-5B36-B51009F97FF3}"/>
+          </ac:spMkLst>
+        </pc:spChg>
+        <pc:spChg chg="del">
+          <ac:chgData name="Dilan De Silva" userId="579b606d6e18a4ed" providerId="LiveId" clId="{B4EA8C78-5629-4CB8-9794-5E1861B660A8}" dt="2025-06-04T11:46:47.040" v="310"/>
+          <ac:spMkLst>
+            <pc:docMk/>
+            <pc:sldMk cId="2965452809" sldId="261"/>
+            <ac:spMk id="6" creationId="{6874E7C7-F85F-7C86-DCEE-7AD33E86EFA9}"/>
+          </ac:spMkLst>
+        </pc:spChg>
+        <pc:spChg chg="add">
+          <ac:chgData name="Dilan De Silva" userId="579b606d6e18a4ed" providerId="LiveId" clId="{B4EA8C78-5629-4CB8-9794-5E1861B660A8}" dt="2025-06-04T11:46:56.629" v="313" actId="26606"/>
+          <ac:spMkLst>
+            <pc:docMk/>
+            <pc:sldMk cId="2965452809" sldId="261"/>
+            <ac:spMk id="9" creationId="{A4AC5506-6312-4701-8D3C-40187889A947}"/>
+          </ac:spMkLst>
+        </pc:spChg>
+        <pc:picChg chg="del mod">
+          <ac:chgData name="Dilan De Silva" userId="579b606d6e18a4ed" providerId="LiveId" clId="{B4EA8C78-5629-4CB8-9794-5E1861B660A8}" dt="2025-06-04T11:47:03.115" v="317" actId="478"/>
+          <ac:picMkLst>
+            <pc:docMk/>
+            <pc:sldMk cId="2965452809" sldId="261"/>
+            <ac:picMk id="4" creationId="{4AE3B28B-4CDB-869A-F5BE-7F62A2D925B6}"/>
+          </ac:picMkLst>
+        </pc:picChg>
+        <pc:picChg chg="add mod">
+          <ac:chgData name="Dilan De Silva" userId="579b606d6e18a4ed" providerId="LiveId" clId="{B4EA8C78-5629-4CB8-9794-5E1861B660A8}" dt="2025-06-04T11:51:31.738" v="329" actId="14100"/>
+          <ac:picMkLst>
+            <pc:docMk/>
+            <pc:sldMk cId="2965452809" sldId="261"/>
+            <ac:picMk id="5" creationId="{7E98FE36-BF12-46D4-2CD2-33F841A9E8A2}"/>
+          </ac:picMkLst>
+        </pc:picChg>
+        <pc:picChg chg="del">
+          <ac:chgData name="Dilan De Silva" userId="579b606d6e18a4ed" providerId="LiveId" clId="{B4EA8C78-5629-4CB8-9794-5E1861B660A8}" dt="2025-06-04T11:46:54.410" v="312" actId="478"/>
+          <ac:picMkLst>
+            <pc:docMk/>
+            <pc:sldMk cId="2965452809" sldId="261"/>
+            <ac:picMk id="8" creationId="{D51CD665-AFE1-AE67-E7FC-8F4B4CBC5FC7}"/>
+          </ac:picMkLst>
+        </pc:picChg>
+        <pc:picChg chg="add mod">
+          <ac:chgData name="Dilan De Silva" userId="579b606d6e18a4ed" providerId="LiveId" clId="{B4EA8C78-5629-4CB8-9794-5E1861B660A8}" dt="2025-06-04T11:51:56.207" v="331" actId="1076"/>
+          <ac:picMkLst>
+            <pc:docMk/>
+            <pc:sldMk cId="2965452809" sldId="261"/>
+            <ac:picMk id="10" creationId="{B526E69E-5BDE-F210-2D61-FF8FD171BCF2}"/>
+          </ac:picMkLst>
+        </pc:picChg>
+        <pc:picChg chg="add mod modCrop">
+          <ac:chgData name="Dilan De Silva" userId="579b606d6e18a4ed" providerId="LiveId" clId="{B4EA8C78-5629-4CB8-9794-5E1861B660A8}" dt="2025-06-04T11:52:54.903" v="340" actId="14100"/>
+          <ac:picMkLst>
+            <pc:docMk/>
+            <pc:sldMk cId="2965452809" sldId="261"/>
+            <ac:picMk id="12" creationId="{342A7AB9-6630-4F9C-7639-DBB9443F9BE2}"/>
+          </ac:picMkLst>
+        </pc:picChg>
+        <pc:picChg chg="del">
+          <ac:chgData name="Dilan De Silva" userId="579b606d6e18a4ed" providerId="LiveId" clId="{B4EA8C78-5629-4CB8-9794-5E1861B660A8}" dt="2025-06-04T11:46:50.116" v="311" actId="478"/>
+          <ac:picMkLst>
+            <pc:docMk/>
+            <pc:sldMk cId="2965452809" sldId="261"/>
+            <ac:picMk id="13" creationId="{2F957EFD-A50B-A610-FCE0-2C5E49C173CF}"/>
+          </ac:picMkLst>
+        </pc:picChg>
+      </pc:sldChg>
+    </pc:docChg>
+  </pc:docChgLst>
+</pc:chgInfo>
 </file>
 
 <file path=ppt/slideLayouts/slideLayout1.xml><?xml version="1.0" encoding="utf-8"?>
@@ -269,7 +707,7 @@
           <a:p>
             <a:fld id="{2D73D9AC-D42E-4620-8482-0397FE94AE8B}" type="datetimeFigureOut">
               <a:rPr lang="en-AU" smtClean="0"/>
-              <a:t>18/05/2025</a:t>
+              <a:t>4/06/2025</a:t>
             </a:fld>
             <a:endParaRPr lang="en-AU"/>
           </a:p>
@@ -469,7 +907,7 @@
           <a:p>
             <a:fld id="{2D73D9AC-D42E-4620-8482-0397FE94AE8B}" type="datetimeFigureOut">
               <a:rPr lang="en-AU" smtClean="0"/>
-              <a:t>18/05/2025</a:t>
+              <a:t>4/06/2025</a:t>
             </a:fld>
             <a:endParaRPr lang="en-AU"/>
           </a:p>
@@ -679,7 +1117,7 @@
           <a:p>
             <a:fld id="{2D73D9AC-D42E-4620-8482-0397FE94AE8B}" type="datetimeFigureOut">
               <a:rPr lang="en-AU" smtClean="0"/>
-              <a:t>18/05/2025</a:t>
+              <a:t>4/06/2025</a:t>
             </a:fld>
             <a:endParaRPr lang="en-AU"/>
           </a:p>
@@ -879,7 +1317,7 @@
           <a:p>
             <a:fld id="{2D73D9AC-D42E-4620-8482-0397FE94AE8B}" type="datetimeFigureOut">
               <a:rPr lang="en-AU" smtClean="0"/>
-              <a:t>18/05/2025</a:t>
+              <a:t>4/06/2025</a:t>
             </a:fld>
             <a:endParaRPr lang="en-AU"/>
           </a:p>
@@ -1155,7 +1593,7 @@
           <a:p>
             <a:fld id="{2D73D9AC-D42E-4620-8482-0397FE94AE8B}" type="datetimeFigureOut">
               <a:rPr lang="en-AU" smtClean="0"/>
-              <a:t>18/05/2025</a:t>
+              <a:t>4/06/2025</a:t>
             </a:fld>
             <a:endParaRPr lang="en-AU"/>
           </a:p>
@@ -1423,7 +1861,7 @@
           <a:p>
             <a:fld id="{2D73D9AC-D42E-4620-8482-0397FE94AE8B}" type="datetimeFigureOut">
               <a:rPr lang="en-AU" smtClean="0"/>
-              <a:t>18/05/2025</a:t>
+              <a:t>4/06/2025</a:t>
             </a:fld>
             <a:endParaRPr lang="en-AU"/>
           </a:p>
@@ -1838,7 +2276,7 @@
           <a:p>
             <a:fld id="{2D73D9AC-D42E-4620-8482-0397FE94AE8B}" type="datetimeFigureOut">
               <a:rPr lang="en-AU" smtClean="0"/>
-              <a:t>18/05/2025</a:t>
+              <a:t>4/06/2025</a:t>
             </a:fld>
             <a:endParaRPr lang="en-AU"/>
           </a:p>
@@ -1980,7 +2418,7 @@
           <a:p>
             <a:fld id="{2D73D9AC-D42E-4620-8482-0397FE94AE8B}" type="datetimeFigureOut">
               <a:rPr lang="en-AU" smtClean="0"/>
-              <a:t>18/05/2025</a:t>
+              <a:t>4/06/2025</a:t>
             </a:fld>
             <a:endParaRPr lang="en-AU"/>
           </a:p>
@@ -2093,7 +2531,7 @@
           <a:p>
             <a:fld id="{2D73D9AC-D42E-4620-8482-0397FE94AE8B}" type="datetimeFigureOut">
               <a:rPr lang="en-AU" smtClean="0"/>
-              <a:t>18/05/2025</a:t>
+              <a:t>4/06/2025</a:t>
             </a:fld>
             <a:endParaRPr lang="en-AU"/>
           </a:p>
@@ -2406,7 +2844,7 @@
           <a:p>
             <a:fld id="{2D73D9AC-D42E-4620-8482-0397FE94AE8B}" type="datetimeFigureOut">
               <a:rPr lang="en-AU" smtClean="0"/>
-              <a:t>18/05/2025</a:t>
+              <a:t>4/06/2025</a:t>
             </a:fld>
             <a:endParaRPr lang="en-AU"/>
           </a:p>
@@ -2695,7 +3133,7 @@
           <a:p>
             <a:fld id="{2D73D9AC-D42E-4620-8482-0397FE94AE8B}" type="datetimeFigureOut">
               <a:rPr lang="en-AU" smtClean="0"/>
-              <a:t>18/05/2025</a:t>
+              <a:t>4/06/2025</a:t>
             </a:fld>
             <a:endParaRPr lang="en-AU"/>
           </a:p>
@@ -2938,7 +3376,7 @@
           <a:p>
             <a:fld id="{2D73D9AC-D42E-4620-8482-0397FE94AE8B}" type="datetimeFigureOut">
               <a:rPr lang="en-AU" smtClean="0"/>
-              <a:t>18/05/2025</a:t>
+              <a:t>4/06/2025</a:t>
             </a:fld>
             <a:endParaRPr lang="en-AU"/>
           </a:p>
@@ -3488,8 +3926,12 @@
           <a:lstStyle/>
           <a:p>
             <a:r>
-              <a:rPr lang="en-AU" dirty="0"/>
-              <a:t>Pricing Model (*)</a:t>
+              <a:rPr lang="en-AU" dirty="0">
+                <a:solidFill>
+                  <a:schemeClr val="accent6"/>
+                </a:solidFill>
+              </a:rPr>
+              <a:t>Pricing Model</a:t>
             </a:r>
           </a:p>
           <a:p>
@@ -3501,8 +3943,13 @@
           <a:p>
             <a:r>
               <a:rPr lang="en-AU" dirty="0"/>
-              <a:t>Batting &amp; Bowling Points Modelling</a:t>
-            </a:r>
+              <a:t>Batting &amp; Bowling </a:t>
+            </a:r>
+            <a:r>
+              <a:rPr lang="en-AU"/>
+              <a:t>Points Modelling (*)</a:t>
+            </a:r>
+            <a:endParaRPr lang="en-AU" dirty="0"/>
           </a:p>
           <a:p>
             <a:r>
@@ -3519,6 +3966,860 @@
     <p:extLst>
       <p:ext uri="{BB962C8B-B14F-4D97-AF65-F5344CB8AC3E}">
         <p14:creationId xmlns:p14="http://schemas.microsoft.com/office/powerpoint/2010/main" val="1969437762"/>
+      </p:ext>
+    </p:extLst>
+  </p:cSld>
+  <p:clrMapOvr>
+    <a:masterClrMapping/>
+  </p:clrMapOvr>
+</p:sld>
+</file>
+
+<file path=ppt/slides/slide3.xml><?xml version="1.0" encoding="utf-8"?>
+<p:sld xmlns:a="http://schemas.openxmlformats.org/drawingml/2006/main" xmlns:r="http://schemas.openxmlformats.org/officeDocument/2006/relationships" xmlns:p="http://schemas.openxmlformats.org/presentationml/2006/main">
+  <p:cSld>
+    <p:spTree>
+      <p:nvGrpSpPr>
+        <p:cNvPr id="1" name=""/>
+        <p:cNvGrpSpPr/>
+        <p:nvPr/>
+      </p:nvGrpSpPr>
+      <p:grpSpPr>
+        <a:xfrm>
+          <a:off x="0" y="0"/>
+          <a:ext cx="0" cy="0"/>
+          <a:chOff x="0" y="0"/>
+          <a:chExt cx="0" cy="0"/>
+        </a:xfrm>
+      </p:grpSpPr>
+      <p:sp>
+        <p:nvSpPr>
+          <p:cNvPr id="2" name="Title 1">
+            <a:extLst>
+              <a:ext uri="{FF2B5EF4-FFF2-40B4-BE49-F238E27FC236}">
+                <a16:creationId xmlns:a16="http://schemas.microsoft.com/office/drawing/2014/main" id="{DCD29F56-BA59-FAF6-79C8-A248333FA0BB}"/>
+              </a:ext>
+            </a:extLst>
+          </p:cNvPr>
+          <p:cNvSpPr>
+            <a:spLocks noGrp="1"/>
+          </p:cNvSpPr>
+          <p:nvPr>
+            <p:ph type="title"/>
+          </p:nvPr>
+        </p:nvSpPr>
+        <p:spPr/>
+        <p:txBody>
+          <a:bodyPr/>
+          <a:lstStyle/>
+          <a:p>
+            <a:r>
+              <a:rPr lang="en-AU"/>
+              <a:t>Pricing Model</a:t>
+            </a:r>
+            <a:endParaRPr lang="en-AU" dirty="0"/>
+          </a:p>
+        </p:txBody>
+      </p:sp>
+      <p:sp>
+        <p:nvSpPr>
+          <p:cNvPr id="3" name="Content Placeholder 2">
+            <a:extLst>
+              <a:ext uri="{FF2B5EF4-FFF2-40B4-BE49-F238E27FC236}">
+                <a16:creationId xmlns:a16="http://schemas.microsoft.com/office/drawing/2014/main" id="{6AA0120E-7982-2BE3-3FA1-358B5018E8F7}"/>
+              </a:ext>
+            </a:extLst>
+          </p:cNvPr>
+          <p:cNvSpPr>
+            <a:spLocks noGrp="1"/>
+          </p:cNvSpPr>
+          <p:nvPr>
+            <p:ph idx="1"/>
+          </p:nvPr>
+        </p:nvSpPr>
+        <p:spPr/>
+        <p:txBody>
+          <a:bodyPr/>
+          <a:lstStyle/>
+          <a:p>
+            <a:r>
+              <a:rPr lang="en-AU"/>
+              <a:t>Three individual models</a:t>
+            </a:r>
+          </a:p>
+          <a:p>
+            <a:pPr marL="914400" lvl="1" indent="-457200">
+              <a:buFont typeface="+mj-lt"/>
+              <a:buAutoNum type="arabicPeriod"/>
+            </a:pPr>
+            <a:r>
+              <a:rPr lang="en-AU"/>
+              <a:t>After 1 Game Expected Price Change Model</a:t>
+            </a:r>
+          </a:p>
+          <a:p>
+            <a:pPr marL="914400" lvl="1" indent="-457200">
+              <a:buFont typeface="+mj-lt"/>
+              <a:buAutoNum type="arabicPeriod"/>
+            </a:pPr>
+            <a:r>
+              <a:rPr lang="en-AU"/>
+              <a:t>After 2 Games Expected Price Change Model</a:t>
+            </a:r>
+          </a:p>
+          <a:p>
+            <a:pPr marL="914400" lvl="1" indent="-457200">
+              <a:buFont typeface="+mj-lt"/>
+              <a:buAutoNum type="arabicPeriod"/>
+            </a:pPr>
+            <a:r>
+              <a:rPr lang="en-AU"/>
+              <a:t>After 3 or more Games Expected Price Change Model</a:t>
+            </a:r>
+            <a:endParaRPr lang="en-AU" dirty="0"/>
+          </a:p>
+        </p:txBody>
+      </p:sp>
+    </p:spTree>
+    <p:extLst>
+      <p:ext uri="{BB962C8B-B14F-4D97-AF65-F5344CB8AC3E}">
+        <p14:creationId xmlns:p14="http://schemas.microsoft.com/office/powerpoint/2010/main" val="1471337115"/>
+      </p:ext>
+    </p:extLst>
+  </p:cSld>
+  <p:clrMapOvr>
+    <a:masterClrMapping/>
+  </p:clrMapOvr>
+</p:sld>
+</file>
+
+<file path=ppt/slides/slide4.xml><?xml version="1.0" encoding="utf-8"?>
+<p:sld xmlns:a="http://schemas.openxmlformats.org/drawingml/2006/main" xmlns:r="http://schemas.openxmlformats.org/officeDocument/2006/relationships" xmlns:p="http://schemas.openxmlformats.org/presentationml/2006/main">
+  <p:cSld>
+    <p:bg>
+      <p:bgPr>
+        <a:solidFill>
+          <a:schemeClr val="bg1"/>
+        </a:solidFill>
+        <a:effectLst/>
+      </p:bgPr>
+    </p:bg>
+    <p:spTree>
+      <p:nvGrpSpPr>
+        <p:cNvPr id="1" name="">
+          <a:extLst>
+            <a:ext uri="{FF2B5EF4-FFF2-40B4-BE49-F238E27FC236}">
+              <a16:creationId xmlns:a16="http://schemas.microsoft.com/office/drawing/2014/main" id="{7AA1C0DD-1F29-6BF9-21F2-BC1473961741}"/>
+            </a:ext>
+          </a:extLst>
+        </p:cNvPr>
+        <p:cNvGrpSpPr/>
+        <p:nvPr/>
+      </p:nvGrpSpPr>
+      <p:grpSpPr>
+        <a:xfrm>
+          <a:off x="0" y="0"/>
+          <a:ext cx="0" cy="0"/>
+          <a:chOff x="0" y="0"/>
+          <a:chExt cx="0" cy="0"/>
+        </a:xfrm>
+      </p:grpSpPr>
+      <p:sp>
+        <p:nvSpPr>
+          <p:cNvPr id="12" name="Rectangle 11">
+            <a:extLst>
+              <a:ext uri="{FF2B5EF4-FFF2-40B4-BE49-F238E27FC236}">
+                <a16:creationId xmlns:a16="http://schemas.microsoft.com/office/drawing/2014/main" id="{A4AC5506-6312-4701-8D3C-40187889A947}"/>
+              </a:ext>
+              <a:ext uri="{C183D7F6-B498-43B3-948B-1728B52AA6E4}">
+                <adec:decorative xmlns:adec="http://schemas.microsoft.com/office/drawing/2017/decorative" val="1"/>
+              </a:ext>
+            </a:extLst>
+          </p:cNvPr>
+          <p:cNvSpPr>
+            <a:spLocks noGrp="1" noRot="1" noChangeAspect="1" noMove="1" noResize="1" noEditPoints="1" noAdjustHandles="1" noChangeArrowheads="1" noChangeShapeType="1" noTextEdit="1"/>
+          </p:cNvSpPr>
+          <p:nvPr>
+            <p:extLst>
+              <p:ext uri="{386F3935-93C4-4BCD-93E2-E3B085C9AB24}">
+                <p16:designElem xmlns:p16="http://schemas.microsoft.com/office/powerpoint/2015/main" val="1"/>
+              </p:ext>
+            </p:extLst>
+          </p:nvPr>
+        </p:nvSpPr>
+        <p:spPr>
+          <a:xfrm>
+            <a:off x="0" y="651752"/>
+            <a:ext cx="12192000" cy="736551"/>
+          </a:xfrm>
+          <a:prstGeom prst="rect">
+            <a:avLst/>
+          </a:prstGeom>
+          <a:solidFill>
+            <a:schemeClr val="tx1"/>
+          </a:solidFill>
+          <a:ln>
+            <a:noFill/>
+          </a:ln>
+        </p:spPr>
+        <p:style>
+          <a:lnRef idx="2">
+            <a:schemeClr val="accent1">
+              <a:shade val="50000"/>
+            </a:schemeClr>
+          </a:lnRef>
+          <a:fillRef idx="1">
+            <a:schemeClr val="accent1"/>
+          </a:fillRef>
+          <a:effectRef idx="0">
+            <a:schemeClr val="accent1"/>
+          </a:effectRef>
+          <a:fontRef idx="minor">
+            <a:schemeClr val="lt1"/>
+          </a:fontRef>
+        </p:style>
+        <p:txBody>
+          <a:bodyPr rtlCol="0" anchor="ctr"/>
+          <a:lstStyle/>
+          <a:p>
+            <a:pPr algn="ctr"/>
+            <a:endParaRPr lang="en-US"/>
+          </a:p>
+        </p:txBody>
+      </p:sp>
+      <p:sp>
+        <p:nvSpPr>
+          <p:cNvPr id="2" name="Title 1">
+            <a:extLst>
+              <a:ext uri="{FF2B5EF4-FFF2-40B4-BE49-F238E27FC236}">
+                <a16:creationId xmlns:a16="http://schemas.microsoft.com/office/drawing/2014/main" id="{634F4B6D-B859-81E2-585F-115E16516769}"/>
+              </a:ext>
+            </a:extLst>
+          </p:cNvPr>
+          <p:cNvSpPr>
+            <a:spLocks noGrp="1"/>
+          </p:cNvSpPr>
+          <p:nvPr>
+            <p:ph type="title"/>
+          </p:nvPr>
+        </p:nvSpPr>
+        <p:spPr>
+          <a:xfrm>
+            <a:off x="556532" y="643467"/>
+            <a:ext cx="11210925" cy="744836"/>
+          </a:xfrm>
+        </p:spPr>
+        <p:txBody>
+          <a:bodyPr vert="horz" lIns="91440" tIns="45720" rIns="91440" bIns="45720" rtlCol="0" anchor="ctr">
+            <a:normAutofit/>
+          </a:bodyPr>
+          <a:lstStyle/>
+          <a:p>
+            <a:r>
+              <a:rPr lang="en-US" sz="3200" kern="1200" dirty="0">
+                <a:solidFill>
+                  <a:schemeClr val="bg1"/>
+                </a:solidFill>
+                <a:latin typeface="+mj-lt"/>
+                <a:ea typeface="+mj-ea"/>
+                <a:cs typeface="+mj-cs"/>
+              </a:rPr>
+              <a:t>Pricing Model 1</a:t>
+            </a:r>
+          </a:p>
+        </p:txBody>
+      </p:sp>
+      <p:pic>
+        <p:nvPicPr>
+          <p:cNvPr id="7" name="Picture 6">
+            <a:extLst>
+              <a:ext uri="{FF2B5EF4-FFF2-40B4-BE49-F238E27FC236}">
+                <a16:creationId xmlns:a16="http://schemas.microsoft.com/office/drawing/2014/main" id="{A158E25A-46C3-E912-DFCF-F3A95F3F1F98}"/>
+              </a:ext>
+            </a:extLst>
+          </p:cNvPr>
+          <p:cNvPicPr>
+            <a:picLocks noChangeAspect="1"/>
+          </p:cNvPicPr>
+          <p:nvPr/>
+        </p:nvPicPr>
+        <p:blipFill>
+          <a:blip r:embed="rId2"/>
+          <a:stretch>
+            <a:fillRect/>
+          </a:stretch>
+        </p:blipFill>
+        <p:spPr>
+          <a:xfrm>
+            <a:off x="219631" y="1606373"/>
+            <a:ext cx="5020722" cy="3075193"/>
+          </a:xfrm>
+          <a:prstGeom prst="rect">
+            <a:avLst/>
+          </a:prstGeom>
+        </p:spPr>
+      </p:pic>
+      <p:pic>
+        <p:nvPicPr>
+          <p:cNvPr id="9" name="Picture 8">
+            <a:extLst>
+              <a:ext uri="{FF2B5EF4-FFF2-40B4-BE49-F238E27FC236}">
+                <a16:creationId xmlns:a16="http://schemas.microsoft.com/office/drawing/2014/main" id="{18DAAFF2-7EB9-DAD9-DE9F-137C76ED5049}"/>
+              </a:ext>
+            </a:extLst>
+          </p:cNvPr>
+          <p:cNvPicPr>
+            <a:picLocks noChangeAspect="1"/>
+          </p:cNvPicPr>
+          <p:nvPr/>
+        </p:nvPicPr>
+        <p:blipFill>
+          <a:blip r:embed="rId3"/>
+          <a:srcRect t="759"/>
+          <a:stretch>
+            <a:fillRect/>
+          </a:stretch>
+        </p:blipFill>
+        <p:spPr>
+          <a:xfrm>
+            <a:off x="6951649" y="651752"/>
+            <a:ext cx="3805561" cy="6203305"/>
+          </a:xfrm>
+          <a:prstGeom prst="rect">
+            <a:avLst/>
+          </a:prstGeom>
+        </p:spPr>
+      </p:pic>
+      <p:pic>
+        <p:nvPicPr>
+          <p:cNvPr id="11" name="Picture 10">
+            <a:extLst>
+              <a:ext uri="{FF2B5EF4-FFF2-40B4-BE49-F238E27FC236}">
+                <a16:creationId xmlns:a16="http://schemas.microsoft.com/office/drawing/2014/main" id="{13BF7B19-1051-10FA-A909-0441C239D5AE}"/>
+              </a:ext>
+            </a:extLst>
+          </p:cNvPr>
+          <p:cNvPicPr>
+            <a:picLocks noChangeAspect="1"/>
+          </p:cNvPicPr>
+          <p:nvPr/>
+        </p:nvPicPr>
+        <p:blipFill>
+          <a:blip r:embed="rId4"/>
+          <a:stretch>
+            <a:fillRect/>
+          </a:stretch>
+        </p:blipFill>
+        <p:spPr>
+          <a:xfrm>
+            <a:off x="1208372" y="4899636"/>
+            <a:ext cx="2695951" cy="762106"/>
+          </a:xfrm>
+          <a:prstGeom prst="rect">
+            <a:avLst/>
+          </a:prstGeom>
+        </p:spPr>
+      </p:pic>
+    </p:spTree>
+    <p:extLst>
+      <p:ext uri="{BB962C8B-B14F-4D97-AF65-F5344CB8AC3E}">
+        <p14:creationId xmlns:p14="http://schemas.microsoft.com/office/powerpoint/2010/main" val="3689564591"/>
+      </p:ext>
+    </p:extLst>
+  </p:cSld>
+  <p:clrMapOvr>
+    <a:masterClrMapping/>
+  </p:clrMapOvr>
+</p:sld>
+</file>
+
+<file path=ppt/slides/slide5.xml><?xml version="1.0" encoding="utf-8"?>
+<p:sld xmlns:a="http://schemas.openxmlformats.org/drawingml/2006/main" xmlns:r="http://schemas.openxmlformats.org/officeDocument/2006/relationships" xmlns:p="http://schemas.openxmlformats.org/presentationml/2006/main">
+  <p:cSld>
+    <p:bg>
+      <p:bgPr>
+        <a:solidFill>
+          <a:schemeClr val="bg1"/>
+        </a:solidFill>
+        <a:effectLst/>
+      </p:bgPr>
+    </p:bg>
+    <p:spTree>
+      <p:nvGrpSpPr>
+        <p:cNvPr id="1" name="">
+          <a:extLst>
+            <a:ext uri="{FF2B5EF4-FFF2-40B4-BE49-F238E27FC236}">
+              <a16:creationId xmlns:a16="http://schemas.microsoft.com/office/drawing/2014/main" id="{CFB79B03-F755-0793-DE77-BEAB3378B748}"/>
+            </a:ext>
+          </a:extLst>
+        </p:cNvPr>
+        <p:cNvGrpSpPr/>
+        <p:nvPr/>
+      </p:nvGrpSpPr>
+      <p:grpSpPr>
+        <a:xfrm>
+          <a:off x="0" y="0"/>
+          <a:ext cx="0" cy="0"/>
+          <a:chOff x="0" y="0"/>
+          <a:chExt cx="0" cy="0"/>
+        </a:xfrm>
+      </p:grpSpPr>
+      <p:sp>
+        <p:nvSpPr>
+          <p:cNvPr id="6" name="Rectangle 5">
+            <a:extLst>
+              <a:ext uri="{FF2B5EF4-FFF2-40B4-BE49-F238E27FC236}">
+                <a16:creationId xmlns:a16="http://schemas.microsoft.com/office/drawing/2014/main" id="{A4AC5506-6312-4701-8D3C-40187889A947}"/>
+              </a:ext>
+              <a:ext uri="{C183D7F6-B498-43B3-948B-1728B52AA6E4}">
+                <adec:decorative xmlns:adec="http://schemas.microsoft.com/office/drawing/2017/decorative" val="1"/>
+              </a:ext>
+            </a:extLst>
+          </p:cNvPr>
+          <p:cNvSpPr>
+            <a:spLocks noGrp="1" noRot="1" noChangeAspect="1" noMove="1" noResize="1" noEditPoints="1" noAdjustHandles="1" noChangeArrowheads="1" noChangeShapeType="1" noTextEdit="1"/>
+          </p:cNvSpPr>
+          <p:nvPr>
+            <p:extLst>
+              <p:ext uri="{386F3935-93C4-4BCD-93E2-E3B085C9AB24}">
+                <p16:designElem xmlns:p16="http://schemas.microsoft.com/office/powerpoint/2015/main" val="1"/>
+              </p:ext>
+            </p:extLst>
+          </p:nvPr>
+        </p:nvSpPr>
+        <p:spPr>
+          <a:xfrm>
+            <a:off x="0" y="651752"/>
+            <a:ext cx="12192000" cy="736551"/>
+          </a:xfrm>
+          <a:prstGeom prst="rect">
+            <a:avLst/>
+          </a:prstGeom>
+          <a:solidFill>
+            <a:schemeClr val="tx1"/>
+          </a:solidFill>
+          <a:ln>
+            <a:noFill/>
+          </a:ln>
+        </p:spPr>
+        <p:style>
+          <a:lnRef idx="2">
+            <a:schemeClr val="accent1">
+              <a:shade val="50000"/>
+            </a:schemeClr>
+          </a:lnRef>
+          <a:fillRef idx="1">
+            <a:schemeClr val="accent1"/>
+          </a:fillRef>
+          <a:effectRef idx="0">
+            <a:schemeClr val="accent1"/>
+          </a:effectRef>
+          <a:fontRef idx="minor">
+            <a:schemeClr val="lt1"/>
+          </a:fontRef>
+        </p:style>
+        <p:txBody>
+          <a:bodyPr rtlCol="0" anchor="ctr"/>
+          <a:lstStyle/>
+          <a:p>
+            <a:pPr algn="ctr"/>
+            <a:endParaRPr lang="en-US"/>
+          </a:p>
+        </p:txBody>
+      </p:sp>
+      <p:sp>
+        <p:nvSpPr>
+          <p:cNvPr id="2" name="Title 1">
+            <a:extLst>
+              <a:ext uri="{FF2B5EF4-FFF2-40B4-BE49-F238E27FC236}">
+                <a16:creationId xmlns:a16="http://schemas.microsoft.com/office/drawing/2014/main" id="{BEED9832-E790-FEA8-6024-89D616225AB2}"/>
+              </a:ext>
+            </a:extLst>
+          </p:cNvPr>
+          <p:cNvSpPr>
+            <a:spLocks noGrp="1"/>
+          </p:cNvSpPr>
+          <p:nvPr>
+            <p:ph type="title"/>
+          </p:nvPr>
+        </p:nvSpPr>
+        <p:spPr>
+          <a:xfrm>
+            <a:off x="556532" y="643467"/>
+            <a:ext cx="11210925" cy="744836"/>
+          </a:xfrm>
+        </p:spPr>
+        <p:txBody>
+          <a:bodyPr vert="horz" lIns="91440" tIns="45720" rIns="91440" bIns="45720" rtlCol="0" anchor="ctr">
+            <a:normAutofit/>
+          </a:bodyPr>
+          <a:lstStyle/>
+          <a:p>
+            <a:r>
+              <a:rPr lang="en-US" sz="3200" kern="1200" dirty="0">
+                <a:solidFill>
+                  <a:schemeClr val="bg1"/>
+                </a:solidFill>
+                <a:latin typeface="+mj-lt"/>
+                <a:ea typeface="+mj-ea"/>
+                <a:cs typeface="+mj-cs"/>
+              </a:rPr>
+              <a:t>Pricing Model 2</a:t>
+            </a:r>
+          </a:p>
+        </p:txBody>
+      </p:sp>
+      <p:pic>
+        <p:nvPicPr>
+          <p:cNvPr id="4" name="Picture 3">
+            <a:extLst>
+              <a:ext uri="{FF2B5EF4-FFF2-40B4-BE49-F238E27FC236}">
+                <a16:creationId xmlns:a16="http://schemas.microsoft.com/office/drawing/2014/main" id="{46ADA508-1956-0619-0812-604D6A80AA3D}"/>
+              </a:ext>
+            </a:extLst>
+          </p:cNvPr>
+          <p:cNvPicPr>
+            <a:picLocks noChangeAspect="1"/>
+          </p:cNvPicPr>
+          <p:nvPr/>
+        </p:nvPicPr>
+        <p:blipFill>
+          <a:blip r:embed="rId2"/>
+          <a:stretch>
+            <a:fillRect/>
+          </a:stretch>
+        </p:blipFill>
+        <p:spPr>
+          <a:xfrm>
+            <a:off x="556532" y="1615755"/>
+            <a:ext cx="4721551" cy="2844734"/>
+          </a:xfrm>
+          <a:prstGeom prst="rect">
+            <a:avLst/>
+          </a:prstGeom>
+        </p:spPr>
+      </p:pic>
+      <p:pic>
+        <p:nvPicPr>
+          <p:cNvPr id="8" name="Picture 7">
+            <a:extLst>
+              <a:ext uri="{FF2B5EF4-FFF2-40B4-BE49-F238E27FC236}">
+                <a16:creationId xmlns:a16="http://schemas.microsoft.com/office/drawing/2014/main" id="{21BBA2F4-FEC3-3E5E-40AF-06BB3E73DA43}"/>
+              </a:ext>
+            </a:extLst>
+          </p:cNvPr>
+          <p:cNvPicPr>
+            <a:picLocks noChangeAspect="1"/>
+          </p:cNvPicPr>
+          <p:nvPr/>
+        </p:nvPicPr>
+        <p:blipFill>
+          <a:blip r:embed="rId3"/>
+          <a:stretch>
+            <a:fillRect/>
+          </a:stretch>
+        </p:blipFill>
+        <p:spPr>
+          <a:xfrm>
+            <a:off x="1688410" y="4687941"/>
+            <a:ext cx="2457793" cy="790685"/>
+          </a:xfrm>
+          <a:prstGeom prst="rect">
+            <a:avLst/>
+          </a:prstGeom>
+        </p:spPr>
+      </p:pic>
+      <p:pic>
+        <p:nvPicPr>
+          <p:cNvPr id="13" name="Picture 12">
+            <a:extLst>
+              <a:ext uri="{FF2B5EF4-FFF2-40B4-BE49-F238E27FC236}">
+                <a16:creationId xmlns:a16="http://schemas.microsoft.com/office/drawing/2014/main" id="{F2F1FC21-77D3-F860-F9D5-C4F4D504C51A}"/>
+              </a:ext>
+            </a:extLst>
+          </p:cNvPr>
+          <p:cNvPicPr>
+            <a:picLocks noChangeAspect="1"/>
+          </p:cNvPicPr>
+          <p:nvPr/>
+        </p:nvPicPr>
+        <p:blipFill>
+          <a:blip r:embed="rId4"/>
+          <a:srcRect l="1143" t="542" b="814"/>
+          <a:stretch>
+            <a:fillRect/>
+          </a:stretch>
+        </p:blipFill>
+        <p:spPr>
+          <a:xfrm>
+            <a:off x="7025268" y="651752"/>
+            <a:ext cx="3656884" cy="6206248"/>
+          </a:xfrm>
+          <a:prstGeom prst="rect">
+            <a:avLst/>
+          </a:prstGeom>
+        </p:spPr>
+      </p:pic>
+    </p:spTree>
+    <p:extLst>
+      <p:ext uri="{BB962C8B-B14F-4D97-AF65-F5344CB8AC3E}">
+        <p14:creationId xmlns:p14="http://schemas.microsoft.com/office/powerpoint/2010/main" val="4008747595"/>
+      </p:ext>
+    </p:extLst>
+  </p:cSld>
+  <p:clrMapOvr>
+    <a:masterClrMapping/>
+  </p:clrMapOvr>
+</p:sld>
+</file>
+
+<file path=ppt/slides/slide6.xml><?xml version="1.0" encoding="utf-8"?>
+<p:sld xmlns:a="http://schemas.openxmlformats.org/drawingml/2006/main" xmlns:r="http://schemas.openxmlformats.org/officeDocument/2006/relationships" xmlns:p="http://schemas.openxmlformats.org/presentationml/2006/main">
+  <p:cSld>
+    <p:bg>
+      <p:bgPr>
+        <a:solidFill>
+          <a:schemeClr val="bg1"/>
+        </a:solidFill>
+        <a:effectLst/>
+      </p:bgPr>
+    </p:bg>
+    <p:spTree>
+      <p:nvGrpSpPr>
+        <p:cNvPr id="1" name="">
+          <a:extLst>
+            <a:ext uri="{FF2B5EF4-FFF2-40B4-BE49-F238E27FC236}">
+              <a16:creationId xmlns:a16="http://schemas.microsoft.com/office/drawing/2014/main" id="{D907282D-DF96-7A4D-CA21-90533A8AF7F5}"/>
+            </a:ext>
+          </a:extLst>
+        </p:cNvPr>
+        <p:cNvGrpSpPr/>
+        <p:nvPr/>
+      </p:nvGrpSpPr>
+      <p:grpSpPr>
+        <a:xfrm>
+          <a:off x="0" y="0"/>
+          <a:ext cx="0" cy="0"/>
+          <a:chOff x="0" y="0"/>
+          <a:chExt cx="0" cy="0"/>
+        </a:xfrm>
+      </p:grpSpPr>
+      <p:sp>
+        <p:nvSpPr>
+          <p:cNvPr id="9" name="Rectangle 8">
+            <a:extLst>
+              <a:ext uri="{FF2B5EF4-FFF2-40B4-BE49-F238E27FC236}">
+                <a16:creationId xmlns:a16="http://schemas.microsoft.com/office/drawing/2014/main" id="{A4AC5506-6312-4701-8D3C-40187889A947}"/>
+              </a:ext>
+              <a:ext uri="{C183D7F6-B498-43B3-948B-1728B52AA6E4}">
+                <adec:decorative xmlns:adec="http://schemas.microsoft.com/office/drawing/2017/decorative" val="1"/>
+              </a:ext>
+            </a:extLst>
+          </p:cNvPr>
+          <p:cNvSpPr>
+            <a:spLocks noGrp="1" noRot="1" noChangeAspect="1" noMove="1" noResize="1" noEditPoints="1" noAdjustHandles="1" noChangeArrowheads="1" noChangeShapeType="1" noTextEdit="1"/>
+          </p:cNvSpPr>
+          <p:nvPr>
+            <p:extLst>
+              <p:ext uri="{386F3935-93C4-4BCD-93E2-E3B085C9AB24}">
+                <p16:designElem xmlns:p16="http://schemas.microsoft.com/office/powerpoint/2015/main" val="1"/>
+              </p:ext>
+            </p:extLst>
+          </p:nvPr>
+        </p:nvSpPr>
+        <p:spPr>
+          <a:xfrm>
+            <a:off x="0" y="651752"/>
+            <a:ext cx="12192000" cy="736551"/>
+          </a:xfrm>
+          <a:prstGeom prst="rect">
+            <a:avLst/>
+          </a:prstGeom>
+          <a:solidFill>
+            <a:schemeClr val="tx1"/>
+          </a:solidFill>
+          <a:ln>
+            <a:noFill/>
+          </a:ln>
+        </p:spPr>
+        <p:style>
+          <a:lnRef idx="2">
+            <a:schemeClr val="accent1">
+              <a:shade val="50000"/>
+            </a:schemeClr>
+          </a:lnRef>
+          <a:fillRef idx="1">
+            <a:schemeClr val="accent1"/>
+          </a:fillRef>
+          <a:effectRef idx="0">
+            <a:schemeClr val="accent1"/>
+          </a:effectRef>
+          <a:fontRef idx="minor">
+            <a:schemeClr val="lt1"/>
+          </a:fontRef>
+        </p:style>
+        <p:txBody>
+          <a:bodyPr rtlCol="0" anchor="ctr"/>
+          <a:lstStyle/>
+          <a:p>
+            <a:pPr algn="ctr"/>
+            <a:endParaRPr lang="en-US"/>
+          </a:p>
+        </p:txBody>
+      </p:sp>
+      <p:sp>
+        <p:nvSpPr>
+          <p:cNvPr id="2" name="Title 1">
+            <a:extLst>
+              <a:ext uri="{FF2B5EF4-FFF2-40B4-BE49-F238E27FC236}">
+                <a16:creationId xmlns:a16="http://schemas.microsoft.com/office/drawing/2014/main" id="{C5482A9D-F23B-6B0C-5B36-B51009F97FF3}"/>
+              </a:ext>
+            </a:extLst>
+          </p:cNvPr>
+          <p:cNvSpPr>
+            <a:spLocks noGrp="1"/>
+          </p:cNvSpPr>
+          <p:nvPr>
+            <p:ph type="title"/>
+          </p:nvPr>
+        </p:nvSpPr>
+        <p:spPr>
+          <a:xfrm>
+            <a:off x="556532" y="643467"/>
+            <a:ext cx="11210925" cy="744836"/>
+          </a:xfrm>
+        </p:spPr>
+        <p:txBody>
+          <a:bodyPr vert="horz" lIns="91440" tIns="45720" rIns="91440" bIns="45720" rtlCol="0" anchor="ctr">
+            <a:normAutofit/>
+          </a:bodyPr>
+          <a:lstStyle/>
+          <a:p>
+            <a:r>
+              <a:rPr lang="en-US" sz="3200" kern="1200" dirty="0">
+                <a:solidFill>
+                  <a:schemeClr val="bg1"/>
+                </a:solidFill>
+                <a:latin typeface="+mj-lt"/>
+                <a:ea typeface="+mj-ea"/>
+                <a:cs typeface="+mj-cs"/>
+              </a:rPr>
+              <a:t>Pricing Model </a:t>
+            </a:r>
+            <a:r>
+              <a:rPr lang="en-US" sz="3200" dirty="0">
+                <a:solidFill>
+                  <a:schemeClr val="bg1"/>
+                </a:solidFill>
+              </a:rPr>
+              <a:t>3</a:t>
+            </a:r>
+            <a:endParaRPr lang="en-US" sz="3200" kern="1200" dirty="0">
+              <a:solidFill>
+                <a:schemeClr val="bg1"/>
+              </a:solidFill>
+              <a:latin typeface="+mj-lt"/>
+              <a:ea typeface="+mj-ea"/>
+              <a:cs typeface="+mj-cs"/>
+            </a:endParaRPr>
+          </a:p>
+        </p:txBody>
+      </p:sp>
+      <p:pic>
+        <p:nvPicPr>
+          <p:cNvPr id="5" name="Picture 4">
+            <a:extLst>
+              <a:ext uri="{FF2B5EF4-FFF2-40B4-BE49-F238E27FC236}">
+                <a16:creationId xmlns:a16="http://schemas.microsoft.com/office/drawing/2014/main" id="{7E98FE36-BF12-46D4-2CD2-33F841A9E8A2}"/>
+              </a:ext>
+            </a:extLst>
+          </p:cNvPr>
+          <p:cNvPicPr>
+            <a:picLocks noChangeAspect="1"/>
+          </p:cNvPicPr>
+          <p:nvPr/>
+        </p:nvPicPr>
+        <p:blipFill>
+          <a:blip r:embed="rId2"/>
+          <a:stretch>
+            <a:fillRect/>
+          </a:stretch>
+        </p:blipFill>
+        <p:spPr>
+          <a:xfrm>
+            <a:off x="275174" y="1582997"/>
+            <a:ext cx="5538328" cy="3376265"/>
+          </a:xfrm>
+          <a:prstGeom prst="rect">
+            <a:avLst/>
+          </a:prstGeom>
+        </p:spPr>
+      </p:pic>
+      <p:pic>
+        <p:nvPicPr>
+          <p:cNvPr id="10" name="Picture 9">
+            <a:extLst>
+              <a:ext uri="{FF2B5EF4-FFF2-40B4-BE49-F238E27FC236}">
+                <a16:creationId xmlns:a16="http://schemas.microsoft.com/office/drawing/2014/main" id="{B526E69E-5BDE-F210-2D61-FF8FD171BCF2}"/>
+              </a:ext>
+            </a:extLst>
+          </p:cNvPr>
+          <p:cNvPicPr>
+            <a:picLocks noChangeAspect="1"/>
+          </p:cNvPicPr>
+          <p:nvPr/>
+        </p:nvPicPr>
+        <p:blipFill>
+          <a:blip r:embed="rId3"/>
+          <a:stretch>
+            <a:fillRect/>
+          </a:stretch>
+        </p:blipFill>
+        <p:spPr>
+          <a:xfrm>
+            <a:off x="1521026" y="5338242"/>
+            <a:ext cx="2667372" cy="790685"/>
+          </a:xfrm>
+          <a:prstGeom prst="rect">
+            <a:avLst/>
+          </a:prstGeom>
+        </p:spPr>
+      </p:pic>
+      <p:pic>
+        <p:nvPicPr>
+          <p:cNvPr id="12" name="Picture 11">
+            <a:extLst>
+              <a:ext uri="{FF2B5EF4-FFF2-40B4-BE49-F238E27FC236}">
+                <a16:creationId xmlns:a16="http://schemas.microsoft.com/office/drawing/2014/main" id="{342A7AB9-6630-4F9C-7639-DBB9443F9BE2}"/>
+              </a:ext>
+            </a:extLst>
+          </p:cNvPr>
+          <p:cNvPicPr>
+            <a:picLocks noChangeAspect="1"/>
+          </p:cNvPicPr>
+          <p:nvPr/>
+        </p:nvPicPr>
+        <p:blipFill>
+          <a:blip r:embed="rId4"/>
+          <a:srcRect l="1348" t="968" r="1259" b="712"/>
+          <a:stretch>
+            <a:fillRect/>
+          </a:stretch>
+        </p:blipFill>
+        <p:spPr>
+          <a:xfrm>
+            <a:off x="7426713" y="643467"/>
+            <a:ext cx="3616848" cy="6143223"/>
+          </a:xfrm>
+          <a:prstGeom prst="rect">
+            <a:avLst/>
+          </a:prstGeom>
+        </p:spPr>
+      </p:pic>
+    </p:spTree>
+    <p:extLst>
+      <p:ext uri="{BB962C8B-B14F-4D97-AF65-F5344CB8AC3E}">
+        <p14:creationId xmlns:p14="http://schemas.microsoft.com/office/powerpoint/2010/main" val="2965452809"/>
       </p:ext>
     </p:extLst>
   </p:cSld>

</xml_diff>

<commit_message>
building optimisation tourney simulator
</commit_message>
<xml_diff>
--- a/strategy/BBL Fantasy AI v2 Strategy & Planning.pptx
+++ b/strategy/BBL Fantasy AI v2 Strategy & Planning.pptx
@@ -11,6 +11,9 @@
     <p:sldId id="259" r:id="rId5"/>
     <p:sldId id="260" r:id="rId6"/>
     <p:sldId id="261" r:id="rId7"/>
+    <p:sldId id="263" r:id="rId8"/>
+    <p:sldId id="262" r:id="rId9"/>
+    <p:sldId id="264" r:id="rId10"/>
   </p:sldIdLst>
   <p:sldSz cx="12192000" cy="6858000"/>
   <p:notesSz cx="6858000" cy="9144000"/>
@@ -116,10 +119,25 @@
           <p14:sldIdLst>
             <p14:sldId id="256"/>
             <p14:sldId id="257"/>
+          </p14:sldIdLst>
+        </p14:section>
+        <p14:section name="Pricing Model" id="{7923590F-B911-4954-8180-316826DCECB0}">
+          <p14:sldIdLst>
             <p14:sldId id="258"/>
             <p14:sldId id="259"/>
             <p14:sldId id="260"/>
             <p14:sldId id="261"/>
+          </p14:sldIdLst>
+        </p14:section>
+        <p14:section name="Previous Model Build" id="{F6783EA7-0B85-432C-8B34-5ACBD9E0708B}">
+          <p14:sldIdLst>
+            <p14:sldId id="263"/>
+          </p14:sldIdLst>
+        </p14:section>
+        <p14:section name="Batting Point Model" id="{20176CAB-22A2-449A-ADF4-9AEF7BF31A4F}">
+          <p14:sldIdLst>
+            <p14:sldId id="262"/>
+            <p14:sldId id="264"/>
           </p14:sldIdLst>
         </p14:section>
       </p14:sectionLst>
@@ -145,7 +163,7 @@
 <file path=ppt/revisionInfo.xml><?xml version="1.0" encoding="utf-8"?>
 <p1510:revInfo xmlns:a="http://schemas.openxmlformats.org/drawingml/2006/main" xmlns:r="http://schemas.openxmlformats.org/officeDocument/2006/relationships" xmlns:p1510="http://schemas.microsoft.com/office/powerpoint/2015/10/main">
   <p1510:revLst>
-    <p1510:client id="{B4EA8C78-5629-4CB8-9794-5E1861B660A8}" v="4" dt="2025-06-04T11:46:47.040"/>
+    <p1510:client id="{B4EA8C78-5629-4CB8-9794-5E1861B660A8}" v="3" dt="2025-06-15T12:39:55.563"/>
   </p1510:revLst>
 </p1510:revInfo>
 </file>
@@ -154,19 +172,19 @@
 <pc:chgInfo xmlns:a="http://schemas.openxmlformats.org/drawingml/2006/main" xmlns:r="http://schemas.openxmlformats.org/officeDocument/2006/relationships" xmlns:ac="http://schemas.microsoft.com/office/drawing/2013/main/command" xmlns:pc="http://schemas.microsoft.com/office/powerpoint/2013/main/command">
   <pc:docChgLst>
     <pc:chgData name="Dilan De Silva" userId="579b606d6e18a4ed" providerId="LiveId" clId="{B4EA8C78-5629-4CB8-9794-5E1861B660A8}"/>
-    <pc:docChg chg="undo custSel addSld delSld modSld modSection">
-      <pc:chgData name="Dilan De Silva" userId="579b606d6e18a4ed" providerId="LiveId" clId="{B4EA8C78-5629-4CB8-9794-5E1861B660A8}" dt="2025-06-04T11:53:20.945" v="351" actId="20577"/>
+    <pc:docChg chg="undo custSel addSld delSld modSld sldOrd addSection modSection">
+      <pc:chgData name="Dilan De Silva" userId="579b606d6e18a4ed" providerId="LiveId" clId="{B4EA8C78-5629-4CB8-9794-5E1861B660A8}" dt="2025-06-15T12:50:16.556" v="1890" actId="20577"/>
       <pc:docMkLst>
         <pc:docMk/>
       </pc:docMkLst>
       <pc:sldChg chg="modSp mod">
-        <pc:chgData name="Dilan De Silva" userId="579b606d6e18a4ed" providerId="LiveId" clId="{B4EA8C78-5629-4CB8-9794-5E1861B660A8}" dt="2025-06-04T11:53:20.945" v="351" actId="20577"/>
+        <pc:chgData name="Dilan De Silva" userId="579b606d6e18a4ed" providerId="LiveId" clId="{B4EA8C78-5629-4CB8-9794-5E1861B660A8}" dt="2025-06-15T12:45:43.389" v="1685" actId="20577"/>
         <pc:sldMkLst>
           <pc:docMk/>
           <pc:sldMk cId="1969437762" sldId="257"/>
         </pc:sldMkLst>
         <pc:spChg chg="mod">
-          <ac:chgData name="Dilan De Silva" userId="579b606d6e18a4ed" providerId="LiveId" clId="{B4EA8C78-5629-4CB8-9794-5E1861B660A8}" dt="2025-06-04T11:53:20.945" v="351" actId="20577"/>
+          <ac:chgData name="Dilan De Silva" userId="579b606d6e18a4ed" providerId="LiveId" clId="{B4EA8C78-5629-4CB8-9794-5E1861B660A8}" dt="2025-06-15T12:45:43.389" v="1685" actId="20577"/>
           <ac:spMkLst>
             <pc:docMk/>
             <pc:sldMk cId="1969437762" sldId="257"/>
@@ -196,126 +214,6 @@
             <ac:spMk id="3" creationId="{6AA0120E-7982-2BE3-3FA1-358B5018E8F7}"/>
           </ac:spMkLst>
         </pc:spChg>
-        <pc:spChg chg="add del">
-          <ac:chgData name="Dilan De Silva" userId="579b606d6e18a4ed" providerId="LiveId" clId="{B4EA8C78-5629-4CB8-9794-5E1861B660A8}" dt="2025-06-04T11:50:15.728" v="319" actId="26606"/>
-          <ac:spMkLst>
-            <pc:docMk/>
-            <pc:sldMk cId="1471337115" sldId="258"/>
-            <ac:spMk id="8" creationId="{907EF6B7-1338-4443-8C46-6A318D952DFD}"/>
-          </ac:spMkLst>
-        </pc:spChg>
-        <pc:spChg chg="add del">
-          <ac:chgData name="Dilan De Silva" userId="579b606d6e18a4ed" providerId="LiveId" clId="{B4EA8C78-5629-4CB8-9794-5E1861B660A8}" dt="2025-06-04T11:50:15.728" v="319" actId="26606"/>
-          <ac:spMkLst>
-            <pc:docMk/>
-            <pc:sldMk cId="1471337115" sldId="258"/>
-            <ac:spMk id="10" creationId="{DAAE4CDD-124C-4DCF-9584-B6033B545DD5}"/>
-          </ac:spMkLst>
-        </pc:spChg>
-        <pc:spChg chg="add del">
-          <ac:chgData name="Dilan De Silva" userId="579b606d6e18a4ed" providerId="LiveId" clId="{B4EA8C78-5629-4CB8-9794-5E1861B660A8}" dt="2025-06-04T11:50:15.728" v="319" actId="26606"/>
-          <ac:spMkLst>
-            <pc:docMk/>
-            <pc:sldMk cId="1471337115" sldId="258"/>
-            <ac:spMk id="12" creationId="{081E4A58-353D-44AE-B2FC-2A74E2E400F7}"/>
-          </ac:spMkLst>
-        </pc:spChg>
-        <pc:spChg chg="add del">
-          <ac:chgData name="Dilan De Silva" userId="579b606d6e18a4ed" providerId="LiveId" clId="{B4EA8C78-5629-4CB8-9794-5E1861B660A8}" dt="2025-06-04T11:50:54.585" v="325" actId="26606"/>
-          <ac:spMkLst>
-            <pc:docMk/>
-            <pc:sldMk cId="1471337115" sldId="258"/>
-            <ac:spMk id="14" creationId="{21C9FE86-FCC3-4A31-AA1C-C882262B7FE7}"/>
-          </ac:spMkLst>
-        </pc:spChg>
-        <pc:spChg chg="add del">
-          <ac:chgData name="Dilan De Silva" userId="579b606d6e18a4ed" providerId="LiveId" clId="{B4EA8C78-5629-4CB8-9794-5E1861B660A8}" dt="2025-06-04T11:50:54.585" v="325" actId="26606"/>
-          <ac:spMkLst>
-            <pc:docMk/>
-            <pc:sldMk cId="1471337115" sldId="258"/>
-            <ac:spMk id="15" creationId="{DEE2AD96-B495-4E06-9291-B71706F728CB}"/>
-          </ac:spMkLst>
-        </pc:spChg>
-        <pc:spChg chg="add del">
-          <ac:chgData name="Dilan De Silva" userId="579b606d6e18a4ed" providerId="LiveId" clId="{B4EA8C78-5629-4CB8-9794-5E1861B660A8}" dt="2025-06-04T11:50:54.585" v="325" actId="26606"/>
-          <ac:spMkLst>
-            <pc:docMk/>
-            <pc:sldMk cId="1471337115" sldId="258"/>
-            <ac:spMk id="16" creationId="{7D96243B-ECED-4B71-8E06-AE9A285EAD20}"/>
-          </ac:spMkLst>
-        </pc:spChg>
-        <pc:spChg chg="add del">
-          <ac:chgData name="Dilan De Silva" userId="579b606d6e18a4ed" providerId="LiveId" clId="{B4EA8C78-5629-4CB8-9794-5E1861B660A8}" dt="2025-06-04T11:50:54.585" v="325" actId="26606"/>
-          <ac:spMkLst>
-            <pc:docMk/>
-            <pc:sldMk cId="1471337115" sldId="258"/>
-            <ac:spMk id="17" creationId="{53CF6D67-C5A8-4ADD-9E8E-1E38CA1D3166}"/>
-          </ac:spMkLst>
-        </pc:spChg>
-        <pc:spChg chg="add del">
-          <ac:chgData name="Dilan De Silva" userId="579b606d6e18a4ed" providerId="LiveId" clId="{B4EA8C78-5629-4CB8-9794-5E1861B660A8}" dt="2025-06-04T11:50:54.585" v="325" actId="26606"/>
-          <ac:spMkLst>
-            <pc:docMk/>
-            <pc:sldMk cId="1471337115" sldId="258"/>
-            <ac:spMk id="18" creationId="{A09989E4-EFDC-4A90-A633-E0525FB4139E}"/>
-          </ac:spMkLst>
-        </pc:spChg>
-        <pc:spChg chg="add del">
-          <ac:chgData name="Dilan De Silva" userId="579b606d6e18a4ed" providerId="LiveId" clId="{B4EA8C78-5629-4CB8-9794-5E1861B660A8}" dt="2025-06-04T11:50:54.585" v="325" actId="26606"/>
-          <ac:spMkLst>
-            <pc:docMk/>
-            <pc:sldMk cId="1471337115" sldId="258"/>
-            <ac:spMk id="19" creationId="{86909FA0-B515-4681-B7A8-FA281D133B94}"/>
-          </ac:spMkLst>
-        </pc:spChg>
-        <pc:spChg chg="add del">
-          <ac:chgData name="Dilan De Silva" userId="579b606d6e18a4ed" providerId="LiveId" clId="{B4EA8C78-5629-4CB8-9794-5E1861B660A8}" dt="2025-06-04T11:50:54" v="324" actId="26606"/>
-          <ac:spMkLst>
-            <pc:docMk/>
-            <pc:sldMk cId="1471337115" sldId="258"/>
-            <ac:spMk id="24" creationId="{C2554CA6-288E-4202-BC52-2E5A8F0C0AED}"/>
-          </ac:spMkLst>
-        </pc:spChg>
-        <pc:spChg chg="add del">
-          <ac:chgData name="Dilan De Silva" userId="579b606d6e18a4ed" providerId="LiveId" clId="{B4EA8C78-5629-4CB8-9794-5E1861B660A8}" dt="2025-06-04T11:50:46.650" v="322" actId="26606"/>
-          <ac:spMkLst>
-            <pc:docMk/>
-            <pc:sldMk cId="1471337115" sldId="258"/>
-            <ac:spMk id="25" creationId="{E51BA4DF-2BD4-4EC2-B1DB-B27C8AC71864}"/>
-          </ac:spMkLst>
-        </pc:spChg>
-        <pc:spChg chg="add del">
-          <ac:chgData name="Dilan De Silva" userId="579b606d6e18a4ed" providerId="LiveId" clId="{B4EA8C78-5629-4CB8-9794-5E1861B660A8}" dt="2025-06-04T11:50:54" v="324" actId="26606"/>
-          <ac:spMkLst>
-            <pc:docMk/>
-            <pc:sldMk cId="1471337115" sldId="258"/>
-            <ac:spMk id="26" creationId="{B10BB131-AC8E-4A8E-A5D1-36260F720C3B}"/>
-          </ac:spMkLst>
-        </pc:spChg>
-        <pc:spChg chg="add del">
-          <ac:chgData name="Dilan De Silva" userId="579b606d6e18a4ed" providerId="LiveId" clId="{B4EA8C78-5629-4CB8-9794-5E1861B660A8}" dt="2025-06-04T11:50:54" v="324" actId="26606"/>
-          <ac:spMkLst>
-            <pc:docMk/>
-            <pc:sldMk cId="1471337115" sldId="258"/>
-            <ac:spMk id="28" creationId="{5B7778FC-632E-4DCA-A7CB-0D7731CCF970}"/>
-          </ac:spMkLst>
-        </pc:spChg>
-        <pc:spChg chg="add del">
-          <ac:chgData name="Dilan De Silva" userId="579b606d6e18a4ed" providerId="LiveId" clId="{B4EA8C78-5629-4CB8-9794-5E1861B660A8}" dt="2025-06-04T11:50:54" v="324" actId="26606"/>
-          <ac:spMkLst>
-            <pc:docMk/>
-            <pc:sldMk cId="1471337115" sldId="258"/>
-            <ac:spMk id="30" creationId="{FA23A907-97FB-4A8F-880A-DD77401C4296}"/>
-          </ac:spMkLst>
-        </pc:spChg>
-        <pc:picChg chg="add del">
-          <ac:chgData name="Dilan De Silva" userId="579b606d6e18a4ed" providerId="LiveId" clId="{B4EA8C78-5629-4CB8-9794-5E1861B660A8}" dt="2025-06-04T11:50:46.650" v="322" actId="26606"/>
-          <ac:picMkLst>
-            <pc:docMk/>
-            <pc:sldMk cId="1471337115" sldId="258"/>
-            <ac:picMk id="21" creationId="{177C5153-58F6-5D3A-8D0E-54723CBCC58C}"/>
-          </ac:picMkLst>
-        </pc:picChg>
       </pc:sldChg>
       <pc:sldChg chg="addSp delSp modSp add mod setBg">
         <pc:chgData name="Dilan De Silva" userId="579b606d6e18a4ed" providerId="LiveId" clId="{B4EA8C78-5629-4CB8-9794-5E1861B660A8}" dt="2025-06-04T11:43:17.177" v="278" actId="14100"/>
@@ -329,22 +227,6 @@
             <pc:docMk/>
             <pc:sldMk cId="3689564591" sldId="259"/>
             <ac:spMk id="2" creationId="{634F4B6D-B859-81E2-585F-115E16516769}"/>
-          </ac:spMkLst>
-        </pc:spChg>
-        <pc:spChg chg="del">
-          <ac:chgData name="Dilan De Silva" userId="579b606d6e18a4ed" providerId="LiveId" clId="{B4EA8C78-5629-4CB8-9794-5E1861B660A8}" dt="2025-06-04T11:39:44.756" v="254" actId="478"/>
-          <ac:spMkLst>
-            <pc:docMk/>
-            <pc:sldMk cId="3689564591" sldId="259"/>
-            <ac:spMk id="3" creationId="{0DF82F1A-9CA6-D0BF-8E13-9118095E8C40}"/>
-          </ac:spMkLst>
-        </pc:spChg>
-        <pc:spChg chg="add del mod">
-          <ac:chgData name="Dilan De Silva" userId="579b606d6e18a4ed" providerId="LiveId" clId="{B4EA8C78-5629-4CB8-9794-5E1861B660A8}" dt="2025-06-04T11:39:46.203" v="255" actId="478"/>
-          <ac:spMkLst>
-            <pc:docMk/>
-            <pc:sldMk cId="3689564591" sldId="259"/>
-            <ac:spMk id="5" creationId="{4C5D2196-DF3C-B032-394F-B89861FD881B}"/>
           </ac:spMkLst>
         </pc:spChg>
         <pc:spChg chg="add">
@@ -386,14 +268,6 @@
           <pc:docMk/>
           <pc:sldMk cId="3635980319" sldId="260"/>
         </pc:sldMkLst>
-        <pc:spChg chg="del">
-          <ac:chgData name="Dilan De Silva" userId="579b606d6e18a4ed" providerId="LiveId" clId="{B4EA8C78-5629-4CB8-9794-5E1861B660A8}" dt="2025-06-04T11:43:20.431" v="280"/>
-          <ac:spMkLst>
-            <pc:docMk/>
-            <pc:sldMk cId="3635980319" sldId="260"/>
-            <ac:spMk id="12" creationId="{BD3E3139-69B3-EF75-1D3F-6E80688BF8A1}"/>
-          </ac:spMkLst>
-        </pc:spChg>
       </pc:sldChg>
       <pc:sldChg chg="addSp delSp modSp add mod setBg delDesignElem">
         <pc:chgData name="Dilan De Silva" userId="579b606d6e18a4ed" providerId="LiveId" clId="{B4EA8C78-5629-4CB8-9794-5E1861B660A8}" dt="2025-06-04T11:46:42.393" v="308" actId="14100"/>
@@ -417,14 +291,6 @@
             <ac:spMk id="6" creationId="{A4AC5506-6312-4701-8D3C-40187889A947}"/>
           </ac:spMkLst>
         </pc:spChg>
-        <pc:spChg chg="del">
-          <ac:chgData name="Dilan De Silva" userId="579b606d6e18a4ed" providerId="LiveId" clId="{B4EA8C78-5629-4CB8-9794-5E1861B660A8}" dt="2025-06-04T11:43:35.442" v="283"/>
-          <ac:spMkLst>
-            <pc:docMk/>
-            <pc:sldMk cId="4008747595" sldId="260"/>
-            <ac:spMk id="12" creationId="{426A7368-99AE-D5EB-011B-646DC6C76C88}"/>
-          </ac:spMkLst>
-        </pc:spChg>
         <pc:picChg chg="add mod">
           <ac:chgData name="Dilan De Silva" userId="579b606d6e18a4ed" providerId="LiveId" clId="{B4EA8C78-5629-4CB8-9794-5E1861B660A8}" dt="2025-06-04T11:45:07.352" v="297" actId="1076"/>
           <ac:picMkLst>
@@ -433,36 +299,12 @@
             <ac:picMk id="4" creationId="{46ADA508-1956-0619-0812-604D6A80AA3D}"/>
           </ac:picMkLst>
         </pc:picChg>
-        <pc:picChg chg="del">
-          <ac:chgData name="Dilan De Silva" userId="579b606d6e18a4ed" providerId="LiveId" clId="{B4EA8C78-5629-4CB8-9794-5E1861B660A8}" dt="2025-06-04T11:44:27.829" v="289" actId="478"/>
-          <ac:picMkLst>
-            <pc:docMk/>
-            <pc:sldMk cId="4008747595" sldId="260"/>
-            <ac:picMk id="7" creationId="{B4D6DD62-E031-EFB6-3B5D-98BFAF1D453D}"/>
-          </ac:picMkLst>
-        </pc:picChg>
         <pc:picChg chg="add mod">
           <ac:chgData name="Dilan De Silva" userId="579b606d6e18a4ed" providerId="LiveId" clId="{B4EA8C78-5629-4CB8-9794-5E1861B660A8}" dt="2025-06-04T11:45:35.399" v="301" actId="1076"/>
           <ac:picMkLst>
             <pc:docMk/>
             <pc:sldMk cId="4008747595" sldId="260"/>
             <ac:picMk id="8" creationId="{21BBA2F4-FEC3-3E5E-40AF-06BB3E73DA43}"/>
-          </ac:picMkLst>
-        </pc:picChg>
-        <pc:picChg chg="del">
-          <ac:chgData name="Dilan De Silva" userId="579b606d6e18a4ed" providerId="LiveId" clId="{B4EA8C78-5629-4CB8-9794-5E1861B660A8}" dt="2025-06-04T11:44:32.408" v="291" actId="478"/>
-          <ac:picMkLst>
-            <pc:docMk/>
-            <pc:sldMk cId="4008747595" sldId="260"/>
-            <ac:picMk id="9" creationId="{8E082431-13F4-A59C-C1AD-60F1B4EFF310}"/>
-          </ac:picMkLst>
-        </pc:picChg>
-        <pc:picChg chg="del">
-          <ac:chgData name="Dilan De Silva" userId="579b606d6e18a4ed" providerId="LiveId" clId="{B4EA8C78-5629-4CB8-9794-5E1861B660A8}" dt="2025-06-04T11:44:30.026" v="290" actId="478"/>
-          <ac:picMkLst>
-            <pc:docMk/>
-            <pc:sldMk cId="4008747595" sldId="260"/>
-            <ac:picMk id="11" creationId="{DC3C450D-DA42-6D36-10EE-3A2DDADD55E6}"/>
           </ac:picMkLst>
         </pc:picChg>
         <pc:picChg chg="add mod modCrop">
@@ -474,8 +316,8 @@
           </ac:picMkLst>
         </pc:picChg>
       </pc:sldChg>
-      <pc:sldChg chg="addSp delSp modSp add mod setBg delDesignElem">
-        <pc:chgData name="Dilan De Silva" userId="579b606d6e18a4ed" providerId="LiveId" clId="{B4EA8C78-5629-4CB8-9794-5E1861B660A8}" dt="2025-06-04T11:52:54.903" v="340" actId="14100"/>
+      <pc:sldChg chg="addSp delSp modSp add mod ord setBg delDesignElem">
+        <pc:chgData name="Dilan De Silva" userId="579b606d6e18a4ed" providerId="LiveId" clId="{B4EA8C78-5629-4CB8-9794-5E1861B660A8}" dt="2025-06-15T12:27:12.774" v="550"/>
         <pc:sldMkLst>
           <pc:docMk/>
           <pc:sldMk cId="2965452809" sldId="261"/>
@@ -488,14 +330,6 @@
             <ac:spMk id="2" creationId="{C5482A9D-F23B-6B0C-5B36-B51009F97FF3}"/>
           </ac:spMkLst>
         </pc:spChg>
-        <pc:spChg chg="del">
-          <ac:chgData name="Dilan De Silva" userId="579b606d6e18a4ed" providerId="LiveId" clId="{B4EA8C78-5629-4CB8-9794-5E1861B660A8}" dt="2025-06-04T11:46:47.040" v="310"/>
-          <ac:spMkLst>
-            <pc:docMk/>
-            <pc:sldMk cId="2965452809" sldId="261"/>
-            <ac:spMk id="6" creationId="{6874E7C7-F85F-7C86-DCEE-7AD33E86EFA9}"/>
-          </ac:spMkLst>
-        </pc:spChg>
         <pc:spChg chg="add">
           <ac:chgData name="Dilan De Silva" userId="579b606d6e18a4ed" providerId="LiveId" clId="{B4EA8C78-5629-4CB8-9794-5E1861B660A8}" dt="2025-06-04T11:46:56.629" v="313" actId="26606"/>
           <ac:spMkLst>
@@ -504,28 +338,12 @@
             <ac:spMk id="9" creationId="{A4AC5506-6312-4701-8D3C-40187889A947}"/>
           </ac:spMkLst>
         </pc:spChg>
-        <pc:picChg chg="del mod">
-          <ac:chgData name="Dilan De Silva" userId="579b606d6e18a4ed" providerId="LiveId" clId="{B4EA8C78-5629-4CB8-9794-5E1861B660A8}" dt="2025-06-04T11:47:03.115" v="317" actId="478"/>
-          <ac:picMkLst>
-            <pc:docMk/>
-            <pc:sldMk cId="2965452809" sldId="261"/>
-            <ac:picMk id="4" creationId="{4AE3B28B-4CDB-869A-F5BE-7F62A2D925B6}"/>
-          </ac:picMkLst>
-        </pc:picChg>
         <pc:picChg chg="add mod">
           <ac:chgData name="Dilan De Silva" userId="579b606d6e18a4ed" providerId="LiveId" clId="{B4EA8C78-5629-4CB8-9794-5E1861B660A8}" dt="2025-06-04T11:51:31.738" v="329" actId="14100"/>
           <ac:picMkLst>
             <pc:docMk/>
             <pc:sldMk cId="2965452809" sldId="261"/>
             <ac:picMk id="5" creationId="{7E98FE36-BF12-46D4-2CD2-33F841A9E8A2}"/>
-          </ac:picMkLst>
-        </pc:picChg>
-        <pc:picChg chg="del">
-          <ac:chgData name="Dilan De Silva" userId="579b606d6e18a4ed" providerId="LiveId" clId="{B4EA8C78-5629-4CB8-9794-5E1861B660A8}" dt="2025-06-04T11:46:54.410" v="312" actId="478"/>
-          <ac:picMkLst>
-            <pc:docMk/>
-            <pc:sldMk cId="2965452809" sldId="261"/>
-            <ac:picMk id="8" creationId="{D51CD665-AFE1-AE67-E7FC-8F4B4CBC5FC7}"/>
           </ac:picMkLst>
         </pc:picChg>
         <pc:picChg chg="add mod">
@@ -544,14 +362,67 @@
             <ac:picMk id="12" creationId="{342A7AB9-6630-4F9C-7639-DBB9443F9BE2}"/>
           </ac:picMkLst>
         </pc:picChg>
-        <pc:picChg chg="del">
-          <ac:chgData name="Dilan De Silva" userId="579b606d6e18a4ed" providerId="LiveId" clId="{B4EA8C78-5629-4CB8-9794-5E1861B660A8}" dt="2025-06-04T11:46:50.116" v="311" actId="478"/>
-          <ac:picMkLst>
+      </pc:sldChg>
+      <pc:sldChg chg="modSp add mod ord">
+        <pc:chgData name="Dilan De Silva" userId="579b606d6e18a4ed" providerId="LiveId" clId="{B4EA8C78-5629-4CB8-9794-5E1861B660A8}" dt="2025-06-15T12:50:16.556" v="1890" actId="20577"/>
+        <pc:sldMkLst>
+          <pc:docMk/>
+          <pc:sldMk cId="4290225454" sldId="262"/>
+        </pc:sldMkLst>
+        <pc:spChg chg="mod">
+          <ac:chgData name="Dilan De Silva" userId="579b606d6e18a4ed" providerId="LiveId" clId="{B4EA8C78-5629-4CB8-9794-5E1861B660A8}" dt="2025-06-15T12:25:10.942" v="373" actId="20577"/>
+          <ac:spMkLst>
             <pc:docMk/>
-            <pc:sldMk cId="2965452809" sldId="261"/>
-            <ac:picMk id="13" creationId="{2F957EFD-A50B-A610-FCE0-2C5E49C173CF}"/>
-          </ac:picMkLst>
-        </pc:picChg>
+            <pc:sldMk cId="4290225454" sldId="262"/>
+            <ac:spMk id="2" creationId="{38189B02-1CB5-3025-7E40-16AC7F9CC97E}"/>
+          </ac:spMkLst>
+        </pc:spChg>
+        <pc:spChg chg="mod">
+          <ac:chgData name="Dilan De Silva" userId="579b606d6e18a4ed" providerId="LiveId" clId="{B4EA8C78-5629-4CB8-9794-5E1861B660A8}" dt="2025-06-15T12:50:16.556" v="1890" actId="20577"/>
+          <ac:spMkLst>
+            <pc:docMk/>
+            <pc:sldMk cId="4290225454" sldId="262"/>
+            <ac:spMk id="3" creationId="{74486134-C9F0-19C3-2C44-4B0A4DBC5B91}"/>
+          </ac:spMkLst>
+        </pc:spChg>
+      </pc:sldChg>
+      <pc:sldChg chg="modSp add mod ord">
+        <pc:chgData name="Dilan De Silva" userId="579b606d6e18a4ed" providerId="LiveId" clId="{B4EA8C78-5629-4CB8-9794-5E1861B660A8}" dt="2025-06-15T12:33:19.261" v="878" actId="20577"/>
+        <pc:sldMkLst>
+          <pc:docMk/>
+          <pc:sldMk cId="3167652951" sldId="263"/>
+        </pc:sldMkLst>
+        <pc:spChg chg="mod">
+          <ac:chgData name="Dilan De Silva" userId="579b606d6e18a4ed" providerId="LiveId" clId="{B4EA8C78-5629-4CB8-9794-5E1861B660A8}" dt="2025-06-15T12:27:25.575" v="573" actId="20577"/>
+          <ac:spMkLst>
+            <pc:docMk/>
+            <pc:sldMk cId="3167652951" sldId="263"/>
+            <ac:spMk id="2" creationId="{81D8804F-5E8C-1D4B-605A-E3F1492FD67A}"/>
+          </ac:spMkLst>
+        </pc:spChg>
+        <pc:spChg chg="mod">
+          <ac:chgData name="Dilan De Silva" userId="579b606d6e18a4ed" providerId="LiveId" clId="{B4EA8C78-5629-4CB8-9794-5E1861B660A8}" dt="2025-06-15T12:33:19.261" v="878" actId="20577"/>
+          <ac:spMkLst>
+            <pc:docMk/>
+            <pc:sldMk cId="3167652951" sldId="263"/>
+            <ac:spMk id="3" creationId="{BBDF9F51-6BFC-E765-0305-5CD19BCBA5E1}"/>
+          </ac:spMkLst>
+        </pc:spChg>
+      </pc:sldChg>
+      <pc:sldChg chg="modSp add mod">
+        <pc:chgData name="Dilan De Silva" userId="579b606d6e18a4ed" providerId="LiveId" clId="{B4EA8C78-5629-4CB8-9794-5E1861B660A8}" dt="2025-06-15T12:42:45.144" v="1575" actId="20577"/>
+        <pc:sldMkLst>
+          <pc:docMk/>
+          <pc:sldMk cId="2530891803" sldId="264"/>
+        </pc:sldMkLst>
+        <pc:spChg chg="mod">
+          <ac:chgData name="Dilan De Silva" userId="579b606d6e18a4ed" providerId="LiveId" clId="{B4EA8C78-5629-4CB8-9794-5E1861B660A8}" dt="2025-06-15T12:42:45.144" v="1575" actId="20577"/>
+          <ac:spMkLst>
+            <pc:docMk/>
+            <pc:sldMk cId="2530891803" sldId="264"/>
+            <ac:spMk id="3" creationId="{C11D1478-2B91-A5BD-6C42-8F2FEAD445BC}"/>
+          </ac:spMkLst>
+        </pc:spChg>
       </pc:sldChg>
     </pc:docChg>
   </pc:docChgLst>
@@ -707,7 +578,7 @@
           <a:p>
             <a:fld id="{2D73D9AC-D42E-4620-8482-0397FE94AE8B}" type="datetimeFigureOut">
               <a:rPr lang="en-AU" smtClean="0"/>
-              <a:t>4/06/2025</a:t>
+              <a:t>15/06/2025</a:t>
             </a:fld>
             <a:endParaRPr lang="en-AU"/>
           </a:p>
@@ -907,7 +778,7 @@
           <a:p>
             <a:fld id="{2D73D9AC-D42E-4620-8482-0397FE94AE8B}" type="datetimeFigureOut">
               <a:rPr lang="en-AU" smtClean="0"/>
-              <a:t>4/06/2025</a:t>
+              <a:t>15/06/2025</a:t>
             </a:fld>
             <a:endParaRPr lang="en-AU"/>
           </a:p>
@@ -1117,7 +988,7 @@
           <a:p>
             <a:fld id="{2D73D9AC-D42E-4620-8482-0397FE94AE8B}" type="datetimeFigureOut">
               <a:rPr lang="en-AU" smtClean="0"/>
-              <a:t>4/06/2025</a:t>
+              <a:t>15/06/2025</a:t>
             </a:fld>
             <a:endParaRPr lang="en-AU"/>
           </a:p>
@@ -1317,7 +1188,7 @@
           <a:p>
             <a:fld id="{2D73D9AC-D42E-4620-8482-0397FE94AE8B}" type="datetimeFigureOut">
               <a:rPr lang="en-AU" smtClean="0"/>
-              <a:t>4/06/2025</a:t>
+              <a:t>15/06/2025</a:t>
             </a:fld>
             <a:endParaRPr lang="en-AU"/>
           </a:p>
@@ -1593,7 +1464,7 @@
           <a:p>
             <a:fld id="{2D73D9AC-D42E-4620-8482-0397FE94AE8B}" type="datetimeFigureOut">
               <a:rPr lang="en-AU" smtClean="0"/>
-              <a:t>4/06/2025</a:t>
+              <a:t>15/06/2025</a:t>
             </a:fld>
             <a:endParaRPr lang="en-AU"/>
           </a:p>
@@ -1861,7 +1732,7 @@
           <a:p>
             <a:fld id="{2D73D9AC-D42E-4620-8482-0397FE94AE8B}" type="datetimeFigureOut">
               <a:rPr lang="en-AU" smtClean="0"/>
-              <a:t>4/06/2025</a:t>
+              <a:t>15/06/2025</a:t>
             </a:fld>
             <a:endParaRPr lang="en-AU"/>
           </a:p>
@@ -2276,7 +2147,7 @@
           <a:p>
             <a:fld id="{2D73D9AC-D42E-4620-8482-0397FE94AE8B}" type="datetimeFigureOut">
               <a:rPr lang="en-AU" smtClean="0"/>
-              <a:t>4/06/2025</a:t>
+              <a:t>15/06/2025</a:t>
             </a:fld>
             <a:endParaRPr lang="en-AU"/>
           </a:p>
@@ -2418,7 +2289,7 @@
           <a:p>
             <a:fld id="{2D73D9AC-D42E-4620-8482-0397FE94AE8B}" type="datetimeFigureOut">
               <a:rPr lang="en-AU" smtClean="0"/>
-              <a:t>4/06/2025</a:t>
+              <a:t>15/06/2025</a:t>
             </a:fld>
             <a:endParaRPr lang="en-AU"/>
           </a:p>
@@ -2531,7 +2402,7 @@
           <a:p>
             <a:fld id="{2D73D9AC-D42E-4620-8482-0397FE94AE8B}" type="datetimeFigureOut">
               <a:rPr lang="en-AU" smtClean="0"/>
-              <a:t>4/06/2025</a:t>
+              <a:t>15/06/2025</a:t>
             </a:fld>
             <a:endParaRPr lang="en-AU"/>
           </a:p>
@@ -2844,7 +2715,7 @@
           <a:p>
             <a:fld id="{2D73D9AC-D42E-4620-8482-0397FE94AE8B}" type="datetimeFigureOut">
               <a:rPr lang="en-AU" smtClean="0"/>
-              <a:t>4/06/2025</a:t>
+              <a:t>15/06/2025</a:t>
             </a:fld>
             <a:endParaRPr lang="en-AU"/>
           </a:p>
@@ -3133,7 +3004,7 @@
           <a:p>
             <a:fld id="{2D73D9AC-D42E-4620-8482-0397FE94AE8B}" type="datetimeFigureOut">
               <a:rPr lang="en-AU" smtClean="0"/>
-              <a:t>4/06/2025</a:t>
+              <a:t>15/06/2025</a:t>
             </a:fld>
             <a:endParaRPr lang="en-AU"/>
           </a:p>
@@ -3376,7 +3247,7 @@
           <a:p>
             <a:fld id="{2D73D9AC-D42E-4620-8482-0397FE94AE8B}" type="datetimeFigureOut">
               <a:rPr lang="en-AU" smtClean="0"/>
-              <a:t>4/06/2025</a:t>
+              <a:t>15/06/2025</a:t>
             </a:fld>
             <a:endParaRPr lang="en-AU"/>
           </a:p>
@@ -3943,18 +3814,33 @@
           <a:p>
             <a:r>
               <a:rPr lang="en-AU" dirty="0"/>
-              <a:t>Batting &amp; Bowling </a:t>
-            </a:r>
-            <a:r>
-              <a:rPr lang="en-AU"/>
-              <a:t>Points Modelling (*)</a:t>
-            </a:r>
-            <a:endParaRPr lang="en-AU" dirty="0"/>
+              <a:t>Batting &amp; Bowling Points Modelling (*)</a:t>
+            </a:r>
           </a:p>
           <a:p>
             <a:r>
               <a:rPr lang="en-AU" dirty="0"/>
               <a:t>Interval Modelling instead of Point Estimation</a:t>
+            </a:r>
+          </a:p>
+          <a:p>
+            <a:r>
+              <a:rPr lang="en-AU" dirty="0"/>
+              <a:t>New Player Unsupervised Clustering Model to identify closest x amount of current </a:t>
+            </a:r>
+            <a:r>
+              <a:rPr lang="en-AU" dirty="0" err="1"/>
+              <a:t>bbl</a:t>
+            </a:r>
+            <a:r>
+              <a:rPr lang="en-AU" dirty="0"/>
+              <a:t> players and mimic predictions (Gen AI?)</a:t>
+            </a:r>
+          </a:p>
+          <a:p>
+            <a:r>
+              <a:rPr lang="en-AU" dirty="0"/>
+              <a:t>Weather model/ alternative strategies based on rain out games</a:t>
             </a:r>
           </a:p>
           <a:p>
@@ -4820,6 +4706,460 @@
     <p:extLst>
       <p:ext uri="{BB962C8B-B14F-4D97-AF65-F5344CB8AC3E}">
         <p14:creationId xmlns:p14="http://schemas.microsoft.com/office/powerpoint/2010/main" val="2965452809"/>
+      </p:ext>
+    </p:extLst>
+  </p:cSld>
+  <p:clrMapOvr>
+    <a:masterClrMapping/>
+  </p:clrMapOvr>
+</p:sld>
+</file>
+
+<file path=ppt/slides/slide7.xml><?xml version="1.0" encoding="utf-8"?>
+<p:sld xmlns:a="http://schemas.openxmlformats.org/drawingml/2006/main" xmlns:r="http://schemas.openxmlformats.org/officeDocument/2006/relationships" xmlns:p="http://schemas.openxmlformats.org/presentationml/2006/main">
+  <p:cSld>
+    <p:spTree>
+      <p:nvGrpSpPr>
+        <p:cNvPr id="1" name="">
+          <a:extLst>
+            <a:ext uri="{FF2B5EF4-FFF2-40B4-BE49-F238E27FC236}">
+              <a16:creationId xmlns:a16="http://schemas.microsoft.com/office/drawing/2014/main" id="{F4A38E95-46C2-8089-3AFF-EC46EF3AD4DE}"/>
+            </a:ext>
+          </a:extLst>
+        </p:cNvPr>
+        <p:cNvGrpSpPr/>
+        <p:nvPr/>
+      </p:nvGrpSpPr>
+      <p:grpSpPr>
+        <a:xfrm>
+          <a:off x="0" y="0"/>
+          <a:ext cx="0" cy="0"/>
+          <a:chOff x="0" y="0"/>
+          <a:chExt cx="0" cy="0"/>
+        </a:xfrm>
+      </p:grpSpPr>
+      <p:sp>
+        <p:nvSpPr>
+          <p:cNvPr id="2" name="Title 1">
+            <a:extLst>
+              <a:ext uri="{FF2B5EF4-FFF2-40B4-BE49-F238E27FC236}">
+                <a16:creationId xmlns:a16="http://schemas.microsoft.com/office/drawing/2014/main" id="{81D8804F-5E8C-1D4B-605A-E3F1492FD67A}"/>
+              </a:ext>
+            </a:extLst>
+          </p:cNvPr>
+          <p:cNvSpPr>
+            <a:spLocks noGrp="1"/>
+          </p:cNvSpPr>
+          <p:nvPr>
+            <p:ph type="title"/>
+          </p:nvPr>
+        </p:nvSpPr>
+        <p:spPr/>
+        <p:txBody>
+          <a:bodyPr/>
+          <a:lstStyle/>
+          <a:p>
+            <a:r>
+              <a:rPr lang="en-AU" dirty="0"/>
+              <a:t>Previous Features</a:t>
+            </a:r>
+          </a:p>
+        </p:txBody>
+      </p:sp>
+      <p:sp>
+        <p:nvSpPr>
+          <p:cNvPr id="3" name="Content Placeholder 2">
+            <a:extLst>
+              <a:ext uri="{FF2B5EF4-FFF2-40B4-BE49-F238E27FC236}">
+                <a16:creationId xmlns:a16="http://schemas.microsoft.com/office/drawing/2014/main" id="{BBDF9F51-6BFC-E765-0305-5CD19BCBA5E1}"/>
+              </a:ext>
+            </a:extLst>
+          </p:cNvPr>
+          <p:cNvSpPr>
+            <a:spLocks noGrp="1"/>
+          </p:cNvSpPr>
+          <p:nvPr>
+            <p:ph idx="1"/>
+          </p:nvPr>
+        </p:nvSpPr>
+        <p:spPr/>
+        <p:txBody>
+          <a:bodyPr>
+            <a:normAutofit lnSpcReduction="10000"/>
+          </a:bodyPr>
+          <a:lstStyle/>
+          <a:p>
+            <a:r>
+              <a:rPr lang="en-AU" dirty="0"/>
+              <a:t>Features</a:t>
+            </a:r>
+          </a:p>
+          <a:p>
+            <a:pPr lvl="1"/>
+            <a:r>
+              <a:rPr lang="en-AU" dirty="0"/>
+              <a:t>Player previous seasons fantasy points summary stats</a:t>
+            </a:r>
+          </a:p>
+          <a:p>
+            <a:pPr lvl="1"/>
+            <a:r>
+              <a:rPr lang="en-AU" dirty="0"/>
+              <a:t>Match opponent</a:t>
+            </a:r>
+          </a:p>
+          <a:p>
+            <a:pPr lvl="1"/>
+            <a:r>
+              <a:rPr lang="en-AU" dirty="0"/>
+              <a:t>Match venue</a:t>
+            </a:r>
+          </a:p>
+          <a:p>
+            <a:pPr lvl="1"/>
+            <a:r>
+              <a:rPr lang="en-AU" dirty="0"/>
+              <a:t>Home venue</a:t>
+            </a:r>
+          </a:p>
+          <a:p>
+            <a:pPr lvl="1"/>
+            <a:r>
+              <a:rPr lang="en-AU" dirty="0"/>
+              <a:t>Team Rank</a:t>
+            </a:r>
+          </a:p>
+          <a:p>
+            <a:pPr lvl="1"/>
+            <a:r>
+              <a:rPr lang="en-AU" dirty="0"/>
+              <a:t>Home Ground Advantage Interaction Term</a:t>
+            </a:r>
+          </a:p>
+          <a:p>
+            <a:r>
+              <a:rPr lang="en-AU" dirty="0"/>
+              <a:t>During Tournament</a:t>
+            </a:r>
+          </a:p>
+          <a:p>
+            <a:pPr lvl="1"/>
+            <a:r>
+              <a:rPr lang="en-AU" dirty="0"/>
+              <a:t>Current season player fantasy points summary stats</a:t>
+            </a:r>
+          </a:p>
+          <a:p>
+            <a:pPr lvl="1"/>
+            <a:r>
+              <a:rPr lang="en-AU" dirty="0"/>
+              <a:t>Which overs bowled</a:t>
+            </a:r>
+          </a:p>
+          <a:p>
+            <a:pPr lvl="1"/>
+            <a:r>
+              <a:rPr lang="en-AU" dirty="0"/>
+              <a:t>Batting position</a:t>
+            </a:r>
+          </a:p>
+          <a:p>
+            <a:pPr lvl="1"/>
+            <a:endParaRPr lang="en-AU" dirty="0"/>
+          </a:p>
+          <a:p>
+            <a:pPr lvl="1"/>
+            <a:endParaRPr lang="en-AU" dirty="0"/>
+          </a:p>
+          <a:p>
+            <a:pPr lvl="1"/>
+            <a:endParaRPr lang="en-AU" dirty="0"/>
+          </a:p>
+        </p:txBody>
+      </p:sp>
+    </p:spTree>
+    <p:extLst>
+      <p:ext uri="{BB962C8B-B14F-4D97-AF65-F5344CB8AC3E}">
+        <p14:creationId xmlns:p14="http://schemas.microsoft.com/office/powerpoint/2010/main" val="3167652951"/>
+      </p:ext>
+    </p:extLst>
+  </p:cSld>
+  <p:clrMapOvr>
+    <a:masterClrMapping/>
+  </p:clrMapOvr>
+</p:sld>
+</file>
+
+<file path=ppt/slides/slide8.xml><?xml version="1.0" encoding="utf-8"?>
+<p:sld xmlns:a="http://schemas.openxmlformats.org/drawingml/2006/main" xmlns:r="http://schemas.openxmlformats.org/officeDocument/2006/relationships" xmlns:p="http://schemas.openxmlformats.org/presentationml/2006/main">
+  <p:cSld>
+    <p:spTree>
+      <p:nvGrpSpPr>
+        <p:cNvPr id="1" name="">
+          <a:extLst>
+            <a:ext uri="{FF2B5EF4-FFF2-40B4-BE49-F238E27FC236}">
+              <a16:creationId xmlns:a16="http://schemas.microsoft.com/office/drawing/2014/main" id="{EEFDBAF1-9EC8-0E7F-DDC2-4E1D27C49E4F}"/>
+            </a:ext>
+          </a:extLst>
+        </p:cNvPr>
+        <p:cNvGrpSpPr/>
+        <p:nvPr/>
+      </p:nvGrpSpPr>
+      <p:grpSpPr>
+        <a:xfrm>
+          <a:off x="0" y="0"/>
+          <a:ext cx="0" cy="0"/>
+          <a:chOff x="0" y="0"/>
+          <a:chExt cx="0" cy="0"/>
+        </a:xfrm>
+      </p:grpSpPr>
+      <p:sp>
+        <p:nvSpPr>
+          <p:cNvPr id="2" name="Title 1">
+            <a:extLst>
+              <a:ext uri="{FF2B5EF4-FFF2-40B4-BE49-F238E27FC236}">
+                <a16:creationId xmlns:a16="http://schemas.microsoft.com/office/drawing/2014/main" id="{38189B02-1CB5-3025-7E40-16AC7F9CC97E}"/>
+              </a:ext>
+            </a:extLst>
+          </p:cNvPr>
+          <p:cNvSpPr>
+            <a:spLocks noGrp="1"/>
+          </p:cNvSpPr>
+          <p:nvPr>
+            <p:ph type="title"/>
+          </p:nvPr>
+        </p:nvSpPr>
+        <p:spPr/>
+        <p:txBody>
+          <a:bodyPr/>
+          <a:lstStyle/>
+          <a:p>
+            <a:r>
+              <a:rPr lang="en-AU" dirty="0"/>
+              <a:t>Batting Model</a:t>
+            </a:r>
+          </a:p>
+        </p:txBody>
+      </p:sp>
+      <p:sp>
+        <p:nvSpPr>
+          <p:cNvPr id="3" name="Content Placeholder 2">
+            <a:extLst>
+              <a:ext uri="{FF2B5EF4-FFF2-40B4-BE49-F238E27FC236}">
+                <a16:creationId xmlns:a16="http://schemas.microsoft.com/office/drawing/2014/main" id="{74486134-C9F0-19C3-2C44-4B0A4DBC5B91}"/>
+              </a:ext>
+            </a:extLst>
+          </p:cNvPr>
+          <p:cNvSpPr>
+            <a:spLocks noGrp="1"/>
+          </p:cNvSpPr>
+          <p:nvPr>
+            <p:ph idx="1"/>
+          </p:nvPr>
+        </p:nvSpPr>
+        <p:spPr/>
+        <p:txBody>
+          <a:bodyPr/>
+          <a:lstStyle/>
+          <a:p>
+            <a:r>
+              <a:rPr lang="en-AU" dirty="0"/>
+              <a:t>Additional Features:</a:t>
+            </a:r>
+          </a:p>
+          <a:p>
+            <a:pPr lvl="1"/>
+            <a:r>
+              <a:rPr lang="en-AU" dirty="0"/>
+              <a:t>Whether the player will bat feeder model</a:t>
+            </a:r>
+          </a:p>
+          <a:p>
+            <a:pPr lvl="1"/>
+            <a:r>
+              <a:rPr lang="en-AU" dirty="0"/>
+              <a:t>Player actual performance (average runs, average strike rate, average bowls faced etc)</a:t>
+            </a:r>
+          </a:p>
+          <a:p>
+            <a:pPr lvl="1"/>
+            <a:r>
+              <a:rPr lang="en-AU" dirty="0"/>
+              <a:t>Previous season batting points</a:t>
+            </a:r>
+          </a:p>
+          <a:p>
+            <a:pPr lvl="1"/>
+            <a:r>
+              <a:rPr lang="en-AU" dirty="0"/>
+              <a:t>Pre season form? </a:t>
+            </a:r>
+            <a:r>
+              <a:rPr lang="en-AU" dirty="0" err="1"/>
+              <a:t>Cricinfo</a:t>
+            </a:r>
+            <a:r>
+              <a:rPr lang="en-AU" dirty="0"/>
+              <a:t>/ other tournaments</a:t>
+            </a:r>
+          </a:p>
+          <a:p>
+            <a:pPr lvl="1"/>
+            <a:r>
+              <a:rPr lang="en-AU" dirty="0"/>
+              <a:t>Other tournaments flag (e.g. total number of t20 leagues played)</a:t>
+            </a:r>
+          </a:p>
+          <a:p>
+            <a:pPr lvl="1"/>
+            <a:r>
+              <a:rPr lang="en-AU" dirty="0"/>
+              <a:t>Number of games played compared max </a:t>
+            </a:r>
+            <a:r>
+              <a:rPr lang="en-AU"/>
+              <a:t>in team</a:t>
+            </a:r>
+            <a:endParaRPr lang="en-AU" dirty="0"/>
+          </a:p>
+          <a:p>
+            <a:pPr lvl="1"/>
+            <a:endParaRPr lang="en-AU" dirty="0"/>
+          </a:p>
+        </p:txBody>
+      </p:sp>
+    </p:spTree>
+    <p:extLst>
+      <p:ext uri="{BB962C8B-B14F-4D97-AF65-F5344CB8AC3E}">
+        <p14:creationId xmlns:p14="http://schemas.microsoft.com/office/powerpoint/2010/main" val="4290225454"/>
+      </p:ext>
+    </p:extLst>
+  </p:cSld>
+  <p:clrMapOvr>
+    <a:masterClrMapping/>
+  </p:clrMapOvr>
+</p:sld>
+</file>
+
+<file path=ppt/slides/slide9.xml><?xml version="1.0" encoding="utf-8"?>
+<p:sld xmlns:a="http://schemas.openxmlformats.org/drawingml/2006/main" xmlns:r="http://schemas.openxmlformats.org/officeDocument/2006/relationships" xmlns:p="http://schemas.openxmlformats.org/presentationml/2006/main">
+  <p:cSld>
+    <p:spTree>
+      <p:nvGrpSpPr>
+        <p:cNvPr id="1" name="">
+          <a:extLst>
+            <a:ext uri="{FF2B5EF4-FFF2-40B4-BE49-F238E27FC236}">
+              <a16:creationId xmlns:a16="http://schemas.microsoft.com/office/drawing/2014/main" id="{6F694D5A-41B3-0418-A227-B6AC28DC73CC}"/>
+            </a:ext>
+          </a:extLst>
+        </p:cNvPr>
+        <p:cNvGrpSpPr/>
+        <p:nvPr/>
+      </p:nvGrpSpPr>
+      <p:grpSpPr>
+        <a:xfrm>
+          <a:off x="0" y="0"/>
+          <a:ext cx="0" cy="0"/>
+          <a:chOff x="0" y="0"/>
+          <a:chExt cx="0" cy="0"/>
+        </a:xfrm>
+      </p:grpSpPr>
+      <p:sp>
+        <p:nvSpPr>
+          <p:cNvPr id="2" name="Title 1">
+            <a:extLst>
+              <a:ext uri="{FF2B5EF4-FFF2-40B4-BE49-F238E27FC236}">
+                <a16:creationId xmlns:a16="http://schemas.microsoft.com/office/drawing/2014/main" id="{6EE02526-3D7C-1772-95EE-C96EFC1E8596}"/>
+              </a:ext>
+            </a:extLst>
+          </p:cNvPr>
+          <p:cNvSpPr>
+            <a:spLocks noGrp="1"/>
+          </p:cNvSpPr>
+          <p:nvPr>
+            <p:ph type="title"/>
+          </p:nvPr>
+        </p:nvSpPr>
+        <p:spPr/>
+        <p:txBody>
+          <a:bodyPr/>
+          <a:lstStyle/>
+          <a:p>
+            <a:r>
+              <a:rPr lang="en-AU" dirty="0"/>
+              <a:t>Batting Model</a:t>
+            </a:r>
+          </a:p>
+        </p:txBody>
+      </p:sp>
+      <p:sp>
+        <p:nvSpPr>
+          <p:cNvPr id="3" name="Content Placeholder 2">
+            <a:extLst>
+              <a:ext uri="{FF2B5EF4-FFF2-40B4-BE49-F238E27FC236}">
+                <a16:creationId xmlns:a16="http://schemas.microsoft.com/office/drawing/2014/main" id="{C11D1478-2B91-A5BD-6C42-8F2FEAD445BC}"/>
+              </a:ext>
+            </a:extLst>
+          </p:cNvPr>
+          <p:cNvSpPr>
+            <a:spLocks noGrp="1"/>
+          </p:cNvSpPr>
+          <p:nvPr>
+            <p:ph idx="1"/>
+          </p:nvPr>
+        </p:nvSpPr>
+        <p:spPr/>
+        <p:txBody>
+          <a:bodyPr/>
+          <a:lstStyle/>
+          <a:p>
+            <a:r>
+              <a:rPr lang="en-AU" dirty="0"/>
+              <a:t>Problem:</a:t>
+            </a:r>
+          </a:p>
+          <a:p>
+            <a:pPr lvl="1"/>
+            <a:r>
+              <a:rPr lang="en-AU" dirty="0"/>
+              <a:t>Currently can not identify the batting position of the players who do not bat in the game (truncated data) and </a:t>
+            </a:r>
+            <a:r>
+              <a:rPr lang="en-AU" b="1" dirty="0"/>
+              <a:t>therefore the current batting position flags are skewed</a:t>
+            </a:r>
+          </a:p>
+          <a:p>
+            <a:r>
+              <a:rPr lang="en-AU" dirty="0"/>
+              <a:t>Solution: Two part model </a:t>
+            </a:r>
+          </a:p>
+          <a:p>
+            <a:pPr lvl="1"/>
+            <a:r>
+              <a:rPr lang="en-AU" dirty="0"/>
+              <a:t>Expected Batting points = </a:t>
+            </a:r>
+            <a:r>
+              <a:rPr lang="en-AU" dirty="0" err="1"/>
+              <a:t>Pr</a:t>
+            </a:r>
+            <a:r>
+              <a:rPr lang="en-AU" dirty="0"/>
+              <a:t> of batting model x Number of batting points given player bats</a:t>
+            </a:r>
+          </a:p>
+          <a:p>
+            <a:pPr lvl="1"/>
+            <a:endParaRPr lang="en-AU" dirty="0"/>
+          </a:p>
+        </p:txBody>
+      </p:sp>
+    </p:spTree>
+    <p:extLst>
+      <p:ext uri="{BB962C8B-B14F-4D97-AF65-F5344CB8AC3E}">
+        <p14:creationId xmlns:p14="http://schemas.microsoft.com/office/powerpoint/2010/main" val="2530891803"/>
       </p:ext>
     </p:extLst>
   </p:cSld>

</xml_diff>

<commit_message>
base model build flow checked and cleaned
</commit_message>
<xml_diff>
--- a/strategy/BBL Fantasy AI v2 Strategy & Planning.pptx
+++ b/strategy/BBL Fantasy AI v2 Strategy & Planning.pptx
@@ -14,6 +14,7 @@
     <p:sldId id="263" r:id="rId8"/>
     <p:sldId id="262" r:id="rId9"/>
     <p:sldId id="264" r:id="rId10"/>
+    <p:sldId id="265" r:id="rId11"/>
   </p:sldIdLst>
   <p:sldSz cx="12192000" cy="6858000"/>
   <p:notesSz cx="6858000" cy="9144000"/>
@@ -140,6 +141,11 @@
             <p14:sldId id="264"/>
           </p14:sldIdLst>
         </p14:section>
+        <p14:section name="Base Model (Reweight/Rebuild)" id="{684E1DFC-4CB6-4340-901B-D6627A0B3C03}">
+          <p14:sldIdLst>
+            <p14:sldId id="265"/>
+          </p14:sldIdLst>
+        </p14:section>
       </p14:sectionLst>
     </p:ext>
     <p:ext uri="{EFAFB233-063F-42B5-8137-9DF3F51BA10A}">
@@ -160,269 +166,117 @@
 </p:presentation>
 </file>
 
-<file path=ppt/revisionInfo.xml><?xml version="1.0" encoding="utf-8"?>
-<p1510:revInfo xmlns:a="http://schemas.openxmlformats.org/drawingml/2006/main" xmlns:r="http://schemas.openxmlformats.org/officeDocument/2006/relationships" xmlns:p1510="http://schemas.microsoft.com/office/powerpoint/2015/10/main">
-  <p1510:revLst>
-    <p1510:client id="{B4EA8C78-5629-4CB8-9794-5E1861B660A8}" v="3" dt="2025-06-15T12:39:55.563"/>
-  </p1510:revLst>
-</p1510:revInfo>
-</file>
-
 <file path=ppt/changesInfos/changesInfo1.xml><?xml version="1.0" encoding="utf-8"?>
 <pc:chgInfo xmlns:a="http://schemas.openxmlformats.org/drawingml/2006/main" xmlns:r="http://schemas.openxmlformats.org/officeDocument/2006/relationships" xmlns:ac="http://schemas.microsoft.com/office/drawing/2013/main/command" xmlns:pc="http://schemas.microsoft.com/office/powerpoint/2013/main/command">
   <pc:docChgLst>
-    <pc:chgData name="Dilan De Silva" userId="579b606d6e18a4ed" providerId="LiveId" clId="{B4EA8C78-5629-4CB8-9794-5E1861B660A8}"/>
-    <pc:docChg chg="undo custSel addSld delSld modSld sldOrd addSection modSection">
-      <pc:chgData name="Dilan De Silva" userId="579b606d6e18a4ed" providerId="LiveId" clId="{B4EA8C78-5629-4CB8-9794-5E1861B660A8}" dt="2025-06-15T12:50:16.556" v="1890" actId="20577"/>
+    <pc:chgData name="Dilan De Silva" userId="579b606d6e18a4ed" providerId="LiveId" clId="{55D98E11-54C8-4694-9916-6163FE05F5A8}"/>
+    <pc:docChg chg="custSel addSld modSld addSection modSection">
+      <pc:chgData name="Dilan De Silva" userId="579b606d6e18a4ed" providerId="LiveId" clId="{55D98E11-54C8-4694-9916-6163FE05F5A8}" dt="2025-11-11T13:25:10.101" v="68" actId="14100"/>
       <pc:docMkLst>
         <pc:docMk/>
       </pc:docMkLst>
-      <pc:sldChg chg="modSp mod">
-        <pc:chgData name="Dilan De Silva" userId="579b606d6e18a4ed" providerId="LiveId" clId="{B4EA8C78-5629-4CB8-9794-5E1861B660A8}" dt="2025-06-15T12:45:43.389" v="1685" actId="20577"/>
+      <pc:sldChg chg="addSp delSp modSp add mod">
+        <pc:chgData name="Dilan De Silva" userId="579b606d6e18a4ed" providerId="LiveId" clId="{55D98E11-54C8-4694-9916-6163FE05F5A8}" dt="2025-11-11T13:25:10.101" v="68" actId="14100"/>
         <pc:sldMkLst>
           <pc:docMk/>
-          <pc:sldMk cId="1969437762" sldId="257"/>
+          <pc:sldMk cId="778238734" sldId="265"/>
         </pc:sldMkLst>
         <pc:spChg chg="mod">
-          <ac:chgData name="Dilan De Silva" userId="579b606d6e18a4ed" providerId="LiveId" clId="{B4EA8C78-5629-4CB8-9794-5E1861B660A8}" dt="2025-06-15T12:45:43.389" v="1685" actId="20577"/>
+          <ac:chgData name="Dilan De Silva" userId="579b606d6e18a4ed" providerId="LiveId" clId="{55D98E11-54C8-4694-9916-6163FE05F5A8}" dt="2025-11-11T12:52:47.369" v="17" actId="20577"/>
           <ac:spMkLst>
             <pc:docMk/>
-            <pc:sldMk cId="1969437762" sldId="257"/>
-            <ac:spMk id="5" creationId="{80194462-8D64-20D4-246C-4E22D630ECE3}"/>
+            <pc:sldMk cId="778238734" sldId="265"/>
+            <ac:spMk id="2" creationId="{6247B832-A404-856B-5B15-498B899D8D57}"/>
           </ac:spMkLst>
         </pc:spChg>
-      </pc:sldChg>
-      <pc:sldChg chg="addSp delSp modSp new mod setBg">
-        <pc:chgData name="Dilan De Silva" userId="579b606d6e18a4ed" providerId="LiveId" clId="{B4EA8C78-5629-4CB8-9794-5E1861B660A8}" dt="2025-06-04T11:50:54.585" v="325" actId="26606"/>
-        <pc:sldMkLst>
-          <pc:docMk/>
-          <pc:sldMk cId="1471337115" sldId="258"/>
-        </pc:sldMkLst>
-        <pc:spChg chg="mod">
-          <ac:chgData name="Dilan De Silva" userId="579b606d6e18a4ed" providerId="LiveId" clId="{B4EA8C78-5629-4CB8-9794-5E1861B660A8}" dt="2025-06-04T11:50:54.585" v="325" actId="26606"/>
+        <pc:spChg chg="del">
+          <ac:chgData name="Dilan De Silva" userId="579b606d6e18a4ed" providerId="LiveId" clId="{55D98E11-54C8-4694-9916-6163FE05F5A8}" dt="2025-11-11T12:52:42.975" v="7" actId="478"/>
           <ac:spMkLst>
             <pc:docMk/>
-            <pc:sldMk cId="1471337115" sldId="258"/>
-            <ac:spMk id="2" creationId="{DCD29F56-BA59-FAF6-79C8-A248333FA0BB}"/>
+            <pc:sldMk cId="778238734" sldId="265"/>
+            <ac:spMk id="3" creationId="{5D6B57CB-75A0-BD7E-564B-DF6170A9B175}"/>
           </ac:spMkLst>
         </pc:spChg>
-        <pc:spChg chg="mod">
-          <ac:chgData name="Dilan De Silva" userId="579b606d6e18a4ed" providerId="LiveId" clId="{B4EA8C78-5629-4CB8-9794-5E1861B660A8}" dt="2025-06-04T11:50:54.585" v="325" actId="26606"/>
+        <pc:spChg chg="add del mod">
+          <ac:chgData name="Dilan De Silva" userId="579b606d6e18a4ed" providerId="LiveId" clId="{55D98E11-54C8-4694-9916-6163FE05F5A8}" dt="2025-11-11T12:52:50.569" v="18" actId="478"/>
           <ac:spMkLst>
             <pc:docMk/>
-            <pc:sldMk cId="1471337115" sldId="258"/>
-            <ac:spMk id="3" creationId="{6AA0120E-7982-2BE3-3FA1-358B5018E8F7}"/>
+            <pc:sldMk cId="778238734" sldId="265"/>
+            <ac:spMk id="5" creationId="{C961A8EB-168C-B1E1-9AFF-6D466367A754}"/>
           </ac:spMkLst>
         </pc:spChg>
-      </pc:sldChg>
-      <pc:sldChg chg="addSp delSp modSp add mod setBg">
-        <pc:chgData name="Dilan De Silva" userId="579b606d6e18a4ed" providerId="LiveId" clId="{B4EA8C78-5629-4CB8-9794-5E1861B660A8}" dt="2025-06-04T11:43:17.177" v="278" actId="14100"/>
-        <pc:sldMkLst>
-          <pc:docMk/>
-          <pc:sldMk cId="3689564591" sldId="259"/>
-        </pc:sldMkLst>
-        <pc:spChg chg="mod">
-          <ac:chgData name="Dilan De Silva" userId="579b606d6e18a4ed" providerId="LiveId" clId="{B4EA8C78-5629-4CB8-9794-5E1861B660A8}" dt="2025-06-04T11:41:55.682" v="266" actId="120"/>
-          <ac:spMkLst>
-            <pc:docMk/>
-            <pc:sldMk cId="3689564591" sldId="259"/>
-            <ac:spMk id="2" creationId="{634F4B6D-B859-81E2-585F-115E16516769}"/>
-          </ac:spMkLst>
-        </pc:spChg>
-        <pc:spChg chg="add">
-          <ac:chgData name="Dilan De Silva" userId="579b606d6e18a4ed" providerId="LiveId" clId="{B4EA8C78-5629-4CB8-9794-5E1861B660A8}" dt="2025-06-04T11:40:49" v="259" actId="26606"/>
-          <ac:spMkLst>
-            <pc:docMk/>
-            <pc:sldMk cId="3689564591" sldId="259"/>
-            <ac:spMk id="12" creationId="{A4AC5506-6312-4701-8D3C-40187889A947}"/>
-          </ac:spMkLst>
-        </pc:spChg>
-        <pc:picChg chg="add mod">
-          <ac:chgData name="Dilan De Silva" userId="579b606d6e18a4ed" providerId="LiveId" clId="{B4EA8C78-5629-4CB8-9794-5E1861B660A8}" dt="2025-06-04T11:42:11.719" v="269" actId="1076"/>
+        <pc:picChg chg="add del mod">
+          <ac:chgData name="Dilan De Silva" userId="579b606d6e18a4ed" providerId="LiveId" clId="{55D98E11-54C8-4694-9916-6163FE05F5A8}" dt="2025-11-11T13:22:37.209" v="51" actId="478"/>
           <ac:picMkLst>
             <pc:docMk/>
-            <pc:sldMk cId="3689564591" sldId="259"/>
-            <ac:picMk id="7" creationId="{A158E25A-46C3-E912-DFCF-F3A95F3F1F98}"/>
+            <pc:sldMk cId="778238734" sldId="265"/>
+            <ac:picMk id="7" creationId="{9C007BD9-6495-7865-4113-0D957F7D713C}"/>
           </ac:picMkLst>
         </pc:picChg>
-        <pc:picChg chg="add mod modCrop">
-          <ac:chgData name="Dilan De Silva" userId="579b606d6e18a4ed" providerId="LiveId" clId="{B4EA8C78-5629-4CB8-9794-5E1861B660A8}" dt="2025-06-04T11:43:17.177" v="278" actId="14100"/>
+        <pc:picChg chg="add del mod">
+          <ac:chgData name="Dilan De Silva" userId="579b606d6e18a4ed" providerId="LiveId" clId="{55D98E11-54C8-4694-9916-6163FE05F5A8}" dt="2025-11-11T13:22:37.703" v="52" actId="478"/>
           <ac:picMkLst>
             <pc:docMk/>
-            <pc:sldMk cId="3689564591" sldId="259"/>
-            <ac:picMk id="9" creationId="{18DAAFF2-7EB9-DAD9-DE9F-137C76ED5049}"/>
+            <pc:sldMk cId="778238734" sldId="265"/>
+            <ac:picMk id="9" creationId="{5BF8AC2C-197C-9889-B1AA-8815E96F3EA4}"/>
+          </ac:picMkLst>
+        </pc:picChg>
+        <pc:picChg chg="add del mod">
+          <ac:chgData name="Dilan De Silva" userId="579b606d6e18a4ed" providerId="LiveId" clId="{55D98E11-54C8-4694-9916-6163FE05F5A8}" dt="2025-11-11T13:22:35.833" v="49" actId="478"/>
+          <ac:picMkLst>
+            <pc:docMk/>
+            <pc:sldMk cId="778238734" sldId="265"/>
+            <ac:picMk id="11" creationId="{472B34DC-282B-DE33-9234-7C8CA1B48499}"/>
+          </ac:picMkLst>
+        </pc:picChg>
+        <pc:picChg chg="add del mod">
+          <ac:chgData name="Dilan De Silva" userId="579b606d6e18a4ed" providerId="LiveId" clId="{55D98E11-54C8-4694-9916-6163FE05F5A8}" dt="2025-11-11T13:22:36.383" v="50" actId="478"/>
+          <ac:picMkLst>
+            <pc:docMk/>
+            <pc:sldMk cId="778238734" sldId="265"/>
+            <ac:picMk id="13" creationId="{186C2D99-1DD7-B0A7-8EE0-06775064C0F5}"/>
           </ac:picMkLst>
         </pc:picChg>
         <pc:picChg chg="add mod">
-          <ac:chgData name="Dilan De Silva" userId="579b606d6e18a4ed" providerId="LiveId" clId="{B4EA8C78-5629-4CB8-9794-5E1861B660A8}" dt="2025-06-04T11:42:54.622" v="274" actId="1076"/>
+          <ac:chgData name="Dilan De Silva" userId="579b606d6e18a4ed" providerId="LiveId" clId="{55D98E11-54C8-4694-9916-6163FE05F5A8}" dt="2025-11-11T13:23:30.371" v="54" actId="1076"/>
           <ac:picMkLst>
             <pc:docMk/>
-            <pc:sldMk cId="3689564591" sldId="259"/>
-            <ac:picMk id="11" creationId="{13BF7B19-1051-10FA-A909-0441C239D5AE}"/>
-          </ac:picMkLst>
-        </pc:picChg>
-      </pc:sldChg>
-      <pc:sldChg chg="delSp add del setBg delDesignElem">
-        <pc:chgData name="Dilan De Silva" userId="579b606d6e18a4ed" providerId="LiveId" clId="{B4EA8C78-5629-4CB8-9794-5E1861B660A8}" dt="2025-06-04T11:43:28.091" v="281" actId="47"/>
-        <pc:sldMkLst>
-          <pc:docMk/>
-          <pc:sldMk cId="3635980319" sldId="260"/>
-        </pc:sldMkLst>
-      </pc:sldChg>
-      <pc:sldChg chg="addSp delSp modSp add mod setBg delDesignElem">
-        <pc:chgData name="Dilan De Silva" userId="579b606d6e18a4ed" providerId="LiveId" clId="{B4EA8C78-5629-4CB8-9794-5E1861B660A8}" dt="2025-06-04T11:46:42.393" v="308" actId="14100"/>
-        <pc:sldMkLst>
-          <pc:docMk/>
-          <pc:sldMk cId="4008747595" sldId="260"/>
-        </pc:sldMkLst>
-        <pc:spChg chg="mod">
-          <ac:chgData name="Dilan De Silva" userId="579b606d6e18a4ed" providerId="LiveId" clId="{B4EA8C78-5629-4CB8-9794-5E1861B660A8}" dt="2025-06-04T11:45:12.160" v="298" actId="120"/>
-          <ac:spMkLst>
-            <pc:docMk/>
-            <pc:sldMk cId="4008747595" sldId="260"/>
-            <ac:spMk id="2" creationId="{BEED9832-E790-FEA8-6024-89D616225AB2}"/>
-          </ac:spMkLst>
-        </pc:spChg>
-        <pc:spChg chg="add">
-          <ac:chgData name="Dilan De Silva" userId="579b606d6e18a4ed" providerId="LiveId" clId="{B4EA8C78-5629-4CB8-9794-5E1861B660A8}" dt="2025-06-04T11:45:01.674" v="295" actId="26606"/>
-          <ac:spMkLst>
-            <pc:docMk/>
-            <pc:sldMk cId="4008747595" sldId="260"/>
-            <ac:spMk id="6" creationId="{A4AC5506-6312-4701-8D3C-40187889A947}"/>
-          </ac:spMkLst>
-        </pc:spChg>
-        <pc:picChg chg="add mod">
-          <ac:chgData name="Dilan De Silva" userId="579b606d6e18a4ed" providerId="LiveId" clId="{B4EA8C78-5629-4CB8-9794-5E1861B660A8}" dt="2025-06-04T11:45:07.352" v="297" actId="1076"/>
-          <ac:picMkLst>
-            <pc:docMk/>
-            <pc:sldMk cId="4008747595" sldId="260"/>
-            <ac:picMk id="4" creationId="{46ADA508-1956-0619-0812-604D6A80AA3D}"/>
+            <pc:sldMk cId="778238734" sldId="265"/>
+            <ac:picMk id="15" creationId="{276CF6FE-4742-1F80-08A7-4AEFC184A94D}"/>
           </ac:picMkLst>
         </pc:picChg>
         <pc:picChg chg="add mod">
-          <ac:chgData name="Dilan De Silva" userId="579b606d6e18a4ed" providerId="LiveId" clId="{B4EA8C78-5629-4CB8-9794-5E1861B660A8}" dt="2025-06-04T11:45:35.399" v="301" actId="1076"/>
+          <ac:chgData name="Dilan De Silva" userId="579b606d6e18a4ed" providerId="LiveId" clId="{55D98E11-54C8-4694-9916-6163FE05F5A8}" dt="2025-11-11T13:24:16.491" v="61" actId="14100"/>
           <ac:picMkLst>
             <pc:docMk/>
-            <pc:sldMk cId="4008747595" sldId="260"/>
-            <ac:picMk id="8" creationId="{21BBA2F4-FEC3-3E5E-40AF-06BB3E73DA43}"/>
-          </ac:picMkLst>
-        </pc:picChg>
-        <pc:picChg chg="add mod modCrop">
-          <ac:chgData name="Dilan De Silva" userId="579b606d6e18a4ed" providerId="LiveId" clId="{B4EA8C78-5629-4CB8-9794-5E1861B660A8}" dt="2025-06-04T11:46:42.393" v="308" actId="14100"/>
-          <ac:picMkLst>
-            <pc:docMk/>
-            <pc:sldMk cId="4008747595" sldId="260"/>
-            <ac:picMk id="13" creationId="{F2F1FC21-77D3-F860-F9D5-C4F4D504C51A}"/>
-          </ac:picMkLst>
-        </pc:picChg>
-      </pc:sldChg>
-      <pc:sldChg chg="addSp delSp modSp add mod ord setBg delDesignElem">
-        <pc:chgData name="Dilan De Silva" userId="579b606d6e18a4ed" providerId="LiveId" clId="{B4EA8C78-5629-4CB8-9794-5E1861B660A8}" dt="2025-06-15T12:27:12.774" v="550"/>
-        <pc:sldMkLst>
-          <pc:docMk/>
-          <pc:sldMk cId="2965452809" sldId="261"/>
-        </pc:sldMkLst>
-        <pc:spChg chg="mod">
-          <ac:chgData name="Dilan De Silva" userId="579b606d6e18a4ed" providerId="LiveId" clId="{B4EA8C78-5629-4CB8-9794-5E1861B660A8}" dt="2025-06-04T11:47:00.578" v="316" actId="120"/>
-          <ac:spMkLst>
-            <pc:docMk/>
-            <pc:sldMk cId="2965452809" sldId="261"/>
-            <ac:spMk id="2" creationId="{C5482A9D-F23B-6B0C-5B36-B51009F97FF3}"/>
-          </ac:spMkLst>
-        </pc:spChg>
-        <pc:spChg chg="add">
-          <ac:chgData name="Dilan De Silva" userId="579b606d6e18a4ed" providerId="LiveId" clId="{B4EA8C78-5629-4CB8-9794-5E1861B660A8}" dt="2025-06-04T11:46:56.629" v="313" actId="26606"/>
-          <ac:spMkLst>
-            <pc:docMk/>
-            <pc:sldMk cId="2965452809" sldId="261"/>
-            <ac:spMk id="9" creationId="{A4AC5506-6312-4701-8D3C-40187889A947}"/>
-          </ac:spMkLst>
-        </pc:spChg>
-        <pc:picChg chg="add mod">
-          <ac:chgData name="Dilan De Silva" userId="579b606d6e18a4ed" providerId="LiveId" clId="{B4EA8C78-5629-4CB8-9794-5E1861B660A8}" dt="2025-06-04T11:51:31.738" v="329" actId="14100"/>
-          <ac:picMkLst>
-            <pc:docMk/>
-            <pc:sldMk cId="2965452809" sldId="261"/>
-            <ac:picMk id="5" creationId="{7E98FE36-BF12-46D4-2CD2-33F841A9E8A2}"/>
+            <pc:sldMk cId="778238734" sldId="265"/>
+            <ac:picMk id="17" creationId="{4D15F185-3660-C02F-48C5-4C03BA4FA445}"/>
           </ac:picMkLst>
         </pc:picChg>
         <pc:picChg chg="add mod">
-          <ac:chgData name="Dilan De Silva" userId="579b606d6e18a4ed" providerId="LiveId" clId="{B4EA8C78-5629-4CB8-9794-5E1861B660A8}" dt="2025-06-04T11:51:56.207" v="331" actId="1076"/>
+          <ac:chgData name="Dilan De Silva" userId="579b606d6e18a4ed" providerId="LiveId" clId="{55D98E11-54C8-4694-9916-6163FE05F5A8}" dt="2025-11-11T13:24:13.554" v="60" actId="1076"/>
           <ac:picMkLst>
             <pc:docMk/>
-            <pc:sldMk cId="2965452809" sldId="261"/>
-            <ac:picMk id="10" creationId="{B526E69E-5BDE-F210-2D61-FF8FD171BCF2}"/>
+            <pc:sldMk cId="778238734" sldId="265"/>
+            <ac:picMk id="19" creationId="{49124439-DA01-4E1E-CADA-6BCEB6BE6CEF}"/>
           </ac:picMkLst>
         </pc:picChg>
-        <pc:picChg chg="add mod modCrop">
-          <ac:chgData name="Dilan De Silva" userId="579b606d6e18a4ed" providerId="LiveId" clId="{B4EA8C78-5629-4CB8-9794-5E1861B660A8}" dt="2025-06-04T11:52:54.903" v="340" actId="14100"/>
+        <pc:picChg chg="add mod">
+          <ac:chgData name="Dilan De Silva" userId="579b606d6e18a4ed" providerId="LiveId" clId="{55D98E11-54C8-4694-9916-6163FE05F5A8}" dt="2025-11-11T13:24:46.404" v="64" actId="1076"/>
           <ac:picMkLst>
             <pc:docMk/>
-            <pc:sldMk cId="2965452809" sldId="261"/>
-            <ac:picMk id="12" creationId="{342A7AB9-6630-4F9C-7639-DBB9443F9BE2}"/>
+            <pc:sldMk cId="778238734" sldId="265"/>
+            <ac:picMk id="21" creationId="{FA88AEEE-5EBD-3E40-AE50-BBF77EFA8571}"/>
           </ac:picMkLst>
         </pc:picChg>
-      </pc:sldChg>
-      <pc:sldChg chg="modSp add mod ord">
-        <pc:chgData name="Dilan De Silva" userId="579b606d6e18a4ed" providerId="LiveId" clId="{B4EA8C78-5629-4CB8-9794-5E1861B660A8}" dt="2025-06-15T12:50:16.556" v="1890" actId="20577"/>
-        <pc:sldMkLst>
-          <pc:docMk/>
-          <pc:sldMk cId="4290225454" sldId="262"/>
-        </pc:sldMkLst>
-        <pc:spChg chg="mod">
-          <ac:chgData name="Dilan De Silva" userId="579b606d6e18a4ed" providerId="LiveId" clId="{B4EA8C78-5629-4CB8-9794-5E1861B660A8}" dt="2025-06-15T12:25:10.942" v="373" actId="20577"/>
-          <ac:spMkLst>
+        <pc:picChg chg="add mod">
+          <ac:chgData name="Dilan De Silva" userId="579b606d6e18a4ed" providerId="LiveId" clId="{55D98E11-54C8-4694-9916-6163FE05F5A8}" dt="2025-11-11T13:25:10.101" v="68" actId="14100"/>
+          <ac:picMkLst>
             <pc:docMk/>
-            <pc:sldMk cId="4290225454" sldId="262"/>
-            <ac:spMk id="2" creationId="{38189B02-1CB5-3025-7E40-16AC7F9CC97E}"/>
-          </ac:spMkLst>
-        </pc:spChg>
-        <pc:spChg chg="mod">
-          <ac:chgData name="Dilan De Silva" userId="579b606d6e18a4ed" providerId="LiveId" clId="{B4EA8C78-5629-4CB8-9794-5E1861B660A8}" dt="2025-06-15T12:50:16.556" v="1890" actId="20577"/>
-          <ac:spMkLst>
-            <pc:docMk/>
-            <pc:sldMk cId="4290225454" sldId="262"/>
-            <ac:spMk id="3" creationId="{74486134-C9F0-19C3-2C44-4B0A4DBC5B91}"/>
-          </ac:spMkLst>
-        </pc:spChg>
-      </pc:sldChg>
-      <pc:sldChg chg="modSp add mod ord">
-        <pc:chgData name="Dilan De Silva" userId="579b606d6e18a4ed" providerId="LiveId" clId="{B4EA8C78-5629-4CB8-9794-5E1861B660A8}" dt="2025-06-15T12:33:19.261" v="878" actId="20577"/>
-        <pc:sldMkLst>
-          <pc:docMk/>
-          <pc:sldMk cId="3167652951" sldId="263"/>
-        </pc:sldMkLst>
-        <pc:spChg chg="mod">
-          <ac:chgData name="Dilan De Silva" userId="579b606d6e18a4ed" providerId="LiveId" clId="{B4EA8C78-5629-4CB8-9794-5E1861B660A8}" dt="2025-06-15T12:27:25.575" v="573" actId="20577"/>
-          <ac:spMkLst>
-            <pc:docMk/>
-            <pc:sldMk cId="3167652951" sldId="263"/>
-            <ac:spMk id="2" creationId="{81D8804F-5E8C-1D4B-605A-E3F1492FD67A}"/>
-          </ac:spMkLst>
-        </pc:spChg>
-        <pc:spChg chg="mod">
-          <ac:chgData name="Dilan De Silva" userId="579b606d6e18a4ed" providerId="LiveId" clId="{B4EA8C78-5629-4CB8-9794-5E1861B660A8}" dt="2025-06-15T12:33:19.261" v="878" actId="20577"/>
-          <ac:spMkLst>
-            <pc:docMk/>
-            <pc:sldMk cId="3167652951" sldId="263"/>
-            <ac:spMk id="3" creationId="{BBDF9F51-6BFC-E765-0305-5CD19BCBA5E1}"/>
-          </ac:spMkLst>
-        </pc:spChg>
-      </pc:sldChg>
-      <pc:sldChg chg="modSp add mod">
-        <pc:chgData name="Dilan De Silva" userId="579b606d6e18a4ed" providerId="LiveId" clId="{B4EA8C78-5629-4CB8-9794-5E1861B660A8}" dt="2025-06-15T12:42:45.144" v="1575" actId="20577"/>
-        <pc:sldMkLst>
-          <pc:docMk/>
-          <pc:sldMk cId="2530891803" sldId="264"/>
-        </pc:sldMkLst>
-        <pc:spChg chg="mod">
-          <ac:chgData name="Dilan De Silva" userId="579b606d6e18a4ed" providerId="LiveId" clId="{B4EA8C78-5629-4CB8-9794-5E1861B660A8}" dt="2025-06-15T12:42:45.144" v="1575" actId="20577"/>
-          <ac:spMkLst>
-            <pc:docMk/>
-            <pc:sldMk cId="2530891803" sldId="264"/>
-            <ac:spMk id="3" creationId="{C11D1478-2B91-A5BD-6C42-8F2FEAD445BC}"/>
-          </ac:spMkLst>
-        </pc:spChg>
+            <pc:sldMk cId="778238734" sldId="265"/>
+            <ac:picMk id="23" creationId="{CBB5288E-E7D3-8D27-8717-C302E606D31F}"/>
+          </ac:picMkLst>
+        </pc:picChg>
       </pc:sldChg>
     </pc:docChg>
   </pc:docChgLst>
@@ -578,7 +432,7 @@
           <a:p>
             <a:fld id="{2D73D9AC-D42E-4620-8482-0397FE94AE8B}" type="datetimeFigureOut">
               <a:rPr lang="en-AU" smtClean="0"/>
-              <a:t>15/06/2025</a:t>
+              <a:t>11/11/2025</a:t>
             </a:fld>
             <a:endParaRPr lang="en-AU"/>
           </a:p>
@@ -778,7 +632,7 @@
           <a:p>
             <a:fld id="{2D73D9AC-D42E-4620-8482-0397FE94AE8B}" type="datetimeFigureOut">
               <a:rPr lang="en-AU" smtClean="0"/>
-              <a:t>15/06/2025</a:t>
+              <a:t>11/11/2025</a:t>
             </a:fld>
             <a:endParaRPr lang="en-AU"/>
           </a:p>
@@ -988,7 +842,7 @@
           <a:p>
             <a:fld id="{2D73D9AC-D42E-4620-8482-0397FE94AE8B}" type="datetimeFigureOut">
               <a:rPr lang="en-AU" smtClean="0"/>
-              <a:t>15/06/2025</a:t>
+              <a:t>11/11/2025</a:t>
             </a:fld>
             <a:endParaRPr lang="en-AU"/>
           </a:p>
@@ -1188,7 +1042,7 @@
           <a:p>
             <a:fld id="{2D73D9AC-D42E-4620-8482-0397FE94AE8B}" type="datetimeFigureOut">
               <a:rPr lang="en-AU" smtClean="0"/>
-              <a:t>15/06/2025</a:t>
+              <a:t>11/11/2025</a:t>
             </a:fld>
             <a:endParaRPr lang="en-AU"/>
           </a:p>
@@ -1464,7 +1318,7 @@
           <a:p>
             <a:fld id="{2D73D9AC-D42E-4620-8482-0397FE94AE8B}" type="datetimeFigureOut">
               <a:rPr lang="en-AU" smtClean="0"/>
-              <a:t>15/06/2025</a:t>
+              <a:t>11/11/2025</a:t>
             </a:fld>
             <a:endParaRPr lang="en-AU"/>
           </a:p>
@@ -1732,7 +1586,7 @@
           <a:p>
             <a:fld id="{2D73D9AC-D42E-4620-8482-0397FE94AE8B}" type="datetimeFigureOut">
               <a:rPr lang="en-AU" smtClean="0"/>
-              <a:t>15/06/2025</a:t>
+              <a:t>11/11/2025</a:t>
             </a:fld>
             <a:endParaRPr lang="en-AU"/>
           </a:p>
@@ -2147,7 +2001,7 @@
           <a:p>
             <a:fld id="{2D73D9AC-D42E-4620-8482-0397FE94AE8B}" type="datetimeFigureOut">
               <a:rPr lang="en-AU" smtClean="0"/>
-              <a:t>15/06/2025</a:t>
+              <a:t>11/11/2025</a:t>
             </a:fld>
             <a:endParaRPr lang="en-AU"/>
           </a:p>
@@ -2289,7 +2143,7 @@
           <a:p>
             <a:fld id="{2D73D9AC-D42E-4620-8482-0397FE94AE8B}" type="datetimeFigureOut">
               <a:rPr lang="en-AU" smtClean="0"/>
-              <a:t>15/06/2025</a:t>
+              <a:t>11/11/2025</a:t>
             </a:fld>
             <a:endParaRPr lang="en-AU"/>
           </a:p>
@@ -2402,7 +2256,7 @@
           <a:p>
             <a:fld id="{2D73D9AC-D42E-4620-8482-0397FE94AE8B}" type="datetimeFigureOut">
               <a:rPr lang="en-AU" smtClean="0"/>
-              <a:t>15/06/2025</a:t>
+              <a:t>11/11/2025</a:t>
             </a:fld>
             <a:endParaRPr lang="en-AU"/>
           </a:p>
@@ -2715,7 +2569,7 @@
           <a:p>
             <a:fld id="{2D73D9AC-D42E-4620-8482-0397FE94AE8B}" type="datetimeFigureOut">
               <a:rPr lang="en-AU" smtClean="0"/>
-              <a:t>15/06/2025</a:t>
+              <a:t>11/11/2025</a:t>
             </a:fld>
             <a:endParaRPr lang="en-AU"/>
           </a:p>
@@ -3004,7 +2858,7 @@
           <a:p>
             <a:fld id="{2D73D9AC-D42E-4620-8482-0397FE94AE8B}" type="datetimeFigureOut">
               <a:rPr lang="en-AU" smtClean="0"/>
-              <a:t>15/06/2025</a:t>
+              <a:t>11/11/2025</a:t>
             </a:fld>
             <a:endParaRPr lang="en-AU"/>
           </a:p>
@@ -3247,7 +3101,7 @@
           <a:p>
             <a:fld id="{2D73D9AC-D42E-4620-8482-0397FE94AE8B}" type="datetimeFigureOut">
               <a:rPr lang="en-AU" smtClean="0"/>
-              <a:t>15/06/2025</a:t>
+              <a:t>11/11/2025</a:t>
             </a:fld>
             <a:endParaRPr lang="en-AU"/>
           </a:p>
@@ -3721,6 +3575,220 @@
     <p:extLst>
       <p:ext uri="{BB962C8B-B14F-4D97-AF65-F5344CB8AC3E}">
         <p14:creationId xmlns:p14="http://schemas.microsoft.com/office/powerpoint/2010/main" val="527868580"/>
+      </p:ext>
+    </p:extLst>
+  </p:cSld>
+  <p:clrMapOvr>
+    <a:masterClrMapping/>
+  </p:clrMapOvr>
+</p:sld>
+</file>
+
+<file path=ppt/slides/slide10.xml><?xml version="1.0" encoding="utf-8"?>
+<p:sld xmlns:a="http://schemas.openxmlformats.org/drawingml/2006/main" xmlns:r="http://schemas.openxmlformats.org/officeDocument/2006/relationships" xmlns:p="http://schemas.openxmlformats.org/presentationml/2006/main">
+  <p:cSld>
+    <p:spTree>
+      <p:nvGrpSpPr>
+        <p:cNvPr id="1" name="">
+          <a:extLst>
+            <a:ext uri="{FF2B5EF4-FFF2-40B4-BE49-F238E27FC236}">
+              <a16:creationId xmlns:a16="http://schemas.microsoft.com/office/drawing/2014/main" id="{C56DF11E-9F4E-731D-F4D4-DC85B48237E3}"/>
+            </a:ext>
+          </a:extLst>
+        </p:cNvPr>
+        <p:cNvGrpSpPr/>
+        <p:nvPr/>
+      </p:nvGrpSpPr>
+      <p:grpSpPr>
+        <a:xfrm>
+          <a:off x="0" y="0"/>
+          <a:ext cx="0" cy="0"/>
+          <a:chOff x="0" y="0"/>
+          <a:chExt cx="0" cy="0"/>
+        </a:xfrm>
+      </p:grpSpPr>
+      <p:sp>
+        <p:nvSpPr>
+          <p:cNvPr id="2" name="Title 1">
+            <a:extLst>
+              <a:ext uri="{FF2B5EF4-FFF2-40B4-BE49-F238E27FC236}">
+                <a16:creationId xmlns:a16="http://schemas.microsoft.com/office/drawing/2014/main" id="{6247B832-A404-856B-5B15-498B899D8D57}"/>
+              </a:ext>
+            </a:extLst>
+          </p:cNvPr>
+          <p:cNvSpPr>
+            <a:spLocks noGrp="1"/>
+          </p:cNvSpPr>
+          <p:nvPr>
+            <p:ph type="title"/>
+          </p:nvPr>
+        </p:nvSpPr>
+        <p:spPr/>
+        <p:txBody>
+          <a:bodyPr/>
+          <a:lstStyle/>
+          <a:p>
+            <a:r>
+              <a:rPr lang="en-AU" dirty="0"/>
+              <a:t>RF Model 1</a:t>
+            </a:r>
+          </a:p>
+        </p:txBody>
+      </p:sp>
+      <p:pic>
+        <p:nvPicPr>
+          <p:cNvPr id="15" name="Picture 14">
+            <a:extLst>
+              <a:ext uri="{FF2B5EF4-FFF2-40B4-BE49-F238E27FC236}">
+                <a16:creationId xmlns:a16="http://schemas.microsoft.com/office/drawing/2014/main" id="{276CF6FE-4742-1F80-08A7-4AEFC184A94D}"/>
+              </a:ext>
+            </a:extLst>
+          </p:cNvPr>
+          <p:cNvPicPr>
+            <a:picLocks noChangeAspect="1"/>
+          </p:cNvPicPr>
+          <p:nvPr/>
+        </p:nvPicPr>
+        <p:blipFill>
+          <a:blip r:embed="rId2"/>
+          <a:stretch>
+            <a:fillRect/>
+          </a:stretch>
+        </p:blipFill>
+        <p:spPr>
+          <a:xfrm>
+            <a:off x="916063" y="1581135"/>
+            <a:ext cx="5487166" cy="219106"/>
+          </a:xfrm>
+          <a:prstGeom prst="rect">
+            <a:avLst/>
+          </a:prstGeom>
+        </p:spPr>
+      </p:pic>
+      <p:pic>
+        <p:nvPicPr>
+          <p:cNvPr id="17" name="Picture 16">
+            <a:extLst>
+              <a:ext uri="{FF2B5EF4-FFF2-40B4-BE49-F238E27FC236}">
+                <a16:creationId xmlns:a16="http://schemas.microsoft.com/office/drawing/2014/main" id="{4D15F185-3660-C02F-48C5-4C03BA4FA445}"/>
+              </a:ext>
+            </a:extLst>
+          </p:cNvPr>
+          <p:cNvPicPr>
+            <a:picLocks noChangeAspect="1"/>
+          </p:cNvPicPr>
+          <p:nvPr/>
+        </p:nvPicPr>
+        <p:blipFill>
+          <a:blip r:embed="rId3"/>
+          <a:stretch>
+            <a:fillRect/>
+          </a:stretch>
+        </p:blipFill>
+        <p:spPr>
+          <a:xfrm>
+            <a:off x="9897352" y="0"/>
+            <a:ext cx="2294648" cy="3704613"/>
+          </a:xfrm>
+          <a:prstGeom prst="rect">
+            <a:avLst/>
+          </a:prstGeom>
+        </p:spPr>
+      </p:pic>
+      <p:pic>
+        <p:nvPicPr>
+          <p:cNvPr id="19" name="Picture 18">
+            <a:extLst>
+              <a:ext uri="{FF2B5EF4-FFF2-40B4-BE49-F238E27FC236}">
+                <a16:creationId xmlns:a16="http://schemas.microsoft.com/office/drawing/2014/main" id="{49124439-DA01-4E1E-CADA-6BCEB6BE6CEF}"/>
+              </a:ext>
+            </a:extLst>
+          </p:cNvPr>
+          <p:cNvPicPr>
+            <a:picLocks noChangeAspect="1"/>
+          </p:cNvPicPr>
+          <p:nvPr/>
+        </p:nvPicPr>
+        <p:blipFill>
+          <a:blip r:embed="rId4"/>
+          <a:stretch>
+            <a:fillRect/>
+          </a:stretch>
+        </p:blipFill>
+        <p:spPr>
+          <a:xfrm>
+            <a:off x="9897352" y="3687214"/>
+            <a:ext cx="2294648" cy="3170786"/>
+          </a:xfrm>
+          <a:prstGeom prst="rect">
+            <a:avLst/>
+          </a:prstGeom>
+        </p:spPr>
+      </p:pic>
+      <p:pic>
+        <p:nvPicPr>
+          <p:cNvPr id="21" name="Picture 20">
+            <a:extLst>
+              <a:ext uri="{FF2B5EF4-FFF2-40B4-BE49-F238E27FC236}">
+                <a16:creationId xmlns:a16="http://schemas.microsoft.com/office/drawing/2014/main" id="{FA88AEEE-5EBD-3E40-AE50-BBF77EFA8571}"/>
+              </a:ext>
+            </a:extLst>
+          </p:cNvPr>
+          <p:cNvPicPr>
+            <a:picLocks noChangeAspect="1"/>
+          </p:cNvPicPr>
+          <p:nvPr/>
+        </p:nvPicPr>
+        <p:blipFill>
+          <a:blip r:embed="rId5"/>
+          <a:stretch>
+            <a:fillRect/>
+          </a:stretch>
+        </p:blipFill>
+        <p:spPr>
+          <a:xfrm>
+            <a:off x="288814" y="2468862"/>
+            <a:ext cx="3598221" cy="3265509"/>
+          </a:xfrm>
+          <a:prstGeom prst="rect">
+            <a:avLst/>
+          </a:prstGeom>
+        </p:spPr>
+      </p:pic>
+      <p:pic>
+        <p:nvPicPr>
+          <p:cNvPr id="23" name="Picture 22">
+            <a:extLst>
+              <a:ext uri="{FF2B5EF4-FFF2-40B4-BE49-F238E27FC236}">
+                <a16:creationId xmlns:a16="http://schemas.microsoft.com/office/drawing/2014/main" id="{CBB5288E-E7D3-8D27-8717-C302E606D31F}"/>
+              </a:ext>
+            </a:extLst>
+          </p:cNvPr>
+          <p:cNvPicPr>
+            <a:picLocks noChangeAspect="1"/>
+          </p:cNvPicPr>
+          <p:nvPr/>
+        </p:nvPicPr>
+        <p:blipFill>
+          <a:blip r:embed="rId6"/>
+          <a:stretch>
+            <a:fillRect/>
+          </a:stretch>
+        </p:blipFill>
+        <p:spPr>
+          <a:xfrm>
+            <a:off x="4195387" y="2468862"/>
+            <a:ext cx="3537123" cy="3273067"/>
+          </a:xfrm>
+          <a:prstGeom prst="rect">
+            <a:avLst/>
+          </a:prstGeom>
+        </p:spPr>
+      </p:pic>
+    </p:spTree>
+    <p:extLst>
+      <p:ext uri="{BB962C8B-B14F-4D97-AF65-F5344CB8AC3E}">
+        <p14:creationId xmlns:p14="http://schemas.microsoft.com/office/powerpoint/2010/main" val="778238734"/>
       </p:ext>
     </p:extLst>
   </p:cSld>

</xml_diff>

<commit_message>
Added players who got 0 points via no involvement
</commit_message>
<xml_diff>
--- a/strategy/BBL Fantasy AI v2 Strategy & Planning.pptx
+++ b/strategy/BBL Fantasy AI v2 Strategy & Planning.pptx
@@ -15,6 +15,7 @@
     <p:sldId id="262" r:id="rId9"/>
     <p:sldId id="264" r:id="rId10"/>
     <p:sldId id="265" r:id="rId11"/>
+    <p:sldId id="266" r:id="rId12"/>
   </p:sldIdLst>
   <p:sldSz cx="12192000" cy="6858000"/>
   <p:notesSz cx="6858000" cy="9144000"/>
@@ -144,6 +145,7 @@
         <p14:section name="Base Model (Reweight/Rebuild)" id="{684E1DFC-4CB6-4340-901B-D6627A0B3C03}">
           <p14:sldIdLst>
             <p14:sldId id="265"/>
+            <p14:sldId id="266"/>
           </p14:sldIdLst>
         </p14:section>
       </p14:sectionLst>
@@ -432,7 +434,7 @@
           <a:p>
             <a:fld id="{2D73D9AC-D42E-4620-8482-0397FE94AE8B}" type="datetimeFigureOut">
               <a:rPr lang="en-AU" smtClean="0"/>
-              <a:t>11/11/2025</a:t>
+              <a:t>13/11/2025</a:t>
             </a:fld>
             <a:endParaRPr lang="en-AU"/>
           </a:p>
@@ -632,7 +634,7 @@
           <a:p>
             <a:fld id="{2D73D9AC-D42E-4620-8482-0397FE94AE8B}" type="datetimeFigureOut">
               <a:rPr lang="en-AU" smtClean="0"/>
-              <a:t>11/11/2025</a:t>
+              <a:t>13/11/2025</a:t>
             </a:fld>
             <a:endParaRPr lang="en-AU"/>
           </a:p>
@@ -842,7 +844,7 @@
           <a:p>
             <a:fld id="{2D73D9AC-D42E-4620-8482-0397FE94AE8B}" type="datetimeFigureOut">
               <a:rPr lang="en-AU" smtClean="0"/>
-              <a:t>11/11/2025</a:t>
+              <a:t>13/11/2025</a:t>
             </a:fld>
             <a:endParaRPr lang="en-AU"/>
           </a:p>
@@ -1042,7 +1044,7 @@
           <a:p>
             <a:fld id="{2D73D9AC-D42E-4620-8482-0397FE94AE8B}" type="datetimeFigureOut">
               <a:rPr lang="en-AU" smtClean="0"/>
-              <a:t>11/11/2025</a:t>
+              <a:t>13/11/2025</a:t>
             </a:fld>
             <a:endParaRPr lang="en-AU"/>
           </a:p>
@@ -1318,7 +1320,7 @@
           <a:p>
             <a:fld id="{2D73D9AC-D42E-4620-8482-0397FE94AE8B}" type="datetimeFigureOut">
               <a:rPr lang="en-AU" smtClean="0"/>
-              <a:t>11/11/2025</a:t>
+              <a:t>13/11/2025</a:t>
             </a:fld>
             <a:endParaRPr lang="en-AU"/>
           </a:p>
@@ -1586,7 +1588,7 @@
           <a:p>
             <a:fld id="{2D73D9AC-D42E-4620-8482-0397FE94AE8B}" type="datetimeFigureOut">
               <a:rPr lang="en-AU" smtClean="0"/>
-              <a:t>11/11/2025</a:t>
+              <a:t>13/11/2025</a:t>
             </a:fld>
             <a:endParaRPr lang="en-AU"/>
           </a:p>
@@ -2001,7 +2003,7 @@
           <a:p>
             <a:fld id="{2D73D9AC-D42E-4620-8482-0397FE94AE8B}" type="datetimeFigureOut">
               <a:rPr lang="en-AU" smtClean="0"/>
-              <a:t>11/11/2025</a:t>
+              <a:t>13/11/2025</a:t>
             </a:fld>
             <a:endParaRPr lang="en-AU"/>
           </a:p>
@@ -2143,7 +2145,7 @@
           <a:p>
             <a:fld id="{2D73D9AC-D42E-4620-8482-0397FE94AE8B}" type="datetimeFigureOut">
               <a:rPr lang="en-AU" smtClean="0"/>
-              <a:t>11/11/2025</a:t>
+              <a:t>13/11/2025</a:t>
             </a:fld>
             <a:endParaRPr lang="en-AU"/>
           </a:p>
@@ -2256,7 +2258,7 @@
           <a:p>
             <a:fld id="{2D73D9AC-D42E-4620-8482-0397FE94AE8B}" type="datetimeFigureOut">
               <a:rPr lang="en-AU" smtClean="0"/>
-              <a:t>11/11/2025</a:t>
+              <a:t>13/11/2025</a:t>
             </a:fld>
             <a:endParaRPr lang="en-AU"/>
           </a:p>
@@ -2569,7 +2571,7 @@
           <a:p>
             <a:fld id="{2D73D9AC-D42E-4620-8482-0397FE94AE8B}" type="datetimeFigureOut">
               <a:rPr lang="en-AU" smtClean="0"/>
-              <a:t>11/11/2025</a:t>
+              <a:t>13/11/2025</a:t>
             </a:fld>
             <a:endParaRPr lang="en-AU"/>
           </a:p>
@@ -2858,7 +2860,7 @@
           <a:p>
             <a:fld id="{2D73D9AC-D42E-4620-8482-0397FE94AE8B}" type="datetimeFigureOut">
               <a:rPr lang="en-AU" smtClean="0"/>
-              <a:t>11/11/2025</a:t>
+              <a:t>13/11/2025</a:t>
             </a:fld>
             <a:endParaRPr lang="en-AU"/>
           </a:p>
@@ -3101,7 +3103,7 @@
           <a:p>
             <a:fld id="{2D73D9AC-D42E-4620-8482-0397FE94AE8B}" type="datetimeFigureOut">
               <a:rPr lang="en-AU" smtClean="0"/>
-              <a:t>11/11/2025</a:t>
+              <a:t>13/11/2025</a:t>
             </a:fld>
             <a:endParaRPr lang="en-AU"/>
           </a:p>
@@ -3789,6 +3791,220 @@
     <p:extLst>
       <p:ext uri="{BB962C8B-B14F-4D97-AF65-F5344CB8AC3E}">
         <p14:creationId xmlns:p14="http://schemas.microsoft.com/office/powerpoint/2010/main" val="778238734"/>
+      </p:ext>
+    </p:extLst>
+  </p:cSld>
+  <p:clrMapOvr>
+    <a:masterClrMapping/>
+  </p:clrMapOvr>
+</p:sld>
+</file>
+
+<file path=ppt/slides/slide11.xml><?xml version="1.0" encoding="utf-8"?>
+<p:sld xmlns:a="http://schemas.openxmlformats.org/drawingml/2006/main" xmlns:r="http://schemas.openxmlformats.org/officeDocument/2006/relationships" xmlns:p="http://schemas.openxmlformats.org/presentationml/2006/main">
+  <p:cSld>
+    <p:spTree>
+      <p:nvGrpSpPr>
+        <p:cNvPr id="1" name="">
+          <a:extLst>
+            <a:ext uri="{FF2B5EF4-FFF2-40B4-BE49-F238E27FC236}">
+              <a16:creationId xmlns:a16="http://schemas.microsoft.com/office/drawing/2014/main" id="{E0A2DB9B-00A8-2E03-281D-159BB30A6721}"/>
+            </a:ext>
+          </a:extLst>
+        </p:cNvPr>
+        <p:cNvGrpSpPr/>
+        <p:nvPr/>
+      </p:nvGrpSpPr>
+      <p:grpSpPr>
+        <a:xfrm>
+          <a:off x="0" y="0"/>
+          <a:ext cx="0" cy="0"/>
+          <a:chOff x="0" y="0"/>
+          <a:chExt cx="0" cy="0"/>
+        </a:xfrm>
+      </p:grpSpPr>
+      <p:sp>
+        <p:nvSpPr>
+          <p:cNvPr id="2" name="Title 1">
+            <a:extLst>
+              <a:ext uri="{FF2B5EF4-FFF2-40B4-BE49-F238E27FC236}">
+                <a16:creationId xmlns:a16="http://schemas.microsoft.com/office/drawing/2014/main" id="{B7F9F7BC-688C-D495-D03A-3C54E7A09CA6}"/>
+              </a:ext>
+            </a:extLst>
+          </p:cNvPr>
+          <p:cNvSpPr>
+            <a:spLocks noGrp="1"/>
+          </p:cNvSpPr>
+          <p:nvPr>
+            <p:ph type="title"/>
+          </p:nvPr>
+        </p:nvSpPr>
+        <p:spPr/>
+        <p:txBody>
+          <a:bodyPr/>
+          <a:lstStyle/>
+          <a:p>
+            <a:r>
+              <a:rPr lang="en-AU" dirty="0"/>
+              <a:t>RF Model 2 – Incl 0 players</a:t>
+            </a:r>
+          </a:p>
+        </p:txBody>
+      </p:sp>
+      <p:pic>
+        <p:nvPicPr>
+          <p:cNvPr id="4" name="Picture 3">
+            <a:extLst>
+              <a:ext uri="{FF2B5EF4-FFF2-40B4-BE49-F238E27FC236}">
+                <a16:creationId xmlns:a16="http://schemas.microsoft.com/office/drawing/2014/main" id="{0E9DC3D1-4D5D-F89C-4962-0F6254125BB5}"/>
+              </a:ext>
+            </a:extLst>
+          </p:cNvPr>
+          <p:cNvPicPr>
+            <a:picLocks noChangeAspect="1"/>
+          </p:cNvPicPr>
+          <p:nvPr/>
+        </p:nvPicPr>
+        <p:blipFill>
+          <a:blip r:embed="rId2"/>
+          <a:stretch>
+            <a:fillRect/>
+          </a:stretch>
+        </p:blipFill>
+        <p:spPr>
+          <a:xfrm>
+            <a:off x="936399" y="1462620"/>
+            <a:ext cx="5372850" cy="152421"/>
+          </a:xfrm>
+          <a:prstGeom prst="rect">
+            <a:avLst/>
+          </a:prstGeom>
+        </p:spPr>
+      </p:pic>
+      <p:pic>
+        <p:nvPicPr>
+          <p:cNvPr id="6" name="Picture 5">
+            <a:extLst>
+              <a:ext uri="{FF2B5EF4-FFF2-40B4-BE49-F238E27FC236}">
+                <a16:creationId xmlns:a16="http://schemas.microsoft.com/office/drawing/2014/main" id="{32B87E50-B35B-4799-72BF-660A834D463F}"/>
+              </a:ext>
+            </a:extLst>
+          </p:cNvPr>
+          <p:cNvPicPr>
+            <a:picLocks noChangeAspect="1"/>
+          </p:cNvPicPr>
+          <p:nvPr/>
+        </p:nvPicPr>
+        <p:blipFill>
+          <a:blip r:embed="rId3"/>
+          <a:stretch>
+            <a:fillRect/>
+          </a:stretch>
+        </p:blipFill>
+        <p:spPr>
+          <a:xfrm>
+            <a:off x="9920061" y="0"/>
+            <a:ext cx="2267847" cy="3707861"/>
+          </a:xfrm>
+          <a:prstGeom prst="rect">
+            <a:avLst/>
+          </a:prstGeom>
+        </p:spPr>
+      </p:pic>
+      <p:pic>
+        <p:nvPicPr>
+          <p:cNvPr id="8" name="Picture 7">
+            <a:extLst>
+              <a:ext uri="{FF2B5EF4-FFF2-40B4-BE49-F238E27FC236}">
+                <a16:creationId xmlns:a16="http://schemas.microsoft.com/office/drawing/2014/main" id="{2898794D-F25F-0A49-014B-E60B7CDF5262}"/>
+              </a:ext>
+            </a:extLst>
+          </p:cNvPr>
+          <p:cNvPicPr>
+            <a:picLocks noChangeAspect="1"/>
+          </p:cNvPicPr>
+          <p:nvPr/>
+        </p:nvPicPr>
+        <p:blipFill>
+          <a:blip r:embed="rId4"/>
+          <a:stretch>
+            <a:fillRect/>
+          </a:stretch>
+        </p:blipFill>
+        <p:spPr>
+          <a:xfrm>
+            <a:off x="9920062" y="3718969"/>
+            <a:ext cx="2267847" cy="3139031"/>
+          </a:xfrm>
+          <a:prstGeom prst="rect">
+            <a:avLst/>
+          </a:prstGeom>
+        </p:spPr>
+      </p:pic>
+      <p:pic>
+        <p:nvPicPr>
+          <p:cNvPr id="10" name="Picture 9">
+            <a:extLst>
+              <a:ext uri="{FF2B5EF4-FFF2-40B4-BE49-F238E27FC236}">
+                <a16:creationId xmlns:a16="http://schemas.microsoft.com/office/drawing/2014/main" id="{A12A3679-5D55-BC6D-2669-2B3BE9052661}"/>
+              </a:ext>
+            </a:extLst>
+          </p:cNvPr>
+          <p:cNvPicPr>
+            <a:picLocks noChangeAspect="1"/>
+          </p:cNvPicPr>
+          <p:nvPr/>
+        </p:nvPicPr>
+        <p:blipFill>
+          <a:blip r:embed="rId5"/>
+          <a:stretch>
+            <a:fillRect/>
+          </a:stretch>
+        </p:blipFill>
+        <p:spPr>
+          <a:xfrm>
+            <a:off x="535371" y="2408674"/>
+            <a:ext cx="3582498" cy="3251806"/>
+          </a:xfrm>
+          <a:prstGeom prst="rect">
+            <a:avLst/>
+          </a:prstGeom>
+        </p:spPr>
+      </p:pic>
+      <p:pic>
+        <p:nvPicPr>
+          <p:cNvPr id="12" name="Picture 11">
+            <a:extLst>
+              <a:ext uri="{FF2B5EF4-FFF2-40B4-BE49-F238E27FC236}">
+                <a16:creationId xmlns:a16="http://schemas.microsoft.com/office/drawing/2014/main" id="{1330B8F8-B2A2-6D3B-53B0-E59D26A50C25}"/>
+              </a:ext>
+            </a:extLst>
+          </p:cNvPr>
+          <p:cNvPicPr>
+            <a:picLocks noChangeAspect="1"/>
+          </p:cNvPicPr>
+          <p:nvPr/>
+        </p:nvPicPr>
+        <p:blipFill>
+          <a:blip r:embed="rId6"/>
+          <a:stretch>
+            <a:fillRect/>
+          </a:stretch>
+        </p:blipFill>
+        <p:spPr>
+          <a:xfrm>
+            <a:off x="4713098" y="2365293"/>
+            <a:ext cx="3522640" cy="3270583"/>
+          </a:xfrm>
+          <a:prstGeom prst="rect">
+            <a:avLst/>
+          </a:prstGeom>
+        </p:spPr>
+      </p:pic>
+    </p:spTree>
+    <p:extLst>
+      <p:ext uri="{BB962C8B-B14F-4D97-AF65-F5344CB8AC3E}">
+        <p14:creationId xmlns:p14="http://schemas.microsoft.com/office/powerpoint/2010/main" val="3843652248"/>
       </p:ext>
     </p:extLst>
   </p:cSld>

</xml_diff>

<commit_message>
response variable change and xgboost base model experimentation
</commit_message>
<xml_diff>
--- a/strategy/BBL Fantasy AI v2 Strategy & Planning.pptx
+++ b/strategy/BBL Fantasy AI v2 Strategy & Planning.pptx
@@ -20,6 +20,13 @@
     <p:sldId id="266" r:id="rId14"/>
     <p:sldId id="269" r:id="rId15"/>
     <p:sldId id="270" r:id="rId16"/>
+    <p:sldId id="271" r:id="rId17"/>
+    <p:sldId id="272" r:id="rId18"/>
+    <p:sldId id="273" r:id="rId19"/>
+    <p:sldId id="274" r:id="rId20"/>
+    <p:sldId id="275" r:id="rId21"/>
+    <p:sldId id="276" r:id="rId22"/>
+    <p:sldId id="277" r:id="rId23"/>
   </p:sldIdLst>
   <p:sldSz cx="12192000" cy="6858000"/>
   <p:notesSz cx="6858000" cy="9144000"/>
@@ -154,6 +161,21 @@
             <p14:sldId id="266"/>
             <p14:sldId id="269"/>
             <p14:sldId id="270"/>
+            <p14:sldId id="271"/>
+            <p14:sldId id="272"/>
+          </p14:sldIdLst>
+        </p14:section>
+        <p14:section name="Average Season Model" id="{B145F419-38FA-421F-9C7D-5977CBFEA969}">
+          <p14:sldIdLst>
+            <p14:sldId id="273"/>
+            <p14:sldId id="274"/>
+            <p14:sldId id="275"/>
+            <p14:sldId id="276"/>
+          </p14:sldIdLst>
+        </p14:section>
+        <p14:section name="Batting Avg Points Model" id="{657CCE3E-EEF5-4B7A-BF91-4A5DC543F188}">
+          <p14:sldIdLst>
+            <p14:sldId id="277"/>
           </p14:sldIdLst>
         </p14:section>
       </p14:sectionLst>
@@ -176,12 +198,20 @@
 </p:presentation>
 </file>
 
+<file path=ppt/revisionInfo.xml><?xml version="1.0" encoding="utf-8"?>
+<p1510:revInfo xmlns:a="http://schemas.openxmlformats.org/drawingml/2006/main" xmlns:r="http://schemas.openxmlformats.org/officeDocument/2006/relationships" xmlns:p1510="http://schemas.microsoft.com/office/powerpoint/2015/10/main">
+  <p1510:revLst>
+    <p1510:client id="{B4EA8C78-5629-4CB8-9794-5E1861B660A8}" v="5" dt="2025-11-18T13:55:56.619"/>
+  </p1510:revLst>
+</p1510:revInfo>
+</file>
+
 <file path=ppt/changesInfos/changesInfo1.xml><?xml version="1.0" encoding="utf-8"?>
 <pc:chgInfo xmlns:a="http://schemas.openxmlformats.org/drawingml/2006/main" xmlns:r="http://schemas.openxmlformats.org/officeDocument/2006/relationships" xmlns:ac="http://schemas.microsoft.com/office/drawing/2013/main/command" xmlns:pc="http://schemas.microsoft.com/office/powerpoint/2013/main/command">
   <pc:docChgLst>
     <pc:chgData name="Dilan De Silva" userId="579b606d6e18a4ed" providerId="LiveId" clId="{55D98E11-54C8-4694-9916-6163FE05F5A8}"/>
-    <pc:docChg chg="custSel addSld modSld addSection modSection">
-      <pc:chgData name="Dilan De Silva" userId="579b606d6e18a4ed" providerId="LiveId" clId="{55D98E11-54C8-4694-9916-6163FE05F5A8}" dt="2025-11-16T07:21:06.064" v="108" actId="20577"/>
+    <pc:docChg chg="undo custSel addSld delSld modSld addSection delSection modSection">
+      <pc:chgData name="Dilan De Silva" userId="579b606d6e18a4ed" providerId="LiveId" clId="{55D98E11-54C8-4694-9916-6163FE05F5A8}" dt="2025-11-18T15:41:36.485" v="529" actId="1076"/>
       <pc:docMkLst>
         <pc:docMk/>
       </pc:docMkLst>
@@ -262,14 +292,6 @@
             <ac:picMk id="4" creationId="{57579C64-28B7-38CF-C8A8-D9BB80B5FFD1}"/>
           </ac:picMkLst>
         </pc:picChg>
-        <pc:picChg chg="del">
-          <ac:chgData name="Dilan De Silva" userId="579b606d6e18a4ed" providerId="LiveId" clId="{55D98E11-54C8-4694-9916-6163FE05F5A8}" dt="2025-11-16T07:13:37.417" v="77" actId="478"/>
-          <ac:picMkLst>
-            <pc:docMk/>
-            <pc:sldMk cId="3676518933" sldId="270"/>
-            <ac:picMk id="5" creationId="{2D9354E2-09F8-E624-06C1-918163E514F8}"/>
-          </ac:picMkLst>
-        </pc:picChg>
         <pc:picChg chg="add mod">
           <ac:chgData name="Dilan De Silva" userId="579b606d6e18a4ed" providerId="LiveId" clId="{55D98E11-54C8-4694-9916-6163FE05F5A8}" dt="2025-11-16T07:14:52.354" v="93" actId="14100"/>
           <ac:picMkLst>
@@ -278,14 +300,6 @@
             <ac:picMk id="7" creationId="{F3513B56-B023-AA65-5F08-7B4EA2F4A6E3}"/>
           </ac:picMkLst>
         </pc:picChg>
-        <pc:picChg chg="del">
-          <ac:chgData name="Dilan De Silva" userId="579b606d6e18a4ed" providerId="LiveId" clId="{55D98E11-54C8-4694-9916-6163FE05F5A8}" dt="2025-11-16T07:13:40.387" v="80" actId="478"/>
-          <ac:picMkLst>
-            <pc:docMk/>
-            <pc:sldMk cId="3676518933" sldId="270"/>
-            <ac:picMk id="9" creationId="{2955ED5D-252E-0AE9-F44F-BA8F13330E03}"/>
-          </ac:picMkLst>
-        </pc:picChg>
         <pc:picChg chg="add mod">
           <ac:chgData name="Dilan De Silva" userId="579b606d6e18a4ed" providerId="LiveId" clId="{55D98E11-54C8-4694-9916-6163FE05F5A8}" dt="2025-11-16T07:16:16.455" v="102" actId="1076"/>
           <ac:picMkLst>
@@ -302,22 +316,6 @@
             <ac:picMk id="12" creationId="{0E21CB93-98B3-5B0C-6072-8BD46B185B9D}"/>
           </ac:picMkLst>
         </pc:picChg>
-        <pc:picChg chg="del">
-          <ac:chgData name="Dilan De Silva" userId="579b606d6e18a4ed" providerId="LiveId" clId="{55D98E11-54C8-4694-9916-6163FE05F5A8}" dt="2025-11-16T07:13:40.903" v="81" actId="478"/>
-          <ac:picMkLst>
-            <pc:docMk/>
-            <pc:sldMk cId="3676518933" sldId="270"/>
-            <ac:picMk id="13" creationId="{49466049-2E66-0632-436B-B8A90489F60B}"/>
-          </ac:picMkLst>
-        </pc:picChg>
-        <pc:picChg chg="del">
-          <ac:chgData name="Dilan De Silva" userId="579b606d6e18a4ed" providerId="LiveId" clId="{55D98E11-54C8-4694-9916-6163FE05F5A8}" dt="2025-11-16T07:13:39.351" v="78" actId="478"/>
-          <ac:picMkLst>
-            <pc:docMk/>
-            <pc:sldMk cId="3676518933" sldId="270"/>
-            <ac:picMk id="15" creationId="{B22DE195-9F0C-5DAF-877B-11419AB0DA0C}"/>
-          </ac:picMkLst>
-        </pc:picChg>
         <pc:picChg chg="add mod">
           <ac:chgData name="Dilan De Silva" userId="579b606d6e18a4ed" providerId="LiveId" clId="{55D98E11-54C8-4694-9916-6163FE05F5A8}" dt="2025-11-16T07:20:59.283" v="107" actId="1076"/>
           <ac:picMkLst>
@@ -326,12 +324,1200 @@
             <ac:picMk id="16" creationId="{A82CC3D1-F18C-39D9-F712-3B8F219BF4D5}"/>
           </ac:picMkLst>
         </pc:picChg>
+      </pc:sldChg>
+      <pc:sldChg chg="addSp delSp modSp add mod">
+        <pc:chgData name="Dilan De Silva" userId="579b606d6e18a4ed" providerId="LiveId" clId="{55D98E11-54C8-4694-9916-6163FE05F5A8}" dt="2025-11-18T12:53:47.587" v="151" actId="1076"/>
+        <pc:sldMkLst>
+          <pc:docMk/>
+          <pc:sldMk cId="3936721459" sldId="271"/>
+        </pc:sldMkLst>
+        <pc:spChg chg="mod">
+          <ac:chgData name="Dilan De Silva" userId="579b606d6e18a4ed" providerId="LiveId" clId="{55D98E11-54C8-4694-9916-6163FE05F5A8}" dt="2025-11-18T12:49:55.972" v="111" actId="20577"/>
+          <ac:spMkLst>
+            <pc:docMk/>
+            <pc:sldMk cId="3936721459" sldId="271"/>
+            <ac:spMk id="2" creationId="{326C68D0-23E3-3F12-7098-2A1C235EC35A}"/>
+          </ac:spMkLst>
+        </pc:spChg>
         <pc:picChg chg="del">
-          <ac:chgData name="Dilan De Silva" userId="579b606d6e18a4ed" providerId="LiveId" clId="{55D98E11-54C8-4694-9916-6163FE05F5A8}" dt="2025-11-16T07:13:39.698" v="79" actId="478"/>
-          <ac:picMkLst>
-            <pc:docMk/>
-            <pc:sldMk cId="3676518933" sldId="270"/>
-            <ac:picMk id="17" creationId="{1EE469EF-0F44-D856-4006-63C603D6EDC8}"/>
+          <ac:chgData name="Dilan De Silva" userId="579b606d6e18a4ed" providerId="LiveId" clId="{55D98E11-54C8-4694-9916-6163FE05F5A8}" dt="2025-11-18T12:49:59.331" v="117" actId="478"/>
+          <ac:picMkLst>
+            <pc:docMk/>
+            <pc:sldMk cId="3936721459" sldId="271"/>
+            <ac:picMk id="4" creationId="{A1767807-5DB5-EEA7-54FD-B54FA7ACA7C9}"/>
+          </ac:picMkLst>
+        </pc:picChg>
+        <pc:picChg chg="add mod">
+          <ac:chgData name="Dilan De Silva" userId="579b606d6e18a4ed" providerId="LiveId" clId="{55D98E11-54C8-4694-9916-6163FE05F5A8}" dt="2025-11-18T12:53:44.386" v="148" actId="1076"/>
+          <ac:picMkLst>
+            <pc:docMk/>
+            <pc:sldMk cId="3936721459" sldId="271"/>
+            <ac:picMk id="5" creationId="{AF65B7FD-A905-EE78-31CC-EC4A7A89F9EC}"/>
+          </ac:picMkLst>
+        </pc:picChg>
+        <pc:picChg chg="del">
+          <ac:chgData name="Dilan De Silva" userId="579b606d6e18a4ed" providerId="LiveId" clId="{55D98E11-54C8-4694-9916-6163FE05F5A8}" dt="2025-11-18T12:49:59.822" v="118" actId="478"/>
+          <ac:picMkLst>
+            <pc:docMk/>
+            <pc:sldMk cId="3936721459" sldId="271"/>
+            <ac:picMk id="7" creationId="{839DD7EE-6D08-93BE-D374-D3785EA0EA9A}"/>
+          </ac:picMkLst>
+        </pc:picChg>
+        <pc:picChg chg="add mod">
+          <ac:chgData name="Dilan De Silva" userId="579b606d6e18a4ed" providerId="LiveId" clId="{55D98E11-54C8-4694-9916-6163FE05F5A8}" dt="2025-11-18T12:53:45.711" v="150" actId="1076"/>
+          <ac:picMkLst>
+            <pc:docMk/>
+            <pc:sldMk cId="3936721459" sldId="271"/>
+            <ac:picMk id="8" creationId="{BAD29697-4901-99EE-926D-418EC149ADB7}"/>
+          </ac:picMkLst>
+        </pc:picChg>
+        <pc:picChg chg="del mod">
+          <ac:chgData name="Dilan De Silva" userId="579b606d6e18a4ed" providerId="LiveId" clId="{55D98E11-54C8-4694-9916-6163FE05F5A8}" dt="2025-11-18T12:49:58.160" v="115" actId="478"/>
+          <ac:picMkLst>
+            <pc:docMk/>
+            <pc:sldMk cId="3936721459" sldId="271"/>
+            <ac:picMk id="10" creationId="{EDB24408-085D-67D8-5E3A-E2344631457F}"/>
+          </ac:picMkLst>
+        </pc:picChg>
+        <pc:picChg chg="add mod">
+          <ac:chgData name="Dilan De Silva" userId="579b606d6e18a4ed" providerId="LiveId" clId="{55D98E11-54C8-4694-9916-6163FE05F5A8}" dt="2025-11-18T12:53:33.419" v="144" actId="1076"/>
+          <ac:picMkLst>
+            <pc:docMk/>
+            <pc:sldMk cId="3936721459" sldId="271"/>
+            <ac:picMk id="11" creationId="{29678640-CB9D-2281-43A9-F4A7BEBC571C}"/>
+          </ac:picMkLst>
+        </pc:picChg>
+        <pc:picChg chg="del">
+          <ac:chgData name="Dilan De Silva" userId="579b606d6e18a4ed" providerId="LiveId" clId="{55D98E11-54C8-4694-9916-6163FE05F5A8}" dt="2025-11-18T12:49:58.667" v="116" actId="478"/>
+          <ac:picMkLst>
+            <pc:docMk/>
+            <pc:sldMk cId="3936721459" sldId="271"/>
+            <ac:picMk id="12" creationId="{B304873F-406D-4653-CE56-B986256D04A8}"/>
+          </ac:picMkLst>
+        </pc:picChg>
+        <pc:picChg chg="add mod">
+          <ac:chgData name="Dilan De Silva" userId="579b606d6e18a4ed" providerId="LiveId" clId="{55D98E11-54C8-4694-9916-6163FE05F5A8}" dt="2025-11-18T12:53:31.808" v="143" actId="1076"/>
+          <ac:picMkLst>
+            <pc:docMk/>
+            <pc:sldMk cId="3936721459" sldId="271"/>
+            <ac:picMk id="14" creationId="{6A1A8F6A-7204-307E-3F4D-028687846424}"/>
+          </ac:picMkLst>
+        </pc:picChg>
+        <pc:picChg chg="del mod">
+          <ac:chgData name="Dilan De Silva" userId="579b606d6e18a4ed" providerId="LiveId" clId="{55D98E11-54C8-4694-9916-6163FE05F5A8}" dt="2025-11-18T12:49:57.477" v="113" actId="478"/>
+          <ac:picMkLst>
+            <pc:docMk/>
+            <pc:sldMk cId="3936721459" sldId="271"/>
+            <ac:picMk id="16" creationId="{D0077202-E117-0928-321C-D9F899C9F085}"/>
+          </ac:picMkLst>
+        </pc:picChg>
+        <pc:picChg chg="add mod">
+          <ac:chgData name="Dilan De Silva" userId="579b606d6e18a4ed" providerId="LiveId" clId="{55D98E11-54C8-4694-9916-6163FE05F5A8}" dt="2025-11-18T12:53:05.582" v="142" actId="1076"/>
+          <ac:picMkLst>
+            <pc:docMk/>
+            <pc:sldMk cId="3936721459" sldId="271"/>
+            <ac:picMk id="17" creationId="{1187DB19-34F6-5C2C-2C61-6CF67DAD8251}"/>
+          </ac:picMkLst>
+        </pc:picChg>
+        <pc:picChg chg="add mod">
+          <ac:chgData name="Dilan De Silva" userId="579b606d6e18a4ed" providerId="LiveId" clId="{55D98E11-54C8-4694-9916-6163FE05F5A8}" dt="2025-11-18T12:53:47.587" v="151" actId="1076"/>
+          <ac:picMkLst>
+            <pc:docMk/>
+            <pc:sldMk cId="3936721459" sldId="271"/>
+            <ac:picMk id="19" creationId="{CB8D3467-518A-5823-A85F-C3D46F3C4F5E}"/>
+          </ac:picMkLst>
+        </pc:picChg>
+      </pc:sldChg>
+      <pc:sldChg chg="addSp delSp modSp add mod">
+        <pc:chgData name="Dilan De Silva" userId="579b606d6e18a4ed" providerId="LiveId" clId="{55D98E11-54C8-4694-9916-6163FE05F5A8}" dt="2025-11-18T12:58:41.386" v="200" actId="1076"/>
+        <pc:sldMkLst>
+          <pc:docMk/>
+          <pc:sldMk cId="3689886638" sldId="272"/>
+        </pc:sldMkLst>
+        <pc:spChg chg="mod">
+          <ac:chgData name="Dilan De Silva" userId="579b606d6e18a4ed" providerId="LiveId" clId="{55D98E11-54C8-4694-9916-6163FE05F5A8}" dt="2025-11-18T12:54:11.364" v="174" actId="20577"/>
+          <ac:spMkLst>
+            <pc:docMk/>
+            <pc:sldMk cId="3689886638" sldId="272"/>
+            <ac:spMk id="2" creationId="{76DD7B40-3BC6-D784-C574-7DECB63209BD}"/>
+          </ac:spMkLst>
+        </pc:spChg>
+        <pc:picChg chg="add mod">
+          <ac:chgData name="Dilan De Silva" userId="579b606d6e18a4ed" providerId="LiveId" clId="{55D98E11-54C8-4694-9916-6163FE05F5A8}" dt="2025-11-18T12:56:12.213" v="183" actId="14100"/>
+          <ac:picMkLst>
+            <pc:docMk/>
+            <pc:sldMk cId="3689886638" sldId="272"/>
+            <ac:picMk id="4" creationId="{54A2B921-A557-9DE4-3940-CBAD32198160}"/>
+          </ac:picMkLst>
+        </pc:picChg>
+        <pc:picChg chg="del">
+          <ac:chgData name="Dilan De Silva" userId="579b606d6e18a4ed" providerId="LiveId" clId="{55D98E11-54C8-4694-9916-6163FE05F5A8}" dt="2025-11-18T12:55:55.732" v="179" actId="478"/>
+          <ac:picMkLst>
+            <pc:docMk/>
+            <pc:sldMk cId="3689886638" sldId="272"/>
+            <ac:picMk id="5" creationId="{C812E3AD-434A-9139-58E2-335D4AA5F804}"/>
+          </ac:picMkLst>
+        </pc:picChg>
+        <pc:picChg chg="add mod">
+          <ac:chgData name="Dilan De Silva" userId="579b606d6e18a4ed" providerId="LiveId" clId="{55D98E11-54C8-4694-9916-6163FE05F5A8}" dt="2025-11-18T12:56:32.533" v="187" actId="14100"/>
+          <ac:picMkLst>
+            <pc:docMk/>
+            <pc:sldMk cId="3689886638" sldId="272"/>
+            <ac:picMk id="7" creationId="{E9EC54E5-6D18-9852-42DF-E1A515DD8628}"/>
+          </ac:picMkLst>
+        </pc:picChg>
+        <pc:picChg chg="del">
+          <ac:chgData name="Dilan De Silva" userId="579b606d6e18a4ed" providerId="LiveId" clId="{55D98E11-54C8-4694-9916-6163FE05F5A8}" dt="2025-11-18T12:55:56.203" v="180" actId="478"/>
+          <ac:picMkLst>
+            <pc:docMk/>
+            <pc:sldMk cId="3689886638" sldId="272"/>
+            <ac:picMk id="8" creationId="{53635035-0F36-EBC1-E1E5-3A3AD5CB2DDF}"/>
+          </ac:picMkLst>
+        </pc:picChg>
+        <pc:picChg chg="add mod">
+          <ac:chgData name="Dilan De Silva" userId="579b606d6e18a4ed" providerId="LiveId" clId="{55D98E11-54C8-4694-9916-6163FE05F5A8}" dt="2025-11-18T12:56:55.078" v="189" actId="1076"/>
+          <ac:picMkLst>
+            <pc:docMk/>
+            <pc:sldMk cId="3689886638" sldId="272"/>
+            <ac:picMk id="10" creationId="{B655EC6B-9803-26FF-9931-5A486B6158CF}"/>
+          </ac:picMkLst>
+        </pc:picChg>
+        <pc:picChg chg="del">
+          <ac:chgData name="Dilan De Silva" userId="579b606d6e18a4ed" providerId="LiveId" clId="{55D98E11-54C8-4694-9916-6163FE05F5A8}" dt="2025-11-18T12:55:53.138" v="175" actId="478"/>
+          <ac:picMkLst>
+            <pc:docMk/>
+            <pc:sldMk cId="3689886638" sldId="272"/>
+            <ac:picMk id="11" creationId="{85A4E88D-DC1D-06EA-2D3D-CED60FB72583}"/>
+          </ac:picMkLst>
+        </pc:picChg>
+        <pc:picChg chg="add mod">
+          <ac:chgData name="Dilan De Silva" userId="579b606d6e18a4ed" providerId="LiveId" clId="{55D98E11-54C8-4694-9916-6163FE05F5A8}" dt="2025-11-18T12:58:41.386" v="200" actId="1076"/>
+          <ac:picMkLst>
+            <pc:docMk/>
+            <pc:sldMk cId="3689886638" sldId="272"/>
+            <ac:picMk id="13" creationId="{98D78295-9820-8529-BE1A-2EAA869E4015}"/>
+          </ac:picMkLst>
+        </pc:picChg>
+        <pc:picChg chg="del">
+          <ac:chgData name="Dilan De Silva" userId="579b606d6e18a4ed" providerId="LiveId" clId="{55D98E11-54C8-4694-9916-6163FE05F5A8}" dt="2025-11-18T12:55:53.550" v="176" actId="478"/>
+          <ac:picMkLst>
+            <pc:docMk/>
+            <pc:sldMk cId="3689886638" sldId="272"/>
+            <ac:picMk id="14" creationId="{AF815AF2-BCE1-730F-E2B6-F4EA0089D728}"/>
+          </ac:picMkLst>
+        </pc:picChg>
+        <pc:picChg chg="add mod">
+          <ac:chgData name="Dilan De Silva" userId="579b606d6e18a4ed" providerId="LiveId" clId="{55D98E11-54C8-4694-9916-6163FE05F5A8}" dt="2025-11-18T12:58:39.163" v="199" actId="1076"/>
+          <ac:picMkLst>
+            <pc:docMk/>
+            <pc:sldMk cId="3689886638" sldId="272"/>
+            <ac:picMk id="16" creationId="{6EB31A8E-1C9E-B475-35A1-7C78106A02D1}"/>
+          </ac:picMkLst>
+        </pc:picChg>
+        <pc:picChg chg="del">
+          <ac:chgData name="Dilan De Silva" userId="579b606d6e18a4ed" providerId="LiveId" clId="{55D98E11-54C8-4694-9916-6163FE05F5A8}" dt="2025-11-18T12:55:54.315" v="177" actId="478"/>
+          <ac:picMkLst>
+            <pc:docMk/>
+            <pc:sldMk cId="3689886638" sldId="272"/>
+            <ac:picMk id="17" creationId="{D073CB17-BBF1-B092-A3B0-F8EEE8FAE2D5}"/>
+          </ac:picMkLst>
+        </pc:picChg>
+        <pc:picChg chg="del">
+          <ac:chgData name="Dilan De Silva" userId="579b606d6e18a4ed" providerId="LiveId" clId="{55D98E11-54C8-4694-9916-6163FE05F5A8}" dt="2025-11-18T12:55:55.168" v="178" actId="478"/>
+          <ac:picMkLst>
+            <pc:docMk/>
+            <pc:sldMk cId="3689886638" sldId="272"/>
+            <ac:picMk id="19" creationId="{B7AD7324-1959-327F-E202-837701BE0848}"/>
+          </ac:picMkLst>
+        </pc:picChg>
+        <pc:picChg chg="add mod">
+          <ac:chgData name="Dilan De Silva" userId="579b606d6e18a4ed" providerId="LiveId" clId="{55D98E11-54C8-4694-9916-6163FE05F5A8}" dt="2025-11-18T12:58:37.468" v="198" actId="1076"/>
+          <ac:picMkLst>
+            <pc:docMk/>
+            <pc:sldMk cId="3689886638" sldId="272"/>
+            <ac:picMk id="20" creationId="{777B34DD-5B14-B60E-365A-B41EE8261732}"/>
+          </ac:picMkLst>
+        </pc:picChg>
+      </pc:sldChg>
+      <pc:sldChg chg="addSp delSp modSp new mod">
+        <pc:chgData name="Dilan De Silva" userId="579b606d6e18a4ed" providerId="LiveId" clId="{55D98E11-54C8-4694-9916-6163FE05F5A8}" dt="2025-11-18T14:49:47.609" v="413" actId="1076"/>
+        <pc:sldMkLst>
+          <pc:docMk/>
+          <pc:sldMk cId="4139802702" sldId="273"/>
+        </pc:sldMkLst>
+        <pc:spChg chg="mod">
+          <ac:chgData name="Dilan De Silva" userId="579b606d6e18a4ed" providerId="LiveId" clId="{55D98E11-54C8-4694-9916-6163FE05F5A8}" dt="2025-11-18T13:19:32.748" v="232" actId="14100"/>
+          <ac:spMkLst>
+            <pc:docMk/>
+            <pc:sldMk cId="4139802702" sldId="273"/>
+            <ac:spMk id="2" creationId="{5FACF89F-33D2-9EF4-EDE0-3583CF672AE6}"/>
+          </ac:spMkLst>
+        </pc:spChg>
+        <pc:spChg chg="del">
+          <ac:chgData name="Dilan De Silva" userId="579b606d6e18a4ed" providerId="LiveId" clId="{55D98E11-54C8-4694-9916-6163FE05F5A8}" dt="2025-11-18T13:02:22.942" v="215" actId="478"/>
+          <ac:spMkLst>
+            <pc:docMk/>
+            <pc:sldMk cId="4139802702" sldId="273"/>
+            <ac:spMk id="3" creationId="{4B76B8D6-F7D7-4F82-B502-815A5BA50CA6}"/>
+          </ac:spMkLst>
+        </pc:spChg>
+        <pc:picChg chg="add del mod">
+          <ac:chgData name="Dilan De Silva" userId="579b606d6e18a4ed" providerId="LiveId" clId="{55D98E11-54C8-4694-9916-6163FE05F5A8}" dt="2025-11-18T14:45:57.565" v="395" actId="478"/>
+          <ac:picMkLst>
+            <pc:docMk/>
+            <pc:sldMk cId="4139802702" sldId="273"/>
+            <ac:picMk id="5" creationId="{D3CB9B00-1E16-0CE2-6588-643FDA3F0EC1}"/>
+          </ac:picMkLst>
+        </pc:picChg>
+        <pc:picChg chg="add del mod">
+          <ac:chgData name="Dilan De Silva" userId="579b606d6e18a4ed" providerId="LiveId" clId="{55D98E11-54C8-4694-9916-6163FE05F5A8}" dt="2025-11-18T14:45:45.182" v="383" actId="478"/>
+          <ac:picMkLst>
+            <pc:docMk/>
+            <pc:sldMk cId="4139802702" sldId="273"/>
+            <ac:picMk id="7" creationId="{EAAB753E-AECE-1421-35DC-11F65E45CBAE}"/>
+          </ac:picMkLst>
+        </pc:picChg>
+        <pc:picChg chg="add del mod">
+          <ac:chgData name="Dilan De Silva" userId="579b606d6e18a4ed" providerId="LiveId" clId="{55D98E11-54C8-4694-9916-6163FE05F5A8}" dt="2025-11-18T14:45:45.640" v="384" actId="478"/>
+          <ac:picMkLst>
+            <pc:docMk/>
+            <pc:sldMk cId="4139802702" sldId="273"/>
+            <ac:picMk id="9" creationId="{0A52732E-2EE3-7122-8C1C-DA1D18B82C3A}"/>
+          </ac:picMkLst>
+        </pc:picChg>
+        <pc:picChg chg="add del mod">
+          <ac:chgData name="Dilan De Silva" userId="579b606d6e18a4ed" providerId="LiveId" clId="{55D98E11-54C8-4694-9916-6163FE05F5A8}" dt="2025-11-18T14:45:46.123" v="385" actId="478"/>
+          <ac:picMkLst>
+            <pc:docMk/>
+            <pc:sldMk cId="4139802702" sldId="273"/>
+            <ac:picMk id="11" creationId="{E4C1D59A-5DD8-B83C-DA7C-35AB9B13BAFB}"/>
+          </ac:picMkLst>
+        </pc:picChg>
+        <pc:picChg chg="add del mod">
+          <ac:chgData name="Dilan De Silva" userId="579b606d6e18a4ed" providerId="LiveId" clId="{55D98E11-54C8-4694-9916-6163FE05F5A8}" dt="2025-11-18T14:45:47.062" v="386" actId="478"/>
+          <ac:picMkLst>
+            <pc:docMk/>
+            <pc:sldMk cId="4139802702" sldId="273"/>
+            <ac:picMk id="13" creationId="{EE286DA9-DEC6-1F83-D502-B9F754214707}"/>
+          </ac:picMkLst>
+        </pc:picChg>
+        <pc:picChg chg="add del mod">
+          <ac:chgData name="Dilan De Silva" userId="579b606d6e18a4ed" providerId="LiveId" clId="{55D98E11-54C8-4694-9916-6163FE05F5A8}" dt="2025-11-18T14:45:48.550" v="388" actId="478"/>
+          <ac:picMkLst>
+            <pc:docMk/>
+            <pc:sldMk cId="4139802702" sldId="273"/>
+            <ac:picMk id="15" creationId="{65656C47-B116-4257-D1FB-B3B234FD4AA8}"/>
+          </ac:picMkLst>
+        </pc:picChg>
+        <pc:picChg chg="add del mod">
+          <ac:chgData name="Dilan De Silva" userId="579b606d6e18a4ed" providerId="LiveId" clId="{55D98E11-54C8-4694-9916-6163FE05F5A8}" dt="2025-11-18T14:45:47.999" v="387" actId="478"/>
+          <ac:picMkLst>
+            <pc:docMk/>
+            <pc:sldMk cId="4139802702" sldId="273"/>
+            <ac:picMk id="17" creationId="{6CECB23D-2CB0-BDFD-9E2C-C5BCBED1F1C9}"/>
+          </ac:picMkLst>
+        </pc:picChg>
+        <pc:picChg chg="add mod">
+          <ac:chgData name="Dilan De Silva" userId="579b606d6e18a4ed" providerId="LiveId" clId="{55D98E11-54C8-4694-9916-6163FE05F5A8}" dt="2025-11-18T14:46:52.954" v="403" actId="1076"/>
+          <ac:picMkLst>
+            <pc:docMk/>
+            <pc:sldMk cId="4139802702" sldId="273"/>
+            <ac:picMk id="19" creationId="{00CCED33-49B5-FAA6-6167-5C6ECFB76BEA}"/>
+          </ac:picMkLst>
+        </pc:picChg>
+        <pc:picChg chg="add mod">
+          <ac:chgData name="Dilan De Silva" userId="579b606d6e18a4ed" providerId="LiveId" clId="{55D98E11-54C8-4694-9916-6163FE05F5A8}" dt="2025-11-18T14:46:54.850" v="404" actId="1076"/>
+          <ac:picMkLst>
+            <pc:docMk/>
+            <pc:sldMk cId="4139802702" sldId="273"/>
+            <ac:picMk id="21" creationId="{32581F66-711F-8E1A-FB35-42A9B61D5760}"/>
+          </ac:picMkLst>
+        </pc:picChg>
+        <pc:picChg chg="add mod">
+          <ac:chgData name="Dilan De Silva" userId="579b606d6e18a4ed" providerId="LiveId" clId="{55D98E11-54C8-4694-9916-6163FE05F5A8}" dt="2025-11-18T14:46:49.046" v="402" actId="14100"/>
+          <ac:picMkLst>
+            <pc:docMk/>
+            <pc:sldMk cId="4139802702" sldId="273"/>
+            <ac:picMk id="23" creationId="{51D539E0-AEC2-9307-5BCE-3C55365181FE}"/>
+          </ac:picMkLst>
+        </pc:picChg>
+        <pc:picChg chg="add">
+          <ac:chgData name="Dilan De Silva" userId="579b606d6e18a4ed" providerId="LiveId" clId="{55D98E11-54C8-4694-9916-6163FE05F5A8}" dt="2025-11-18T14:48:13.632" v="405" actId="22"/>
+          <ac:picMkLst>
+            <pc:docMk/>
+            <pc:sldMk cId="4139802702" sldId="273"/>
+            <ac:picMk id="25" creationId="{E82160D3-55D6-69FF-14C3-C607A7EE8EEB}"/>
+          </ac:picMkLst>
+        </pc:picChg>
+        <pc:picChg chg="add mod">
+          <ac:chgData name="Dilan De Silva" userId="579b606d6e18a4ed" providerId="LiveId" clId="{55D98E11-54C8-4694-9916-6163FE05F5A8}" dt="2025-11-18T14:48:40.577" v="407" actId="1076"/>
+          <ac:picMkLst>
+            <pc:docMk/>
+            <pc:sldMk cId="4139802702" sldId="273"/>
+            <ac:picMk id="27" creationId="{37BD9F3D-3199-F7E1-693B-F84C84A2C2CF}"/>
+          </ac:picMkLst>
+        </pc:picChg>
+        <pc:picChg chg="add mod">
+          <ac:chgData name="Dilan De Silva" userId="579b606d6e18a4ed" providerId="LiveId" clId="{55D98E11-54C8-4694-9916-6163FE05F5A8}" dt="2025-11-18T14:49:26.560" v="409" actId="1076"/>
+          <ac:picMkLst>
+            <pc:docMk/>
+            <pc:sldMk cId="4139802702" sldId="273"/>
+            <ac:picMk id="29" creationId="{93EE4C4A-95EF-54CC-BB52-8B5BB1E71A56}"/>
+          </ac:picMkLst>
+        </pc:picChg>
+        <pc:picChg chg="add mod">
+          <ac:chgData name="Dilan De Silva" userId="579b606d6e18a4ed" providerId="LiveId" clId="{55D98E11-54C8-4694-9916-6163FE05F5A8}" dt="2025-11-18T14:49:47.609" v="413" actId="1076"/>
+          <ac:picMkLst>
+            <pc:docMk/>
+            <pc:sldMk cId="4139802702" sldId="273"/>
+            <ac:picMk id="31" creationId="{5700D302-264E-64B4-4030-52C82AAD27DD}"/>
+          </ac:picMkLst>
+        </pc:picChg>
+      </pc:sldChg>
+      <pc:sldChg chg="addSp delSp modSp add mod">
+        <pc:chgData name="Dilan De Silva" userId="579b606d6e18a4ed" providerId="LiveId" clId="{55D98E11-54C8-4694-9916-6163FE05F5A8}" dt="2025-11-18T15:03:48.600" v="449" actId="1076"/>
+        <pc:sldMkLst>
+          <pc:docMk/>
+          <pc:sldMk cId="3294159094" sldId="274"/>
+        </pc:sldMkLst>
+        <pc:spChg chg="mod">
+          <ac:chgData name="Dilan De Silva" userId="579b606d6e18a4ed" providerId="LiveId" clId="{55D98E11-54C8-4694-9916-6163FE05F5A8}" dt="2025-11-18T14:59:31.113" v="416" actId="20577"/>
+          <ac:spMkLst>
+            <pc:docMk/>
+            <pc:sldMk cId="3294159094" sldId="274"/>
+            <ac:spMk id="2" creationId="{262CDD4C-6FC6-76B9-4382-9C4718F679B8}"/>
+          </ac:spMkLst>
+        </pc:spChg>
+        <pc:picChg chg="add mod">
+          <ac:chgData name="Dilan De Silva" userId="579b606d6e18a4ed" providerId="LiveId" clId="{55D98E11-54C8-4694-9916-6163FE05F5A8}" dt="2025-11-18T15:00:21.329" v="437" actId="1076"/>
+          <ac:picMkLst>
+            <pc:docMk/>
+            <pc:sldMk cId="3294159094" sldId="274"/>
+            <ac:picMk id="4" creationId="{E9F50768-6799-4A54-63B2-C5691E3EB269}"/>
+          </ac:picMkLst>
+        </pc:picChg>
+        <pc:picChg chg="add mod">
+          <ac:chgData name="Dilan De Silva" userId="579b606d6e18a4ed" providerId="LiveId" clId="{55D98E11-54C8-4694-9916-6163FE05F5A8}" dt="2025-11-18T15:00:16.380" v="433" actId="1076"/>
+          <ac:picMkLst>
+            <pc:docMk/>
+            <pc:sldMk cId="3294159094" sldId="274"/>
+            <ac:picMk id="6" creationId="{9119BECF-185E-D7BE-C577-82F97E8525A5}"/>
+          </ac:picMkLst>
+        </pc:picChg>
+        <pc:picChg chg="add mod">
+          <ac:chgData name="Dilan De Silva" userId="579b606d6e18a4ed" providerId="LiveId" clId="{55D98E11-54C8-4694-9916-6163FE05F5A8}" dt="2025-11-18T15:00:51.091" v="440" actId="14100"/>
+          <ac:picMkLst>
+            <pc:docMk/>
+            <pc:sldMk cId="3294159094" sldId="274"/>
+            <ac:picMk id="8" creationId="{ECE6AE80-3F19-CCC6-F0AC-C01D860B7D0B}"/>
+          </ac:picMkLst>
+        </pc:picChg>
+        <pc:picChg chg="add">
+          <ac:chgData name="Dilan De Silva" userId="579b606d6e18a4ed" providerId="LiveId" clId="{55D98E11-54C8-4694-9916-6163FE05F5A8}" dt="2025-11-18T15:02:13.665" v="441" actId="22"/>
+          <ac:picMkLst>
+            <pc:docMk/>
+            <pc:sldMk cId="3294159094" sldId="274"/>
+            <ac:picMk id="10" creationId="{79823171-E320-AE26-F2B8-17716067C339}"/>
+          </ac:picMkLst>
+        </pc:picChg>
+        <pc:picChg chg="add del mod">
+          <ac:chgData name="Dilan De Silva" userId="579b606d6e18a4ed" providerId="LiveId" clId="{55D98E11-54C8-4694-9916-6163FE05F5A8}" dt="2025-11-18T15:03:06.402" v="444" actId="478"/>
+          <ac:picMkLst>
+            <pc:docMk/>
+            <pc:sldMk cId="3294159094" sldId="274"/>
+            <ac:picMk id="12" creationId="{6697C6AE-E6FD-913D-EF2C-9B0976CA3332}"/>
+          </ac:picMkLst>
+        </pc:picChg>
+        <pc:picChg chg="add mod">
+          <ac:chgData name="Dilan De Silva" userId="579b606d6e18a4ed" providerId="LiveId" clId="{55D98E11-54C8-4694-9916-6163FE05F5A8}" dt="2025-11-18T15:03:48.600" v="449" actId="1076"/>
+          <ac:picMkLst>
+            <pc:docMk/>
+            <pc:sldMk cId="3294159094" sldId="274"/>
+            <ac:picMk id="14" creationId="{4587CB42-F6A0-D31A-9C89-276867F34375}"/>
+          </ac:picMkLst>
+        </pc:picChg>
+        <pc:picChg chg="add mod">
+          <ac:chgData name="Dilan De Silva" userId="579b606d6e18a4ed" providerId="LiveId" clId="{55D98E11-54C8-4694-9916-6163FE05F5A8}" dt="2025-11-18T15:03:45.842" v="448" actId="1076"/>
+          <ac:picMkLst>
+            <pc:docMk/>
+            <pc:sldMk cId="3294159094" sldId="274"/>
+            <ac:picMk id="16" creationId="{75634E41-B956-EDEB-DC8A-ED777FB17081}"/>
+          </ac:picMkLst>
+        </pc:picChg>
+        <pc:picChg chg="del">
+          <ac:chgData name="Dilan De Silva" userId="579b606d6e18a4ed" providerId="LiveId" clId="{55D98E11-54C8-4694-9916-6163FE05F5A8}" dt="2025-11-18T14:59:34.308" v="418" actId="478"/>
+          <ac:picMkLst>
+            <pc:docMk/>
+            <pc:sldMk cId="3294159094" sldId="274"/>
+            <ac:picMk id="19" creationId="{DF571372-089D-AEF4-A7AA-EC64134F36D9}"/>
+          </ac:picMkLst>
+        </pc:picChg>
+        <pc:picChg chg="del mod">
+          <ac:chgData name="Dilan De Silva" userId="579b606d6e18a4ed" providerId="LiveId" clId="{55D98E11-54C8-4694-9916-6163FE05F5A8}" dt="2025-11-18T14:59:34.736" v="420" actId="478"/>
+          <ac:picMkLst>
+            <pc:docMk/>
+            <pc:sldMk cId="3294159094" sldId="274"/>
+            <ac:picMk id="21" creationId="{D80647B7-9FB0-1450-FA2F-6568D8680792}"/>
+          </ac:picMkLst>
+        </pc:picChg>
+        <pc:picChg chg="del">
+          <ac:chgData name="Dilan De Silva" userId="579b606d6e18a4ed" providerId="LiveId" clId="{55D98E11-54C8-4694-9916-6163FE05F5A8}" dt="2025-11-18T14:59:33.731" v="417" actId="478"/>
+          <ac:picMkLst>
+            <pc:docMk/>
+            <pc:sldMk cId="3294159094" sldId="274"/>
+            <ac:picMk id="23" creationId="{2916BF68-85A9-6F80-24AD-4BB7CE00C6B7}"/>
+          </ac:picMkLst>
+        </pc:picChg>
+        <pc:picChg chg="del">
+          <ac:chgData name="Dilan De Silva" userId="579b606d6e18a4ed" providerId="LiveId" clId="{55D98E11-54C8-4694-9916-6163FE05F5A8}" dt="2025-11-18T14:59:36.278" v="422" actId="478"/>
+          <ac:picMkLst>
+            <pc:docMk/>
+            <pc:sldMk cId="3294159094" sldId="274"/>
+            <ac:picMk id="25" creationId="{78FDC2E0-C919-8A7E-A947-B61F8D53B067}"/>
+          </ac:picMkLst>
+        </pc:picChg>
+        <pc:picChg chg="del mod">
+          <ac:chgData name="Dilan De Silva" userId="579b606d6e18a4ed" providerId="LiveId" clId="{55D98E11-54C8-4694-9916-6163FE05F5A8}" dt="2025-11-18T14:59:37.168" v="423" actId="478"/>
+          <ac:picMkLst>
+            <pc:docMk/>
+            <pc:sldMk cId="3294159094" sldId="274"/>
+            <ac:picMk id="27" creationId="{93875918-126F-043B-B311-A91F9BE585F1}"/>
+          </ac:picMkLst>
+        </pc:picChg>
+        <pc:picChg chg="del">
+          <ac:chgData name="Dilan De Silva" userId="579b606d6e18a4ed" providerId="LiveId" clId="{55D98E11-54C8-4694-9916-6163FE05F5A8}" dt="2025-11-18T14:59:37.751" v="424" actId="478"/>
+          <ac:picMkLst>
+            <pc:docMk/>
+            <pc:sldMk cId="3294159094" sldId="274"/>
+            <ac:picMk id="29" creationId="{D52AAD4D-C3E0-13B3-ACCC-30B0C623FF57}"/>
+          </ac:picMkLst>
+        </pc:picChg>
+        <pc:picChg chg="del">
+          <ac:chgData name="Dilan De Silva" userId="579b606d6e18a4ed" providerId="LiveId" clId="{55D98E11-54C8-4694-9916-6163FE05F5A8}" dt="2025-11-18T14:59:38.225" v="425" actId="478"/>
+          <ac:picMkLst>
+            <pc:docMk/>
+            <pc:sldMk cId="3294159094" sldId="274"/>
+            <ac:picMk id="31" creationId="{B22CEC20-3A62-0924-84B4-24077A5169DA}"/>
+          </ac:picMkLst>
+        </pc:picChg>
+      </pc:sldChg>
+      <pc:sldChg chg="addSp delSp modSp add del mod">
+        <pc:chgData name="Dilan De Silva" userId="579b606d6e18a4ed" providerId="LiveId" clId="{55D98E11-54C8-4694-9916-6163FE05F5A8}" dt="2025-11-18T14:45:34.903" v="381" actId="47"/>
+        <pc:sldMkLst>
+          <pc:docMk/>
+          <pc:sldMk cId="3400616727" sldId="274"/>
+        </pc:sldMkLst>
+        <pc:spChg chg="mod">
+          <ac:chgData name="Dilan De Silva" userId="579b606d6e18a4ed" providerId="LiveId" clId="{55D98E11-54C8-4694-9916-6163FE05F5A8}" dt="2025-11-18T13:21:51.515" v="255" actId="20577"/>
+          <ac:spMkLst>
+            <pc:docMk/>
+            <pc:sldMk cId="3400616727" sldId="274"/>
+            <ac:spMk id="2" creationId="{13DF482B-3A5C-F31E-1FFF-08A84F3CA5E4}"/>
+          </ac:spMkLst>
+        </pc:spChg>
+        <pc:picChg chg="add mod">
+          <ac:chgData name="Dilan De Silva" userId="579b606d6e18a4ed" providerId="LiveId" clId="{55D98E11-54C8-4694-9916-6163FE05F5A8}" dt="2025-11-18T13:34:04.169" v="271" actId="14100"/>
+          <ac:picMkLst>
+            <pc:docMk/>
+            <pc:sldMk cId="3400616727" sldId="274"/>
+            <ac:picMk id="4" creationId="{1DA65ED0-9B97-16BD-3E90-11AE86C37285}"/>
+          </ac:picMkLst>
+        </pc:picChg>
+        <pc:picChg chg="del">
+          <ac:chgData name="Dilan De Silva" userId="579b606d6e18a4ed" providerId="LiveId" clId="{55D98E11-54C8-4694-9916-6163FE05F5A8}" dt="2025-11-18T13:33:04.116" v="261" actId="478"/>
+          <ac:picMkLst>
+            <pc:docMk/>
+            <pc:sldMk cId="3400616727" sldId="274"/>
+            <ac:picMk id="5" creationId="{27D9AE12-B91B-A31F-07E8-432592BD9392}"/>
+          </ac:picMkLst>
+        </pc:picChg>
+        <pc:picChg chg="del mod">
+          <ac:chgData name="Dilan De Silva" userId="579b606d6e18a4ed" providerId="LiveId" clId="{55D98E11-54C8-4694-9916-6163FE05F5A8}" dt="2025-11-18T13:25:26.863" v="260" actId="478"/>
+          <ac:picMkLst>
+            <pc:docMk/>
+            <pc:sldMk cId="3400616727" sldId="274"/>
+            <ac:picMk id="7" creationId="{5664E1F3-176B-295F-34F5-E3CCDC4ED2F7}"/>
+          </ac:picMkLst>
+        </pc:picChg>
+        <pc:picChg chg="add mod">
+          <ac:chgData name="Dilan De Silva" userId="579b606d6e18a4ed" providerId="LiveId" clId="{55D98E11-54C8-4694-9916-6163FE05F5A8}" dt="2025-11-18T13:34:01.824" v="270" actId="1076"/>
+          <ac:picMkLst>
+            <pc:docMk/>
+            <pc:sldMk cId="3400616727" sldId="274"/>
+            <ac:picMk id="8" creationId="{C76D2F67-EBE2-FEE3-89A6-2480B852CD89}"/>
+          </ac:picMkLst>
+        </pc:picChg>
+        <pc:picChg chg="del">
+          <ac:chgData name="Dilan De Silva" userId="579b606d6e18a4ed" providerId="LiveId" clId="{55D98E11-54C8-4694-9916-6163FE05F5A8}" dt="2025-11-18T13:25:26.404" v="258" actId="478"/>
+          <ac:picMkLst>
+            <pc:docMk/>
+            <pc:sldMk cId="3400616727" sldId="274"/>
+            <ac:picMk id="9" creationId="{342F7655-C310-3904-6B72-A42169140367}"/>
+          </ac:picMkLst>
+        </pc:picChg>
+        <pc:picChg chg="del">
+          <ac:chgData name="Dilan De Silva" userId="579b606d6e18a4ed" providerId="LiveId" clId="{55D98E11-54C8-4694-9916-6163FE05F5A8}" dt="2025-11-18T13:25:24.531" v="256" actId="478"/>
+          <ac:picMkLst>
+            <pc:docMk/>
+            <pc:sldMk cId="3400616727" sldId="274"/>
+            <ac:picMk id="11" creationId="{97E2137B-0967-56AF-9501-980A6C3DED09}"/>
+          </ac:picMkLst>
+        </pc:picChg>
+        <pc:picChg chg="add mod">
+          <ac:chgData name="Dilan De Silva" userId="579b606d6e18a4ed" providerId="LiveId" clId="{55D98E11-54C8-4694-9916-6163FE05F5A8}" dt="2025-11-18T13:36:41.504" v="283" actId="1076"/>
+          <ac:picMkLst>
+            <pc:docMk/>
+            <pc:sldMk cId="3400616727" sldId="274"/>
+            <ac:picMk id="12" creationId="{C75EADFF-93E6-3BBC-4C31-3BE39431DD22}"/>
+          </ac:picMkLst>
+        </pc:picChg>
+        <pc:picChg chg="del">
+          <ac:chgData name="Dilan De Silva" userId="579b606d6e18a4ed" providerId="LiveId" clId="{55D98E11-54C8-4694-9916-6163FE05F5A8}" dt="2025-11-18T13:25:25.098" v="257" actId="478"/>
+          <ac:picMkLst>
+            <pc:docMk/>
+            <pc:sldMk cId="3400616727" sldId="274"/>
+            <ac:picMk id="13" creationId="{2B9E53B5-35F6-5EFB-7047-0E615A726A20}"/>
+          </ac:picMkLst>
+        </pc:picChg>
+        <pc:picChg chg="del">
+          <ac:chgData name="Dilan De Silva" userId="579b606d6e18a4ed" providerId="LiveId" clId="{55D98E11-54C8-4694-9916-6163FE05F5A8}" dt="2025-11-18T13:33:04.504" v="262" actId="478"/>
+          <ac:picMkLst>
+            <pc:docMk/>
+            <pc:sldMk cId="3400616727" sldId="274"/>
+            <ac:picMk id="15" creationId="{32BB8C26-265C-4FFD-6917-A67EBBFF706A}"/>
+          </ac:picMkLst>
+        </pc:picChg>
+        <pc:picChg chg="add mod">
+          <ac:chgData name="Dilan De Silva" userId="579b606d6e18a4ed" providerId="LiveId" clId="{55D98E11-54C8-4694-9916-6163FE05F5A8}" dt="2025-11-18T13:36:42.888" v="284" actId="1076"/>
+          <ac:picMkLst>
+            <pc:docMk/>
+            <pc:sldMk cId="3400616727" sldId="274"/>
+            <ac:picMk id="16" creationId="{0EA9B78C-99B3-B033-CC8D-F01932BDAF21}"/>
+          </ac:picMkLst>
+        </pc:picChg>
+        <pc:picChg chg="del">
+          <ac:chgData name="Dilan De Silva" userId="579b606d6e18a4ed" providerId="LiveId" clId="{55D98E11-54C8-4694-9916-6163FE05F5A8}" dt="2025-11-18T13:33:05.171" v="263" actId="478"/>
+          <ac:picMkLst>
+            <pc:docMk/>
+            <pc:sldMk cId="3400616727" sldId="274"/>
+            <ac:picMk id="17" creationId="{C67FD9C1-6E61-942F-F8B5-5EA6AF1D7C06}"/>
+          </ac:picMkLst>
+        </pc:picChg>
+        <pc:picChg chg="add mod">
+          <ac:chgData name="Dilan De Silva" userId="579b606d6e18a4ed" providerId="LiveId" clId="{55D98E11-54C8-4694-9916-6163FE05F5A8}" dt="2025-11-18T13:36:45.030" v="285" actId="1076"/>
+          <ac:picMkLst>
+            <pc:docMk/>
+            <pc:sldMk cId="3400616727" sldId="274"/>
+            <ac:picMk id="19" creationId="{27ACD590-6038-3350-26E2-68C0ADA2C3C9}"/>
+          </ac:picMkLst>
+        </pc:picChg>
+        <pc:picChg chg="add mod">
+          <ac:chgData name="Dilan De Silva" userId="579b606d6e18a4ed" providerId="LiveId" clId="{55D98E11-54C8-4694-9916-6163FE05F5A8}" dt="2025-11-18T13:37:45.449" v="290" actId="1076"/>
+          <ac:picMkLst>
+            <pc:docMk/>
+            <pc:sldMk cId="3400616727" sldId="274"/>
+            <ac:picMk id="21" creationId="{A2A7FE2A-36ED-6BAF-32E7-148630F219EB}"/>
+          </ac:picMkLst>
+        </pc:picChg>
+      </pc:sldChg>
+      <pc:sldChg chg="addSp delSp modSp add mod">
+        <pc:chgData name="Dilan De Silva" userId="579b606d6e18a4ed" providerId="LiveId" clId="{55D98E11-54C8-4694-9916-6163FE05F5A8}" dt="2025-11-18T15:11:50.510" v="476" actId="1076"/>
+        <pc:sldMkLst>
+          <pc:docMk/>
+          <pc:sldMk cId="56286589" sldId="275"/>
+        </pc:sldMkLst>
+        <pc:spChg chg="mod">
+          <ac:chgData name="Dilan De Silva" userId="579b606d6e18a4ed" providerId="LiveId" clId="{55D98E11-54C8-4694-9916-6163FE05F5A8}" dt="2025-11-18T15:07:53.789" v="452" actId="20577"/>
+          <ac:spMkLst>
+            <pc:docMk/>
+            <pc:sldMk cId="56286589" sldId="275"/>
+            <ac:spMk id="2" creationId="{5FBE89E3-D607-20A6-052B-6B9FA1840448}"/>
+          </ac:spMkLst>
+        </pc:spChg>
+        <pc:picChg chg="del mod">
+          <ac:chgData name="Dilan De Silva" userId="579b606d6e18a4ed" providerId="LiveId" clId="{55D98E11-54C8-4694-9916-6163FE05F5A8}" dt="2025-11-18T15:10:00.677" v="463" actId="478"/>
+          <ac:picMkLst>
+            <pc:docMk/>
+            <pc:sldMk cId="56286589" sldId="275"/>
+            <ac:picMk id="4" creationId="{33BF319E-D752-0627-5BA8-5D2814137C1C}"/>
+          </ac:picMkLst>
+        </pc:picChg>
+        <pc:picChg chg="add mod">
+          <ac:chgData name="Dilan De Silva" userId="579b606d6e18a4ed" providerId="LiveId" clId="{55D98E11-54C8-4694-9916-6163FE05F5A8}" dt="2025-11-18T15:09:39.711" v="460" actId="1076"/>
+          <ac:picMkLst>
+            <pc:docMk/>
+            <pc:sldMk cId="56286589" sldId="275"/>
+            <ac:picMk id="5" creationId="{354426C8-CA7F-B716-6ED4-DA78D16685A5}"/>
+          </ac:picMkLst>
+        </pc:picChg>
+        <pc:picChg chg="del mod">
+          <ac:chgData name="Dilan De Silva" userId="579b606d6e18a4ed" providerId="LiveId" clId="{55D98E11-54C8-4694-9916-6163FE05F5A8}" dt="2025-11-18T15:10:16.292" v="468" actId="478"/>
+          <ac:picMkLst>
+            <pc:docMk/>
+            <pc:sldMk cId="56286589" sldId="275"/>
+            <ac:picMk id="6" creationId="{0453F973-2509-8A0E-2649-7D4C344E8E25}"/>
+          </ac:picMkLst>
+        </pc:picChg>
+        <pc:picChg chg="del">
+          <ac:chgData name="Dilan De Silva" userId="579b606d6e18a4ed" providerId="LiveId" clId="{55D98E11-54C8-4694-9916-6163FE05F5A8}" dt="2025-11-18T15:07:55.781" v="453" actId="478"/>
+          <ac:picMkLst>
+            <pc:docMk/>
+            <pc:sldMk cId="56286589" sldId="275"/>
+            <ac:picMk id="8" creationId="{244E2CA5-187E-0830-C0A7-B169AB3414EC}"/>
+          </ac:picMkLst>
+        </pc:picChg>
+        <pc:picChg chg="add mod">
+          <ac:chgData name="Dilan De Silva" userId="579b606d6e18a4ed" providerId="LiveId" clId="{55D98E11-54C8-4694-9916-6163FE05F5A8}" dt="2025-11-18T15:10:38.790" v="472" actId="14100"/>
+          <ac:picMkLst>
+            <pc:docMk/>
+            <pc:sldMk cId="56286589" sldId="275"/>
+            <ac:picMk id="9" creationId="{3A10A73E-7DE7-E133-19DF-BE8FCDAF3130}"/>
+          </ac:picMkLst>
+        </pc:picChg>
+        <pc:picChg chg="del">
+          <ac:chgData name="Dilan De Silva" userId="579b606d6e18a4ed" providerId="LiveId" clId="{55D98E11-54C8-4694-9916-6163FE05F5A8}" dt="2025-11-18T15:07:58.408" v="454" actId="478"/>
+          <ac:picMkLst>
+            <pc:docMk/>
+            <pc:sldMk cId="56286589" sldId="275"/>
+            <ac:picMk id="10" creationId="{525BF96E-AFF9-6CC5-0A74-DFE506627C16}"/>
+          </ac:picMkLst>
+        </pc:picChg>
+        <pc:picChg chg="add mod">
+          <ac:chgData name="Dilan De Silva" userId="579b606d6e18a4ed" providerId="LiveId" clId="{55D98E11-54C8-4694-9916-6163FE05F5A8}" dt="2025-11-18T15:10:40.708" v="473" actId="14100"/>
+          <ac:picMkLst>
+            <pc:docMk/>
+            <pc:sldMk cId="56286589" sldId="275"/>
+            <ac:picMk id="12" creationId="{2ACB8EC5-F22B-E91B-789D-B1A7EE770F43}"/>
+          </ac:picMkLst>
+        </pc:picChg>
+        <pc:picChg chg="del">
+          <ac:chgData name="Dilan De Silva" userId="579b606d6e18a4ed" providerId="LiveId" clId="{55D98E11-54C8-4694-9916-6163FE05F5A8}" dt="2025-11-18T15:07:58.728" v="455" actId="478"/>
+          <ac:picMkLst>
+            <pc:docMk/>
+            <pc:sldMk cId="56286589" sldId="275"/>
+            <ac:picMk id="14" creationId="{FA320303-85A9-8142-E5F9-0365A3EB37E2}"/>
+          </ac:picMkLst>
+        </pc:picChg>
+        <pc:picChg chg="add">
+          <ac:chgData name="Dilan De Silva" userId="579b606d6e18a4ed" providerId="LiveId" clId="{55D98E11-54C8-4694-9916-6163FE05F5A8}" dt="2025-11-18T15:11:20.303" v="474" actId="22"/>
+          <ac:picMkLst>
+            <pc:docMk/>
+            <pc:sldMk cId="56286589" sldId="275"/>
+            <ac:picMk id="15" creationId="{C384A4D8-1E66-2666-636D-37B93779702C}"/>
+          </ac:picMkLst>
+        </pc:picChg>
+        <pc:picChg chg="del mod">
+          <ac:chgData name="Dilan De Silva" userId="579b606d6e18a4ed" providerId="LiveId" clId="{55D98E11-54C8-4694-9916-6163FE05F5A8}" dt="2025-11-18T15:07:59.438" v="457" actId="478"/>
+          <ac:picMkLst>
+            <pc:docMk/>
+            <pc:sldMk cId="56286589" sldId="275"/>
+            <ac:picMk id="16" creationId="{CA07565E-EDF7-4F21-2265-8B6F2EDC2B63}"/>
+          </ac:picMkLst>
+        </pc:picChg>
+        <pc:picChg chg="add mod">
+          <ac:chgData name="Dilan De Silva" userId="579b606d6e18a4ed" providerId="LiveId" clId="{55D98E11-54C8-4694-9916-6163FE05F5A8}" dt="2025-11-18T15:11:50.510" v="476" actId="1076"/>
+          <ac:picMkLst>
+            <pc:docMk/>
+            <pc:sldMk cId="56286589" sldId="275"/>
+            <ac:picMk id="18" creationId="{3042E0C0-52F6-E26F-9AA2-924F04627D55}"/>
+          </ac:picMkLst>
+        </pc:picChg>
+      </pc:sldChg>
+      <pc:sldChg chg="addSp delSp modSp add del mod">
+        <pc:chgData name="Dilan De Silva" userId="579b606d6e18a4ed" providerId="LiveId" clId="{55D98E11-54C8-4694-9916-6163FE05F5A8}" dt="2025-11-18T14:45:18.467" v="377" actId="47"/>
+        <pc:sldMkLst>
+          <pc:docMk/>
+          <pc:sldMk cId="1137419255" sldId="275"/>
+        </pc:sldMkLst>
+        <pc:spChg chg="mod">
+          <ac:chgData name="Dilan De Silva" userId="579b606d6e18a4ed" providerId="LiveId" clId="{55D98E11-54C8-4694-9916-6163FE05F5A8}" dt="2025-11-18T13:38:14.479" v="293" actId="20577"/>
+          <ac:spMkLst>
+            <pc:docMk/>
+            <pc:sldMk cId="1137419255" sldId="275"/>
+            <ac:spMk id="2" creationId="{60D486AD-39A8-74F8-2956-49DF304B40F2}"/>
+          </ac:spMkLst>
+        </pc:spChg>
+        <pc:picChg chg="del">
+          <ac:chgData name="Dilan De Silva" userId="579b606d6e18a4ed" providerId="LiveId" clId="{55D98E11-54C8-4694-9916-6163FE05F5A8}" dt="2025-11-18T13:38:17.408" v="294" actId="478"/>
+          <ac:picMkLst>
+            <pc:docMk/>
+            <pc:sldMk cId="1137419255" sldId="275"/>
+            <ac:picMk id="4" creationId="{644B961F-960D-442D-CA9F-8D730B02C2C0}"/>
+          </ac:picMkLst>
+        </pc:picChg>
+        <pc:picChg chg="add mod">
+          <ac:chgData name="Dilan De Silva" userId="579b606d6e18a4ed" providerId="LiveId" clId="{55D98E11-54C8-4694-9916-6163FE05F5A8}" dt="2025-11-18T13:42:13.405" v="305" actId="14100"/>
+          <ac:picMkLst>
+            <pc:docMk/>
+            <pc:sldMk cId="1137419255" sldId="275"/>
+            <ac:picMk id="5" creationId="{A7D5A21F-0FED-18FF-475B-A0830780355B}"/>
+          </ac:picMkLst>
+        </pc:picChg>
+        <pc:picChg chg="add mod">
+          <ac:chgData name="Dilan De Silva" userId="579b606d6e18a4ed" providerId="LiveId" clId="{55D98E11-54C8-4694-9916-6163FE05F5A8}" dt="2025-11-18T13:42:31.889" v="309" actId="1076"/>
+          <ac:picMkLst>
+            <pc:docMk/>
+            <pc:sldMk cId="1137419255" sldId="275"/>
+            <ac:picMk id="7" creationId="{6B806B24-58AE-D68C-92B1-B5954A6E4BFE}"/>
+          </ac:picMkLst>
+        </pc:picChg>
+        <pc:picChg chg="del">
+          <ac:chgData name="Dilan De Silva" userId="579b606d6e18a4ed" providerId="LiveId" clId="{55D98E11-54C8-4694-9916-6163FE05F5A8}" dt="2025-11-18T13:38:18.001" v="295" actId="478"/>
+          <ac:picMkLst>
+            <pc:docMk/>
+            <pc:sldMk cId="1137419255" sldId="275"/>
+            <ac:picMk id="8" creationId="{D09C1980-0ED7-6F60-C699-CF334BAE3715}"/>
+          </ac:picMkLst>
+        </pc:picChg>
+        <pc:picChg chg="add mod">
+          <ac:chgData name="Dilan De Silva" userId="579b606d6e18a4ed" providerId="LiveId" clId="{55D98E11-54C8-4694-9916-6163FE05F5A8}" dt="2025-11-18T13:42:55.612" v="313" actId="1076"/>
+          <ac:picMkLst>
+            <pc:docMk/>
+            <pc:sldMk cId="1137419255" sldId="275"/>
+            <ac:picMk id="10" creationId="{62EAF89A-7790-BDA2-79D2-3C2366F2CE72}"/>
+          </ac:picMkLst>
+        </pc:picChg>
+        <pc:picChg chg="del">
+          <ac:chgData name="Dilan De Silva" userId="579b606d6e18a4ed" providerId="LiveId" clId="{55D98E11-54C8-4694-9916-6163FE05F5A8}" dt="2025-11-18T13:38:18.405" v="296" actId="478"/>
+          <ac:picMkLst>
+            <pc:docMk/>
+            <pc:sldMk cId="1137419255" sldId="275"/>
+            <ac:picMk id="12" creationId="{78D421F0-7E48-BAFF-12A4-006CFF9FB64B}"/>
+          </ac:picMkLst>
+        </pc:picChg>
+        <pc:picChg chg="add mod">
+          <ac:chgData name="Dilan De Silva" userId="579b606d6e18a4ed" providerId="LiveId" clId="{55D98E11-54C8-4694-9916-6163FE05F5A8}" dt="2025-11-18T13:44:19.779" v="321" actId="1076"/>
+          <ac:picMkLst>
+            <pc:docMk/>
+            <pc:sldMk cId="1137419255" sldId="275"/>
+            <ac:picMk id="13" creationId="{F86D7D82-5193-9C37-8ADE-D2A8EF410F8A}"/>
+          </ac:picMkLst>
+        </pc:picChg>
+        <pc:picChg chg="add mod modCrop">
+          <ac:chgData name="Dilan De Silva" userId="579b606d6e18a4ed" providerId="LiveId" clId="{55D98E11-54C8-4694-9916-6163FE05F5A8}" dt="2025-11-18T13:44:18.230" v="320" actId="1076"/>
+          <ac:picMkLst>
+            <pc:docMk/>
+            <pc:sldMk cId="1137419255" sldId="275"/>
+            <ac:picMk id="15" creationId="{58A8F708-1404-85BF-8554-2B310FE5620F}"/>
+          </ac:picMkLst>
+        </pc:picChg>
+        <pc:picChg chg="del">
+          <ac:chgData name="Dilan De Silva" userId="579b606d6e18a4ed" providerId="LiveId" clId="{55D98E11-54C8-4694-9916-6163FE05F5A8}" dt="2025-11-18T13:38:19.576" v="297" actId="478"/>
+          <ac:picMkLst>
+            <pc:docMk/>
+            <pc:sldMk cId="1137419255" sldId="275"/>
+            <ac:picMk id="16" creationId="{8C590D16-42AC-98C5-39F8-7C63AA25D0A7}"/>
+          </ac:picMkLst>
+        </pc:picChg>
+        <pc:picChg chg="del mod">
+          <ac:chgData name="Dilan De Silva" userId="579b606d6e18a4ed" providerId="LiveId" clId="{55D98E11-54C8-4694-9916-6163FE05F5A8}" dt="2025-11-18T13:38:20.499" v="299" actId="478"/>
+          <ac:picMkLst>
+            <pc:docMk/>
+            <pc:sldMk cId="1137419255" sldId="275"/>
+            <ac:picMk id="19" creationId="{0E33D871-CF9B-0E5A-983F-11BE4CCCF27A}"/>
+          </ac:picMkLst>
+        </pc:picChg>
+        <pc:picChg chg="del mod">
+          <ac:chgData name="Dilan De Silva" userId="579b606d6e18a4ed" providerId="LiveId" clId="{55D98E11-54C8-4694-9916-6163FE05F5A8}" dt="2025-11-18T13:38:21.467" v="301" actId="478"/>
+          <ac:picMkLst>
+            <pc:docMk/>
+            <pc:sldMk cId="1137419255" sldId="275"/>
+            <ac:picMk id="21" creationId="{995B9864-C810-4DC6-AB8F-AA9F01F20A3E}"/>
+          </ac:picMkLst>
+        </pc:picChg>
+      </pc:sldChg>
+      <pc:sldChg chg="addSp delSp modSp add del mod">
+        <pc:chgData name="Dilan De Silva" userId="579b606d6e18a4ed" providerId="LiveId" clId="{55D98E11-54C8-4694-9916-6163FE05F5A8}" dt="2025-11-18T14:45:19.922" v="378" actId="47"/>
+        <pc:sldMkLst>
+          <pc:docMk/>
+          <pc:sldMk cId="30245650" sldId="276"/>
+        </pc:sldMkLst>
+        <pc:spChg chg="mod">
+          <ac:chgData name="Dilan De Silva" userId="579b606d6e18a4ed" providerId="LiveId" clId="{55D98E11-54C8-4694-9916-6163FE05F5A8}" dt="2025-11-18T13:47:36.325" v="324" actId="20577"/>
+          <ac:spMkLst>
+            <pc:docMk/>
+            <pc:sldMk cId="30245650" sldId="276"/>
+            <ac:spMk id="2" creationId="{512051E6-A6D3-9D2E-795C-1C0CC7AE922D}"/>
+          </ac:spMkLst>
+        </pc:spChg>
+        <pc:picChg chg="add mod">
+          <ac:chgData name="Dilan De Silva" userId="579b606d6e18a4ed" providerId="LiveId" clId="{55D98E11-54C8-4694-9916-6163FE05F5A8}" dt="2025-11-18T13:47:43.774" v="329" actId="14100"/>
+          <ac:picMkLst>
+            <pc:docMk/>
+            <pc:sldMk cId="30245650" sldId="276"/>
+            <ac:picMk id="4" creationId="{B47AECAD-F98D-7C3A-DFA7-1BF4A0B43F10}"/>
+          </ac:picMkLst>
+        </pc:picChg>
+        <pc:picChg chg="del">
+          <ac:chgData name="Dilan De Silva" userId="579b606d6e18a4ed" providerId="LiveId" clId="{55D98E11-54C8-4694-9916-6163FE05F5A8}" dt="2025-11-18T13:47:37.910" v="325" actId="478"/>
+          <ac:picMkLst>
+            <pc:docMk/>
+            <pc:sldMk cId="30245650" sldId="276"/>
+            <ac:picMk id="5" creationId="{90B9B432-17DD-DADB-B759-69EA70AD8B32}"/>
+          </ac:picMkLst>
+        </pc:picChg>
+        <pc:picChg chg="del">
+          <ac:chgData name="Dilan De Silva" userId="579b606d6e18a4ed" providerId="LiveId" clId="{55D98E11-54C8-4694-9916-6163FE05F5A8}" dt="2025-11-18T13:47:38.279" v="326" actId="478"/>
+          <ac:picMkLst>
+            <pc:docMk/>
+            <pc:sldMk cId="30245650" sldId="276"/>
+            <ac:picMk id="7" creationId="{EC4C0367-030A-E5A7-16EB-F12750DE5B10}"/>
+          </ac:picMkLst>
+        </pc:picChg>
+        <pc:picChg chg="add mod">
+          <ac:chgData name="Dilan De Silva" userId="579b606d6e18a4ed" providerId="LiveId" clId="{55D98E11-54C8-4694-9916-6163FE05F5A8}" dt="2025-11-18T13:48:07.300" v="334" actId="14100"/>
+          <ac:picMkLst>
+            <pc:docMk/>
+            <pc:sldMk cId="30245650" sldId="276"/>
+            <ac:picMk id="8" creationId="{2A6AD7A5-557E-320A-7B2D-C60D1CD1F360}"/>
+          </ac:picMkLst>
+        </pc:picChg>
+        <pc:picChg chg="add mod">
+          <ac:chgData name="Dilan De Silva" userId="579b606d6e18a4ed" providerId="LiveId" clId="{55D98E11-54C8-4694-9916-6163FE05F5A8}" dt="2025-11-18T13:49:24.331" v="338" actId="1076"/>
+          <ac:picMkLst>
+            <pc:docMk/>
+            <pc:sldMk cId="30245650" sldId="276"/>
+            <ac:picMk id="11" creationId="{6FEF2022-BE9B-4355-901B-8E256D14CBE2}"/>
+          </ac:picMkLst>
+        </pc:picChg>
+        <pc:picChg chg="del">
+          <ac:chgData name="Dilan De Silva" userId="579b606d6e18a4ed" providerId="LiveId" clId="{55D98E11-54C8-4694-9916-6163FE05F5A8}" dt="2025-11-18T13:48:30.541" v="335" actId="478"/>
+          <ac:picMkLst>
+            <pc:docMk/>
+            <pc:sldMk cId="30245650" sldId="276"/>
+            <ac:picMk id="13" creationId="{C9840785-2C64-2E6F-5663-BFE1091BA336}"/>
+          </ac:picMkLst>
+        </pc:picChg>
+        <pc:picChg chg="del">
+          <ac:chgData name="Dilan De Silva" userId="579b606d6e18a4ed" providerId="LiveId" clId="{55D98E11-54C8-4694-9916-6163FE05F5A8}" dt="2025-11-18T13:48:30.994" v="336" actId="478"/>
+          <ac:picMkLst>
+            <pc:docMk/>
+            <pc:sldMk cId="30245650" sldId="276"/>
+            <ac:picMk id="15" creationId="{A453E5E6-8F65-EDF7-17AD-DF1CA6D4282F}"/>
+          </ac:picMkLst>
+        </pc:picChg>
+      </pc:sldChg>
+      <pc:sldChg chg="addSp delSp modSp add mod">
+        <pc:chgData name="Dilan De Silva" userId="579b606d6e18a4ed" providerId="LiveId" clId="{55D98E11-54C8-4694-9916-6163FE05F5A8}" dt="2025-11-18T15:20:32.751" v="499" actId="22"/>
+        <pc:sldMkLst>
+          <pc:docMk/>
+          <pc:sldMk cId="4262127971" sldId="276"/>
+        </pc:sldMkLst>
+        <pc:spChg chg="mod">
+          <ac:chgData name="Dilan De Silva" userId="579b606d6e18a4ed" providerId="LiveId" clId="{55D98E11-54C8-4694-9916-6163FE05F5A8}" dt="2025-11-18T15:18:20.722" v="479" actId="20577"/>
+          <ac:spMkLst>
+            <pc:docMk/>
+            <pc:sldMk cId="4262127971" sldId="276"/>
+            <ac:spMk id="2" creationId="{9DBFAC5B-B282-5B20-E8A6-932852798C62}"/>
+          </ac:spMkLst>
+        </pc:spChg>
+        <pc:picChg chg="add mod">
+          <ac:chgData name="Dilan De Silva" userId="579b606d6e18a4ed" providerId="LiveId" clId="{55D98E11-54C8-4694-9916-6163FE05F5A8}" dt="2025-11-18T15:19:01.343" v="483" actId="14100"/>
+          <ac:picMkLst>
+            <pc:docMk/>
+            <pc:sldMk cId="4262127971" sldId="276"/>
+            <ac:picMk id="4" creationId="{13967056-D28F-30A2-BB73-38E511074B4B}"/>
+          </ac:picMkLst>
+        </pc:picChg>
+        <pc:picChg chg="del">
+          <ac:chgData name="Dilan De Silva" userId="579b606d6e18a4ed" providerId="LiveId" clId="{55D98E11-54C8-4694-9916-6163FE05F5A8}" dt="2025-11-18T15:18:22.387" v="480" actId="478"/>
+          <ac:picMkLst>
+            <pc:docMk/>
+            <pc:sldMk cId="4262127971" sldId="276"/>
+            <ac:picMk id="5" creationId="{CBCE6900-5243-069B-823A-F6B9ACF6BF50}"/>
+          </ac:picMkLst>
+        </pc:picChg>
+        <pc:picChg chg="add mod">
+          <ac:chgData name="Dilan De Silva" userId="579b606d6e18a4ed" providerId="LiveId" clId="{55D98E11-54C8-4694-9916-6163FE05F5A8}" dt="2025-11-18T15:19:55.192" v="496" actId="14100"/>
+          <ac:picMkLst>
+            <pc:docMk/>
+            <pc:sldMk cId="4262127971" sldId="276"/>
+            <ac:picMk id="7" creationId="{54E9097A-8445-B51C-D237-E7636AB5443D}"/>
+          </ac:picMkLst>
+        </pc:picChg>
+        <pc:picChg chg="del">
+          <ac:chgData name="Dilan De Silva" userId="579b606d6e18a4ed" providerId="LiveId" clId="{55D98E11-54C8-4694-9916-6163FE05F5A8}" dt="2025-11-18T15:19:02.972" v="484" actId="478"/>
+          <ac:picMkLst>
+            <pc:docMk/>
+            <pc:sldMk cId="4262127971" sldId="276"/>
+            <ac:picMk id="9" creationId="{E5A7E2C1-F0D2-5D77-E2C3-91F8B080682D}"/>
+          </ac:picMkLst>
+        </pc:picChg>
+        <pc:picChg chg="add mod">
+          <ac:chgData name="Dilan De Silva" userId="579b606d6e18a4ed" providerId="LiveId" clId="{55D98E11-54C8-4694-9916-6163FE05F5A8}" dt="2025-11-18T15:19:52.164" v="495" actId="14100"/>
+          <ac:picMkLst>
+            <pc:docMk/>
+            <pc:sldMk cId="4262127971" sldId="276"/>
+            <ac:picMk id="10" creationId="{E94241EB-BAD5-C185-348F-6F75788546D8}"/>
+          </ac:picMkLst>
+        </pc:picChg>
+        <pc:picChg chg="del">
+          <ac:chgData name="Dilan De Silva" userId="579b606d6e18a4ed" providerId="LiveId" clId="{55D98E11-54C8-4694-9916-6163FE05F5A8}" dt="2025-11-18T15:19:04.114" v="485" actId="478"/>
+          <ac:picMkLst>
+            <pc:docMk/>
+            <pc:sldMk cId="4262127971" sldId="276"/>
+            <ac:picMk id="12" creationId="{2E5812CB-B71A-0F39-2013-042A3A57B108}"/>
+          </ac:picMkLst>
+        </pc:picChg>
+        <pc:picChg chg="add">
+          <ac:chgData name="Dilan De Silva" userId="579b606d6e18a4ed" providerId="LiveId" clId="{55D98E11-54C8-4694-9916-6163FE05F5A8}" dt="2025-11-18T15:20:32.751" v="499" actId="22"/>
+          <ac:picMkLst>
+            <pc:docMk/>
+            <pc:sldMk cId="4262127971" sldId="276"/>
+            <ac:picMk id="13" creationId="{B2AAEA27-D0F5-F2A4-B9CA-217A8DC1B574}"/>
+          </ac:picMkLst>
+        </pc:picChg>
+        <pc:picChg chg="del">
+          <ac:chgData name="Dilan De Silva" userId="579b606d6e18a4ed" providerId="LiveId" clId="{55D98E11-54C8-4694-9916-6163FE05F5A8}" dt="2025-11-18T15:19:57.560" v="497" actId="478"/>
+          <ac:picMkLst>
+            <pc:docMk/>
+            <pc:sldMk cId="4262127971" sldId="276"/>
+            <ac:picMk id="15" creationId="{9290B80D-E9E8-4FEE-0E8B-FA7747CD9836}"/>
+          </ac:picMkLst>
+        </pc:picChg>
+        <pc:picChg chg="del">
+          <ac:chgData name="Dilan De Silva" userId="579b606d6e18a4ed" providerId="LiveId" clId="{55D98E11-54C8-4694-9916-6163FE05F5A8}" dt="2025-11-18T15:19:57.880" v="498" actId="478"/>
+          <ac:picMkLst>
+            <pc:docMk/>
+            <pc:sldMk cId="4262127971" sldId="276"/>
+            <ac:picMk id="18" creationId="{17BA4B36-2A50-FE46-7B56-DFCD55727E38}"/>
+          </ac:picMkLst>
+        </pc:picChg>
+      </pc:sldChg>
+      <pc:sldChg chg="addSp delSp modSp add del mod">
+        <pc:chgData name="Dilan De Silva" userId="579b606d6e18a4ed" providerId="LiveId" clId="{55D98E11-54C8-4694-9916-6163FE05F5A8}" dt="2025-11-18T14:45:22.225" v="380" actId="47"/>
+        <pc:sldMkLst>
+          <pc:docMk/>
+          <pc:sldMk cId="2880977522" sldId="277"/>
+        </pc:sldMkLst>
+        <pc:spChg chg="mod">
+          <ac:chgData name="Dilan De Silva" userId="579b606d6e18a4ed" providerId="LiveId" clId="{55D98E11-54C8-4694-9916-6163FE05F5A8}" dt="2025-11-18T13:54:06.389" v="341" actId="20577"/>
+          <ac:spMkLst>
+            <pc:docMk/>
+            <pc:sldMk cId="2880977522" sldId="277"/>
+            <ac:spMk id="2" creationId="{5DBD4253-BF2C-0093-8B26-760FBA92B911}"/>
+          </ac:spMkLst>
+        </pc:spChg>
+        <pc:picChg chg="del">
+          <ac:chgData name="Dilan De Silva" userId="579b606d6e18a4ed" providerId="LiveId" clId="{55D98E11-54C8-4694-9916-6163FE05F5A8}" dt="2025-11-18T13:55:01.546" v="342" actId="478"/>
+          <ac:picMkLst>
+            <pc:docMk/>
+            <pc:sldMk cId="2880977522" sldId="277"/>
+            <ac:picMk id="4" creationId="{8419BAC0-E262-4D60-CBB2-8068551C1962}"/>
+          </ac:picMkLst>
+        </pc:picChg>
+        <pc:picChg chg="add mod">
+          <ac:chgData name="Dilan De Silva" userId="579b606d6e18a4ed" providerId="LiveId" clId="{55D98E11-54C8-4694-9916-6163FE05F5A8}" dt="2025-11-18T13:55:49.721" v="354" actId="14100"/>
+          <ac:picMkLst>
+            <pc:docMk/>
+            <pc:sldMk cId="2880977522" sldId="277"/>
+            <ac:picMk id="5" creationId="{5DD306C6-3F97-E92C-6881-FFADC906BFC3}"/>
+          </ac:picMkLst>
+        </pc:picChg>
+        <pc:picChg chg="add mod">
+          <ac:chgData name="Dilan De Silva" userId="579b606d6e18a4ed" providerId="LiveId" clId="{55D98E11-54C8-4694-9916-6163FE05F5A8}" dt="2025-11-18T13:55:48.062" v="353" actId="14100"/>
+          <ac:picMkLst>
+            <pc:docMk/>
+            <pc:sldMk cId="2880977522" sldId="277"/>
+            <ac:picMk id="7" creationId="{3974DF46-ABBE-6A1D-2FCA-CA3E75D3F284}"/>
+          </ac:picMkLst>
+        </pc:picChg>
+        <pc:picChg chg="del">
+          <ac:chgData name="Dilan De Silva" userId="579b606d6e18a4ed" providerId="LiveId" clId="{55D98E11-54C8-4694-9916-6163FE05F5A8}" dt="2025-11-18T13:55:02.732" v="343" actId="478"/>
+          <ac:picMkLst>
+            <pc:docMk/>
+            <pc:sldMk cId="2880977522" sldId="277"/>
+            <ac:picMk id="8" creationId="{059CBED1-5CFE-B695-C491-425B4C224999}"/>
+          </ac:picMkLst>
+        </pc:picChg>
+        <pc:picChg chg="add mod">
+          <ac:chgData name="Dilan De Silva" userId="579b606d6e18a4ed" providerId="LiveId" clId="{55D98E11-54C8-4694-9916-6163FE05F5A8}" dt="2025-11-18T13:55:56.619" v="355"/>
+          <ac:picMkLst>
+            <pc:docMk/>
+            <pc:sldMk cId="2880977522" sldId="277"/>
+            <ac:picMk id="9" creationId="{7220AD0D-CE6E-CA59-E853-473157FF107D}"/>
+          </ac:picMkLst>
+        </pc:picChg>
+        <pc:picChg chg="del">
+          <ac:chgData name="Dilan De Silva" userId="579b606d6e18a4ed" providerId="LiveId" clId="{55D98E11-54C8-4694-9916-6163FE05F5A8}" dt="2025-11-18T13:55:03.396" v="344" actId="478"/>
+          <ac:picMkLst>
+            <pc:docMk/>
+            <pc:sldMk cId="2880977522" sldId="277"/>
+            <ac:picMk id="10" creationId="{D5257359-DA05-ED60-9964-5C8D5100C421}"/>
+          </ac:picMkLst>
+        </pc:picChg>
+        <pc:picChg chg="del">
+          <ac:chgData name="Dilan De Silva" userId="579b606d6e18a4ed" providerId="LiveId" clId="{55D98E11-54C8-4694-9916-6163FE05F5A8}" dt="2025-11-18T13:55:04.015" v="345" actId="478"/>
+          <ac:picMkLst>
+            <pc:docMk/>
+            <pc:sldMk cId="2880977522" sldId="277"/>
+            <ac:picMk id="11" creationId="{FE34A72D-0B47-46E2-BE0B-F7A519B67769}"/>
+          </ac:picMkLst>
+        </pc:picChg>
+        <pc:picChg chg="add mod">
+          <ac:chgData name="Dilan De Silva" userId="579b606d6e18a4ed" providerId="LiveId" clId="{55D98E11-54C8-4694-9916-6163FE05F5A8}" dt="2025-11-18T13:56:28.561" v="357" actId="1076"/>
+          <ac:picMkLst>
+            <pc:docMk/>
+            <pc:sldMk cId="2880977522" sldId="277"/>
+            <ac:picMk id="13" creationId="{6F4462C9-021A-A939-7451-59B00FFA936F}"/>
+          </ac:picMkLst>
+        </pc:picChg>
+      </pc:sldChg>
+      <pc:sldChg chg="addSp delSp modSp add mod">
+        <pc:chgData name="Dilan De Silva" userId="579b606d6e18a4ed" providerId="LiveId" clId="{55D98E11-54C8-4694-9916-6163FE05F5A8}" dt="2025-11-18T15:41:36.485" v="529" actId="1076"/>
+        <pc:sldMkLst>
+          <pc:docMk/>
+          <pc:sldMk cId="3453003941" sldId="277"/>
+        </pc:sldMkLst>
+        <pc:spChg chg="mod">
+          <ac:chgData name="Dilan De Silva" userId="579b606d6e18a4ed" providerId="LiveId" clId="{55D98E11-54C8-4694-9916-6163FE05F5A8}" dt="2025-11-18T15:31:51.044" v="504" actId="20577"/>
+          <ac:spMkLst>
+            <pc:docMk/>
+            <pc:sldMk cId="3453003941" sldId="277"/>
+            <ac:spMk id="2" creationId="{FD2E5C85-1145-4179-6CE7-1B7ECD323635}"/>
+          </ac:spMkLst>
+        </pc:spChg>
+        <pc:picChg chg="del">
+          <ac:chgData name="Dilan De Silva" userId="579b606d6e18a4ed" providerId="LiveId" clId="{55D98E11-54C8-4694-9916-6163FE05F5A8}" dt="2025-11-18T15:31:54.104" v="509" actId="478"/>
+          <ac:picMkLst>
+            <pc:docMk/>
+            <pc:sldMk cId="3453003941" sldId="277"/>
+            <ac:picMk id="4" creationId="{DD387F5A-229B-5C6E-17F9-032855022497}"/>
+          </ac:picMkLst>
+        </pc:picChg>
+        <pc:picChg chg="add mod">
+          <ac:chgData name="Dilan De Silva" userId="579b606d6e18a4ed" providerId="LiveId" clId="{55D98E11-54C8-4694-9916-6163FE05F5A8}" dt="2025-11-18T15:39:13.812" v="522" actId="14100"/>
+          <ac:picMkLst>
+            <pc:docMk/>
+            <pc:sldMk cId="3453003941" sldId="277"/>
+            <ac:picMk id="5" creationId="{FB760F3A-65E4-C787-8B84-B12F934A2655}"/>
+          </ac:picMkLst>
+        </pc:picChg>
+        <pc:picChg chg="del">
+          <ac:chgData name="Dilan De Silva" userId="579b606d6e18a4ed" providerId="LiveId" clId="{55D98E11-54C8-4694-9916-6163FE05F5A8}" dt="2025-11-18T15:31:52.427" v="505" actId="478"/>
+          <ac:picMkLst>
+            <pc:docMk/>
+            <pc:sldMk cId="3453003941" sldId="277"/>
+            <ac:picMk id="7" creationId="{FB7D893A-8E6F-0008-5241-67B2CFD9A904}"/>
+          </ac:picMkLst>
+        </pc:picChg>
+        <pc:picChg chg="add mod">
+          <ac:chgData name="Dilan De Silva" userId="579b606d6e18a4ed" providerId="LiveId" clId="{55D98E11-54C8-4694-9916-6163FE05F5A8}" dt="2025-11-18T15:39:09.894" v="520" actId="14100"/>
+          <ac:picMkLst>
+            <pc:docMk/>
+            <pc:sldMk cId="3453003941" sldId="277"/>
+            <ac:picMk id="8" creationId="{6F447E60-9BB6-26BA-0C5C-C52BD1F88047}"/>
+          </ac:picMkLst>
+        </pc:picChg>
+        <pc:picChg chg="del mod">
+          <ac:chgData name="Dilan De Silva" userId="579b606d6e18a4ed" providerId="LiveId" clId="{55D98E11-54C8-4694-9916-6163FE05F5A8}" dt="2025-11-18T15:31:52.945" v="507" actId="478"/>
+          <ac:picMkLst>
+            <pc:docMk/>
+            <pc:sldMk cId="3453003941" sldId="277"/>
+            <ac:picMk id="10" creationId="{09D445DF-7869-1FA0-84A6-E2A2F7F6253D}"/>
+          </ac:picMkLst>
+        </pc:picChg>
+        <pc:picChg chg="add">
+          <ac:chgData name="Dilan De Silva" userId="579b606d6e18a4ed" providerId="LiveId" clId="{55D98E11-54C8-4694-9916-6163FE05F5A8}" dt="2025-11-18T15:40:03.735" v="523" actId="22"/>
+          <ac:picMkLst>
+            <pc:docMk/>
+            <pc:sldMk cId="3453003941" sldId="277"/>
+            <ac:picMk id="11" creationId="{68A495A5-6363-9B2E-64BD-AEF158815488}"/>
+          </ac:picMkLst>
+        </pc:picChg>
+        <pc:picChg chg="del">
+          <ac:chgData name="Dilan De Silva" userId="579b606d6e18a4ed" providerId="LiveId" clId="{55D98E11-54C8-4694-9916-6163FE05F5A8}" dt="2025-11-18T15:31:53.552" v="508" actId="478"/>
+          <ac:picMkLst>
+            <pc:docMk/>
+            <pc:sldMk cId="3453003941" sldId="277"/>
+            <ac:picMk id="13" creationId="{5E481A39-DC67-2632-72F0-C4166854E027}"/>
+          </ac:picMkLst>
+        </pc:picChg>
+        <pc:picChg chg="add mod">
+          <ac:chgData name="Dilan De Silva" userId="579b606d6e18a4ed" providerId="LiveId" clId="{55D98E11-54C8-4694-9916-6163FE05F5A8}" dt="2025-11-18T15:40:32.630" v="525" actId="1076"/>
+          <ac:picMkLst>
+            <pc:docMk/>
+            <pc:sldMk cId="3453003941" sldId="277"/>
+            <ac:picMk id="14" creationId="{04456895-17CB-48FA-CD56-DA99B7494BA1}"/>
+          </ac:picMkLst>
+        </pc:picChg>
+        <pc:picChg chg="add mod">
+          <ac:chgData name="Dilan De Silva" userId="579b606d6e18a4ed" providerId="LiveId" clId="{55D98E11-54C8-4694-9916-6163FE05F5A8}" dt="2025-11-18T15:41:36.485" v="529" actId="1076"/>
+          <ac:picMkLst>
+            <pc:docMk/>
+            <pc:sldMk cId="3453003941" sldId="277"/>
+            <ac:picMk id="16" creationId="{38948D4B-DBBC-932F-0C05-B5756E2D274D}"/>
+          </ac:picMkLst>
+        </pc:picChg>
+      </pc:sldChg>
+      <pc:sldChg chg="addSp delSp modSp add del mod">
+        <pc:chgData name="Dilan De Silva" userId="579b606d6e18a4ed" providerId="LiveId" clId="{55D98E11-54C8-4694-9916-6163FE05F5A8}" dt="2025-11-18T14:45:21.290" v="379" actId="47"/>
+        <pc:sldMkLst>
+          <pc:docMk/>
+          <pc:sldMk cId="3361234612" sldId="278"/>
+        </pc:sldMkLst>
+        <pc:spChg chg="mod">
+          <ac:chgData name="Dilan De Silva" userId="579b606d6e18a4ed" providerId="LiveId" clId="{55D98E11-54C8-4694-9916-6163FE05F5A8}" dt="2025-11-18T14:02:25.009" v="360" actId="20577"/>
+          <ac:spMkLst>
+            <pc:docMk/>
+            <pc:sldMk cId="3361234612" sldId="278"/>
+            <ac:spMk id="2" creationId="{0D99EFB3-5059-CBDE-FA3E-89046402DF79}"/>
+          </ac:spMkLst>
+        </pc:spChg>
+        <pc:picChg chg="add mod">
+          <ac:chgData name="Dilan De Silva" userId="579b606d6e18a4ed" providerId="LiveId" clId="{55D98E11-54C8-4694-9916-6163FE05F5A8}" dt="2025-11-18T14:06:10.363" v="369" actId="14100"/>
+          <ac:picMkLst>
+            <pc:docMk/>
+            <pc:sldMk cId="3361234612" sldId="278"/>
+            <ac:picMk id="4" creationId="{D6574518-9792-16C5-59E5-ECCD43CE59CE}"/>
+          </ac:picMkLst>
+        </pc:picChg>
+        <pc:picChg chg="del">
+          <ac:chgData name="Dilan De Silva" userId="579b606d6e18a4ed" providerId="LiveId" clId="{55D98E11-54C8-4694-9916-6163FE05F5A8}" dt="2025-11-18T14:02:52.545" v="364" actId="478"/>
+          <ac:picMkLst>
+            <pc:docMk/>
+            <pc:sldMk cId="3361234612" sldId="278"/>
+            <ac:picMk id="5" creationId="{5C9381A7-CD1C-CCF2-44B1-BB4AE500B722}"/>
+          </ac:picMkLst>
+        </pc:picChg>
+        <pc:picChg chg="del">
+          <ac:chgData name="Dilan De Silva" userId="579b606d6e18a4ed" providerId="LiveId" clId="{55D98E11-54C8-4694-9916-6163FE05F5A8}" dt="2025-11-18T14:02:53.150" v="365" actId="478"/>
+          <ac:picMkLst>
+            <pc:docMk/>
+            <pc:sldMk cId="3361234612" sldId="278"/>
+            <ac:picMk id="7" creationId="{A4937320-F802-2721-03AB-AD20E18B20DB}"/>
+          </ac:picMkLst>
+        </pc:picChg>
+        <pc:picChg chg="add mod">
+          <ac:chgData name="Dilan De Silva" userId="579b606d6e18a4ed" providerId="LiveId" clId="{55D98E11-54C8-4694-9916-6163FE05F5A8}" dt="2025-11-18T14:06:34.105" v="374" actId="14100"/>
+          <ac:picMkLst>
+            <pc:docMk/>
+            <pc:sldMk cId="3361234612" sldId="278"/>
+            <ac:picMk id="8" creationId="{E5B9E5C9-8A0A-3D2D-B61B-7D4803D1D4D9}"/>
+          </ac:picMkLst>
+        </pc:picChg>
+        <pc:picChg chg="add del">
+          <ac:chgData name="Dilan De Silva" userId="579b606d6e18a4ed" providerId="LiveId" clId="{55D98E11-54C8-4694-9916-6163FE05F5A8}" dt="2025-11-18T14:02:51.253" v="363" actId="478"/>
+          <ac:picMkLst>
+            <pc:docMk/>
+            <pc:sldMk cId="3361234612" sldId="278"/>
+            <ac:picMk id="9" creationId="{27381ADE-E50A-406C-D0D7-2DB77BA18D6C}"/>
+          </ac:picMkLst>
+        </pc:picChg>
+        <pc:picChg chg="add mod">
+          <ac:chgData name="Dilan De Silva" userId="579b606d6e18a4ed" providerId="LiveId" clId="{55D98E11-54C8-4694-9916-6163FE05F5A8}" dt="2025-11-18T14:07:06.022" v="376" actId="1076"/>
+          <ac:picMkLst>
+            <pc:docMk/>
+            <pc:sldMk cId="3361234612" sldId="278"/>
+            <ac:picMk id="11" creationId="{4637A0E3-F52E-542D-D7BE-4E403B2108B9}"/>
+          </ac:picMkLst>
+        </pc:picChg>
+        <pc:picChg chg="del">
+          <ac:chgData name="Dilan De Silva" userId="579b606d6e18a4ed" providerId="LiveId" clId="{55D98E11-54C8-4694-9916-6163FE05F5A8}" dt="2025-11-18T14:02:28.512" v="361" actId="478"/>
+          <ac:picMkLst>
+            <pc:docMk/>
+            <pc:sldMk cId="3361234612" sldId="278"/>
+            <ac:picMk id="13" creationId="{C387D0D9-0F44-8B8C-9E06-4A14274DFC74}"/>
           </ac:picMkLst>
         </pc:picChg>
       </pc:sldChg>
@@ -489,7 +1675,7 @@
           <a:p>
             <a:fld id="{2D73D9AC-D42E-4620-8482-0397FE94AE8B}" type="datetimeFigureOut">
               <a:rPr lang="en-AU" smtClean="0"/>
-              <a:t>16/11/2025</a:t>
+              <a:t>18/11/2025</a:t>
             </a:fld>
             <a:endParaRPr lang="en-AU"/>
           </a:p>
@@ -689,7 +1875,7 @@
           <a:p>
             <a:fld id="{2D73D9AC-D42E-4620-8482-0397FE94AE8B}" type="datetimeFigureOut">
               <a:rPr lang="en-AU" smtClean="0"/>
-              <a:t>16/11/2025</a:t>
+              <a:t>18/11/2025</a:t>
             </a:fld>
             <a:endParaRPr lang="en-AU"/>
           </a:p>
@@ -899,7 +2085,7 @@
           <a:p>
             <a:fld id="{2D73D9AC-D42E-4620-8482-0397FE94AE8B}" type="datetimeFigureOut">
               <a:rPr lang="en-AU" smtClean="0"/>
-              <a:t>16/11/2025</a:t>
+              <a:t>18/11/2025</a:t>
             </a:fld>
             <a:endParaRPr lang="en-AU"/>
           </a:p>
@@ -1099,7 +2285,7 @@
           <a:p>
             <a:fld id="{2D73D9AC-D42E-4620-8482-0397FE94AE8B}" type="datetimeFigureOut">
               <a:rPr lang="en-AU" smtClean="0"/>
-              <a:t>16/11/2025</a:t>
+              <a:t>18/11/2025</a:t>
             </a:fld>
             <a:endParaRPr lang="en-AU"/>
           </a:p>
@@ -1375,7 +2561,7 @@
           <a:p>
             <a:fld id="{2D73D9AC-D42E-4620-8482-0397FE94AE8B}" type="datetimeFigureOut">
               <a:rPr lang="en-AU" smtClean="0"/>
-              <a:t>16/11/2025</a:t>
+              <a:t>18/11/2025</a:t>
             </a:fld>
             <a:endParaRPr lang="en-AU"/>
           </a:p>
@@ -1643,7 +2829,7 @@
           <a:p>
             <a:fld id="{2D73D9AC-D42E-4620-8482-0397FE94AE8B}" type="datetimeFigureOut">
               <a:rPr lang="en-AU" smtClean="0"/>
-              <a:t>16/11/2025</a:t>
+              <a:t>18/11/2025</a:t>
             </a:fld>
             <a:endParaRPr lang="en-AU"/>
           </a:p>
@@ -2058,7 +3244,7 @@
           <a:p>
             <a:fld id="{2D73D9AC-D42E-4620-8482-0397FE94AE8B}" type="datetimeFigureOut">
               <a:rPr lang="en-AU" smtClean="0"/>
-              <a:t>16/11/2025</a:t>
+              <a:t>18/11/2025</a:t>
             </a:fld>
             <a:endParaRPr lang="en-AU"/>
           </a:p>
@@ -2200,7 +3386,7 @@
           <a:p>
             <a:fld id="{2D73D9AC-D42E-4620-8482-0397FE94AE8B}" type="datetimeFigureOut">
               <a:rPr lang="en-AU" smtClean="0"/>
-              <a:t>16/11/2025</a:t>
+              <a:t>18/11/2025</a:t>
             </a:fld>
             <a:endParaRPr lang="en-AU"/>
           </a:p>
@@ -2313,7 +3499,7 @@
           <a:p>
             <a:fld id="{2D73D9AC-D42E-4620-8482-0397FE94AE8B}" type="datetimeFigureOut">
               <a:rPr lang="en-AU" smtClean="0"/>
-              <a:t>16/11/2025</a:t>
+              <a:t>18/11/2025</a:t>
             </a:fld>
             <a:endParaRPr lang="en-AU"/>
           </a:p>
@@ -2626,7 +3812,7 @@
           <a:p>
             <a:fld id="{2D73D9AC-D42E-4620-8482-0397FE94AE8B}" type="datetimeFigureOut">
               <a:rPr lang="en-AU" smtClean="0"/>
-              <a:t>16/11/2025</a:t>
+              <a:t>18/11/2025</a:t>
             </a:fld>
             <a:endParaRPr lang="en-AU"/>
           </a:p>
@@ -2915,7 +4101,7 @@
           <a:p>
             <a:fld id="{2D73D9AC-D42E-4620-8482-0397FE94AE8B}" type="datetimeFigureOut">
               <a:rPr lang="en-AU" smtClean="0"/>
-              <a:t>16/11/2025</a:t>
+              <a:t>18/11/2025</a:t>
             </a:fld>
             <a:endParaRPr lang="en-AU"/>
           </a:p>
@@ -3158,7 +4344,7 @@
           <a:p>
             <a:fld id="{2D73D9AC-D42E-4620-8482-0397FE94AE8B}" type="datetimeFigureOut">
               <a:rPr lang="en-AU" smtClean="0"/>
-              <a:t>16/11/2025</a:t>
+              <a:t>18/11/2025</a:t>
             </a:fld>
             <a:endParaRPr lang="en-AU"/>
           </a:p>
@@ -4776,6 +5962,1016 @@
 </p:sld>
 </file>
 
+<file path=ppt/slides/slide16.xml><?xml version="1.0" encoding="utf-8"?>
+<p:sld xmlns:a="http://schemas.openxmlformats.org/drawingml/2006/main" xmlns:r="http://schemas.openxmlformats.org/officeDocument/2006/relationships" xmlns:p="http://schemas.openxmlformats.org/presentationml/2006/main">
+  <p:cSld>
+    <p:spTree>
+      <p:nvGrpSpPr>
+        <p:cNvPr id="1" name="">
+          <a:extLst>
+            <a:ext uri="{FF2B5EF4-FFF2-40B4-BE49-F238E27FC236}">
+              <a16:creationId xmlns:a16="http://schemas.microsoft.com/office/drawing/2014/main" id="{B05C4315-56EC-0EE5-89A2-39FE6EF7E277}"/>
+            </a:ext>
+          </a:extLst>
+        </p:cNvPr>
+        <p:cNvGrpSpPr/>
+        <p:nvPr/>
+      </p:nvGrpSpPr>
+      <p:grpSpPr>
+        <a:xfrm>
+          <a:off x="0" y="0"/>
+          <a:ext cx="0" cy="0"/>
+          <a:chOff x="0" y="0"/>
+          <a:chExt cx="0" cy="0"/>
+        </a:xfrm>
+      </p:grpSpPr>
+      <p:sp>
+        <p:nvSpPr>
+          <p:cNvPr id="2" name="Title 1">
+            <a:extLst>
+              <a:ext uri="{FF2B5EF4-FFF2-40B4-BE49-F238E27FC236}">
+                <a16:creationId xmlns:a16="http://schemas.microsoft.com/office/drawing/2014/main" id="{326C68D0-23E3-3F12-7098-2A1C235EC35A}"/>
+              </a:ext>
+            </a:extLst>
+          </p:cNvPr>
+          <p:cNvSpPr>
+            <a:spLocks noGrp="1"/>
+          </p:cNvSpPr>
+          <p:nvPr>
+            <p:ph type="title"/>
+          </p:nvPr>
+        </p:nvSpPr>
+        <p:spPr/>
+        <p:txBody>
+          <a:bodyPr/>
+          <a:lstStyle/>
+          <a:p>
+            <a:r>
+              <a:rPr lang="en-AU" dirty="0"/>
+              <a:t>XGB Model 2</a:t>
+            </a:r>
+          </a:p>
+        </p:txBody>
+      </p:sp>
+      <p:pic>
+        <p:nvPicPr>
+          <p:cNvPr id="5" name="Picture 4">
+            <a:extLst>
+              <a:ext uri="{FF2B5EF4-FFF2-40B4-BE49-F238E27FC236}">
+                <a16:creationId xmlns:a16="http://schemas.microsoft.com/office/drawing/2014/main" id="{AF65B7FD-A905-EE78-31CC-EC4A7A89F9EC}"/>
+              </a:ext>
+            </a:extLst>
+          </p:cNvPr>
+          <p:cNvPicPr>
+            <a:picLocks noChangeAspect="1"/>
+          </p:cNvPicPr>
+          <p:nvPr/>
+        </p:nvPicPr>
+        <p:blipFill>
+          <a:blip r:embed="rId2"/>
+          <a:stretch>
+            <a:fillRect/>
+          </a:stretch>
+        </p:blipFill>
+        <p:spPr>
+          <a:xfrm>
+            <a:off x="277746" y="1682088"/>
+            <a:ext cx="2207106" cy="1999600"/>
+          </a:xfrm>
+          <a:prstGeom prst="rect">
+            <a:avLst/>
+          </a:prstGeom>
+        </p:spPr>
+      </p:pic>
+      <p:pic>
+        <p:nvPicPr>
+          <p:cNvPr id="8" name="Picture 7">
+            <a:extLst>
+              <a:ext uri="{FF2B5EF4-FFF2-40B4-BE49-F238E27FC236}">
+                <a16:creationId xmlns:a16="http://schemas.microsoft.com/office/drawing/2014/main" id="{BAD29697-4901-99EE-926D-418EC149ADB7}"/>
+              </a:ext>
+            </a:extLst>
+          </p:cNvPr>
+          <p:cNvPicPr>
+            <a:picLocks noChangeAspect="1"/>
+          </p:cNvPicPr>
+          <p:nvPr/>
+        </p:nvPicPr>
+        <p:blipFill>
+          <a:blip r:embed="rId3"/>
+          <a:stretch>
+            <a:fillRect/>
+          </a:stretch>
+        </p:blipFill>
+        <p:spPr>
+          <a:xfrm>
+            <a:off x="162059" y="3940540"/>
+            <a:ext cx="2743164" cy="2552335"/>
+          </a:xfrm>
+          <a:prstGeom prst="rect">
+            <a:avLst/>
+          </a:prstGeom>
+        </p:spPr>
+      </p:pic>
+      <p:pic>
+        <p:nvPicPr>
+          <p:cNvPr id="11" name="Picture 10">
+            <a:extLst>
+              <a:ext uri="{FF2B5EF4-FFF2-40B4-BE49-F238E27FC236}">
+                <a16:creationId xmlns:a16="http://schemas.microsoft.com/office/drawing/2014/main" id="{29678640-CB9D-2281-43A9-F4A7BEBC571C}"/>
+              </a:ext>
+            </a:extLst>
+          </p:cNvPr>
+          <p:cNvPicPr>
+            <a:picLocks noChangeAspect="1"/>
+          </p:cNvPicPr>
+          <p:nvPr/>
+        </p:nvPicPr>
+        <p:blipFill>
+          <a:blip r:embed="rId4"/>
+          <a:stretch>
+            <a:fillRect/>
+          </a:stretch>
+        </p:blipFill>
+        <p:spPr>
+          <a:xfrm>
+            <a:off x="5600042" y="0"/>
+            <a:ext cx="2216603" cy="6858000"/>
+          </a:xfrm>
+          <a:prstGeom prst="rect">
+            <a:avLst/>
+          </a:prstGeom>
+        </p:spPr>
+      </p:pic>
+      <p:pic>
+        <p:nvPicPr>
+          <p:cNvPr id="14" name="Picture 13">
+            <a:extLst>
+              <a:ext uri="{FF2B5EF4-FFF2-40B4-BE49-F238E27FC236}">
+                <a16:creationId xmlns:a16="http://schemas.microsoft.com/office/drawing/2014/main" id="{6A1A8F6A-7204-307E-3F4D-028687846424}"/>
+              </a:ext>
+            </a:extLst>
+          </p:cNvPr>
+          <p:cNvPicPr>
+            <a:picLocks noChangeAspect="1"/>
+          </p:cNvPicPr>
+          <p:nvPr/>
+        </p:nvPicPr>
+        <p:blipFill>
+          <a:blip r:embed="rId5"/>
+          <a:stretch>
+            <a:fillRect/>
+          </a:stretch>
+        </p:blipFill>
+        <p:spPr>
+          <a:xfrm>
+            <a:off x="7816645" y="0"/>
+            <a:ext cx="2218403" cy="6858000"/>
+          </a:xfrm>
+          <a:prstGeom prst="rect">
+            <a:avLst/>
+          </a:prstGeom>
+        </p:spPr>
+      </p:pic>
+      <p:pic>
+        <p:nvPicPr>
+          <p:cNvPr id="17" name="Picture 16">
+            <a:extLst>
+              <a:ext uri="{FF2B5EF4-FFF2-40B4-BE49-F238E27FC236}">
+                <a16:creationId xmlns:a16="http://schemas.microsoft.com/office/drawing/2014/main" id="{1187DB19-34F6-5C2C-2C61-6CF67DAD8251}"/>
+              </a:ext>
+            </a:extLst>
+          </p:cNvPr>
+          <p:cNvPicPr>
+            <a:picLocks noChangeAspect="1"/>
+          </p:cNvPicPr>
+          <p:nvPr/>
+        </p:nvPicPr>
+        <p:blipFill>
+          <a:blip r:embed="rId6"/>
+          <a:stretch>
+            <a:fillRect/>
+          </a:stretch>
+        </p:blipFill>
+        <p:spPr>
+          <a:xfrm>
+            <a:off x="10035048" y="0"/>
+            <a:ext cx="2156952" cy="6858000"/>
+          </a:xfrm>
+          <a:prstGeom prst="rect">
+            <a:avLst/>
+          </a:prstGeom>
+        </p:spPr>
+      </p:pic>
+      <p:pic>
+        <p:nvPicPr>
+          <p:cNvPr id="19" name="Picture 18">
+            <a:extLst>
+              <a:ext uri="{FF2B5EF4-FFF2-40B4-BE49-F238E27FC236}">
+                <a16:creationId xmlns:a16="http://schemas.microsoft.com/office/drawing/2014/main" id="{CB8D3467-518A-5823-A85F-C3D46F3C4F5E}"/>
+              </a:ext>
+            </a:extLst>
+          </p:cNvPr>
+          <p:cNvPicPr>
+            <a:picLocks noChangeAspect="1"/>
+          </p:cNvPicPr>
+          <p:nvPr/>
+        </p:nvPicPr>
+        <p:blipFill>
+          <a:blip r:embed="rId7"/>
+          <a:stretch>
+            <a:fillRect/>
+          </a:stretch>
+        </p:blipFill>
+        <p:spPr>
+          <a:xfrm>
+            <a:off x="2821530" y="2249497"/>
+            <a:ext cx="2590609" cy="873381"/>
+          </a:xfrm>
+          <a:prstGeom prst="rect">
+            <a:avLst/>
+          </a:prstGeom>
+        </p:spPr>
+      </p:pic>
+    </p:spTree>
+    <p:extLst>
+      <p:ext uri="{BB962C8B-B14F-4D97-AF65-F5344CB8AC3E}">
+        <p14:creationId xmlns:p14="http://schemas.microsoft.com/office/powerpoint/2010/main" val="3936721459"/>
+      </p:ext>
+    </p:extLst>
+  </p:cSld>
+  <p:clrMapOvr>
+    <a:masterClrMapping/>
+  </p:clrMapOvr>
+</p:sld>
+</file>
+
+<file path=ppt/slides/slide17.xml><?xml version="1.0" encoding="utf-8"?>
+<p:sld xmlns:a="http://schemas.openxmlformats.org/drawingml/2006/main" xmlns:r="http://schemas.openxmlformats.org/officeDocument/2006/relationships" xmlns:p="http://schemas.openxmlformats.org/presentationml/2006/main">
+  <p:cSld>
+    <p:spTree>
+      <p:nvGrpSpPr>
+        <p:cNvPr id="1" name="">
+          <a:extLst>
+            <a:ext uri="{FF2B5EF4-FFF2-40B4-BE49-F238E27FC236}">
+              <a16:creationId xmlns:a16="http://schemas.microsoft.com/office/drawing/2014/main" id="{437CAFDA-590E-7D3B-BA8C-034B8708B78B}"/>
+            </a:ext>
+          </a:extLst>
+        </p:cNvPr>
+        <p:cNvGrpSpPr/>
+        <p:nvPr/>
+      </p:nvGrpSpPr>
+      <p:grpSpPr>
+        <a:xfrm>
+          <a:off x="0" y="0"/>
+          <a:ext cx="0" cy="0"/>
+          <a:chOff x="0" y="0"/>
+          <a:chExt cx="0" cy="0"/>
+        </a:xfrm>
+      </p:grpSpPr>
+      <p:sp>
+        <p:nvSpPr>
+          <p:cNvPr id="2" name="Title 1">
+            <a:extLst>
+              <a:ext uri="{FF2B5EF4-FFF2-40B4-BE49-F238E27FC236}">
+                <a16:creationId xmlns:a16="http://schemas.microsoft.com/office/drawing/2014/main" id="{76DD7B40-3BC6-D784-C574-7DECB63209BD}"/>
+              </a:ext>
+            </a:extLst>
+          </p:cNvPr>
+          <p:cNvSpPr>
+            <a:spLocks noGrp="1"/>
+          </p:cNvSpPr>
+          <p:nvPr>
+            <p:ph type="title"/>
+          </p:nvPr>
+        </p:nvSpPr>
+        <p:spPr/>
+        <p:txBody>
+          <a:bodyPr/>
+          <a:lstStyle/>
+          <a:p>
+            <a:r>
+              <a:rPr lang="en-AU" dirty="0"/>
+              <a:t>RF on same data</a:t>
+            </a:r>
+          </a:p>
+        </p:txBody>
+      </p:sp>
+      <p:pic>
+        <p:nvPicPr>
+          <p:cNvPr id="4" name="Picture 3">
+            <a:extLst>
+              <a:ext uri="{FF2B5EF4-FFF2-40B4-BE49-F238E27FC236}">
+                <a16:creationId xmlns:a16="http://schemas.microsoft.com/office/drawing/2014/main" id="{54A2B921-A557-9DE4-3940-CBAD32198160}"/>
+              </a:ext>
+            </a:extLst>
+          </p:cNvPr>
+          <p:cNvPicPr>
+            <a:picLocks noChangeAspect="1"/>
+          </p:cNvPicPr>
+          <p:nvPr/>
+        </p:nvPicPr>
+        <p:blipFill>
+          <a:blip r:embed="rId2"/>
+          <a:stretch>
+            <a:fillRect/>
+          </a:stretch>
+        </p:blipFill>
+        <p:spPr>
+          <a:xfrm>
+            <a:off x="327512" y="1415341"/>
+            <a:ext cx="2210113" cy="2013659"/>
+          </a:xfrm>
+          <a:prstGeom prst="rect">
+            <a:avLst/>
+          </a:prstGeom>
+        </p:spPr>
+      </p:pic>
+      <p:pic>
+        <p:nvPicPr>
+          <p:cNvPr id="7" name="Picture 6">
+            <a:extLst>
+              <a:ext uri="{FF2B5EF4-FFF2-40B4-BE49-F238E27FC236}">
+                <a16:creationId xmlns:a16="http://schemas.microsoft.com/office/drawing/2014/main" id="{E9EC54E5-6D18-9852-42DF-E1A515DD8628}"/>
+              </a:ext>
+            </a:extLst>
+          </p:cNvPr>
+          <p:cNvPicPr>
+            <a:picLocks noChangeAspect="1"/>
+          </p:cNvPicPr>
+          <p:nvPr/>
+        </p:nvPicPr>
+        <p:blipFill>
+          <a:blip r:embed="rId3"/>
+          <a:stretch>
+            <a:fillRect/>
+          </a:stretch>
+        </p:blipFill>
+        <p:spPr>
+          <a:xfrm>
+            <a:off x="327513" y="3640539"/>
+            <a:ext cx="2187446" cy="2013659"/>
+          </a:xfrm>
+          <a:prstGeom prst="rect">
+            <a:avLst/>
+          </a:prstGeom>
+        </p:spPr>
+      </p:pic>
+      <p:pic>
+        <p:nvPicPr>
+          <p:cNvPr id="10" name="Picture 9">
+            <a:extLst>
+              <a:ext uri="{FF2B5EF4-FFF2-40B4-BE49-F238E27FC236}">
+                <a16:creationId xmlns:a16="http://schemas.microsoft.com/office/drawing/2014/main" id="{B655EC6B-9803-26FF-9931-5A486B6158CF}"/>
+              </a:ext>
+            </a:extLst>
+          </p:cNvPr>
+          <p:cNvPicPr>
+            <a:picLocks noChangeAspect="1"/>
+          </p:cNvPicPr>
+          <p:nvPr/>
+        </p:nvPicPr>
+        <p:blipFill>
+          <a:blip r:embed="rId4"/>
+          <a:stretch>
+            <a:fillRect/>
+          </a:stretch>
+        </p:blipFill>
+        <p:spPr>
+          <a:xfrm>
+            <a:off x="327512" y="5990287"/>
+            <a:ext cx="5468113" cy="200053"/>
+          </a:xfrm>
+          <a:prstGeom prst="rect">
+            <a:avLst/>
+          </a:prstGeom>
+        </p:spPr>
+      </p:pic>
+      <p:pic>
+        <p:nvPicPr>
+          <p:cNvPr id="13" name="Picture 12">
+            <a:extLst>
+              <a:ext uri="{FF2B5EF4-FFF2-40B4-BE49-F238E27FC236}">
+                <a16:creationId xmlns:a16="http://schemas.microsoft.com/office/drawing/2014/main" id="{98D78295-9820-8529-BE1A-2EAA869E4015}"/>
+              </a:ext>
+            </a:extLst>
+          </p:cNvPr>
+          <p:cNvPicPr>
+            <a:picLocks noChangeAspect="1"/>
+          </p:cNvPicPr>
+          <p:nvPr/>
+        </p:nvPicPr>
+        <p:blipFill>
+          <a:blip r:embed="rId5"/>
+          <a:stretch>
+            <a:fillRect/>
+          </a:stretch>
+        </p:blipFill>
+        <p:spPr>
+          <a:xfrm>
+            <a:off x="5812847" y="0"/>
+            <a:ext cx="2216464" cy="6858000"/>
+          </a:xfrm>
+          <a:prstGeom prst="rect">
+            <a:avLst/>
+          </a:prstGeom>
+        </p:spPr>
+      </p:pic>
+      <p:pic>
+        <p:nvPicPr>
+          <p:cNvPr id="16" name="Picture 15">
+            <a:extLst>
+              <a:ext uri="{FF2B5EF4-FFF2-40B4-BE49-F238E27FC236}">
+                <a16:creationId xmlns:a16="http://schemas.microsoft.com/office/drawing/2014/main" id="{6EB31A8E-1C9E-B475-35A1-7C78106A02D1}"/>
+              </a:ext>
+            </a:extLst>
+          </p:cNvPr>
+          <p:cNvPicPr>
+            <a:picLocks noChangeAspect="1"/>
+          </p:cNvPicPr>
+          <p:nvPr/>
+        </p:nvPicPr>
+        <p:blipFill>
+          <a:blip r:embed="rId6"/>
+          <a:stretch>
+            <a:fillRect/>
+          </a:stretch>
+        </p:blipFill>
+        <p:spPr>
+          <a:xfrm>
+            <a:off x="8029311" y="0"/>
+            <a:ext cx="2093624" cy="6858000"/>
+          </a:xfrm>
+          <a:prstGeom prst="rect">
+            <a:avLst/>
+          </a:prstGeom>
+        </p:spPr>
+      </p:pic>
+      <p:pic>
+        <p:nvPicPr>
+          <p:cNvPr id="20" name="Picture 19">
+            <a:extLst>
+              <a:ext uri="{FF2B5EF4-FFF2-40B4-BE49-F238E27FC236}">
+                <a16:creationId xmlns:a16="http://schemas.microsoft.com/office/drawing/2014/main" id="{777B34DD-5B14-B60E-365A-B41EE8261732}"/>
+              </a:ext>
+            </a:extLst>
+          </p:cNvPr>
+          <p:cNvPicPr>
+            <a:picLocks noChangeAspect="1"/>
+          </p:cNvPicPr>
+          <p:nvPr/>
+        </p:nvPicPr>
+        <p:blipFill>
+          <a:blip r:embed="rId7"/>
+          <a:stretch>
+            <a:fillRect/>
+          </a:stretch>
+        </p:blipFill>
+        <p:spPr>
+          <a:xfrm>
+            <a:off x="10122935" y="0"/>
+            <a:ext cx="2069065" cy="6858000"/>
+          </a:xfrm>
+          <a:prstGeom prst="rect">
+            <a:avLst/>
+          </a:prstGeom>
+        </p:spPr>
+      </p:pic>
+    </p:spTree>
+    <p:extLst>
+      <p:ext uri="{BB962C8B-B14F-4D97-AF65-F5344CB8AC3E}">
+        <p14:creationId xmlns:p14="http://schemas.microsoft.com/office/powerpoint/2010/main" val="3689886638"/>
+      </p:ext>
+    </p:extLst>
+  </p:cSld>
+  <p:clrMapOvr>
+    <a:masterClrMapping/>
+  </p:clrMapOvr>
+</p:sld>
+</file>
+
+<file path=ppt/slides/slide18.xml><?xml version="1.0" encoding="utf-8"?>
+<p:sld xmlns:a="http://schemas.openxmlformats.org/drawingml/2006/main" xmlns:r="http://schemas.openxmlformats.org/officeDocument/2006/relationships" xmlns:p="http://schemas.openxmlformats.org/presentationml/2006/main">
+  <p:cSld>
+    <p:spTree>
+      <p:nvGrpSpPr>
+        <p:cNvPr id="1" name=""/>
+        <p:cNvGrpSpPr/>
+        <p:nvPr/>
+      </p:nvGrpSpPr>
+      <p:grpSpPr>
+        <a:xfrm>
+          <a:off x="0" y="0"/>
+          <a:ext cx="0" cy="0"/>
+          <a:chOff x="0" y="0"/>
+          <a:chExt cx="0" cy="0"/>
+        </a:xfrm>
+      </p:grpSpPr>
+      <p:sp>
+        <p:nvSpPr>
+          <p:cNvPr id="2" name="Title 1">
+            <a:extLst>
+              <a:ext uri="{FF2B5EF4-FFF2-40B4-BE49-F238E27FC236}">
+                <a16:creationId xmlns:a16="http://schemas.microsoft.com/office/drawing/2014/main" id="{5FACF89F-33D2-9EF4-EDE0-3583CF672AE6}"/>
+              </a:ext>
+            </a:extLst>
+          </p:cNvPr>
+          <p:cNvSpPr>
+            <a:spLocks noGrp="1"/>
+          </p:cNvSpPr>
+          <p:nvPr>
+            <p:ph type="title"/>
+          </p:nvPr>
+        </p:nvSpPr>
+        <p:spPr>
+          <a:xfrm>
+            <a:off x="206914" y="344654"/>
+            <a:ext cx="3300561" cy="1325563"/>
+          </a:xfrm>
+        </p:spPr>
+        <p:txBody>
+          <a:bodyPr/>
+          <a:lstStyle/>
+          <a:p>
+            <a:r>
+              <a:rPr lang="en-AU" dirty="0"/>
+              <a:t>XGB Model 1</a:t>
+            </a:r>
+          </a:p>
+        </p:txBody>
+      </p:sp>
+      <p:pic>
+        <p:nvPicPr>
+          <p:cNvPr id="19" name="Picture 18">
+            <a:extLst>
+              <a:ext uri="{FF2B5EF4-FFF2-40B4-BE49-F238E27FC236}">
+                <a16:creationId xmlns:a16="http://schemas.microsoft.com/office/drawing/2014/main" id="{00CCED33-49B5-FAA6-6167-5C6ECFB76BEA}"/>
+              </a:ext>
+            </a:extLst>
+          </p:cNvPr>
+          <p:cNvPicPr>
+            <a:picLocks noChangeAspect="1"/>
+          </p:cNvPicPr>
+          <p:nvPr/>
+        </p:nvPicPr>
+        <p:blipFill>
+          <a:blip r:embed="rId2"/>
+          <a:stretch>
+            <a:fillRect/>
+          </a:stretch>
+        </p:blipFill>
+        <p:spPr>
+          <a:xfrm>
+            <a:off x="1182296" y="2581057"/>
+            <a:ext cx="1970554" cy="1859394"/>
+          </a:xfrm>
+          <a:prstGeom prst="rect">
+            <a:avLst/>
+          </a:prstGeom>
+        </p:spPr>
+      </p:pic>
+      <p:pic>
+        <p:nvPicPr>
+          <p:cNvPr id="21" name="Picture 20">
+            <a:extLst>
+              <a:ext uri="{FF2B5EF4-FFF2-40B4-BE49-F238E27FC236}">
+                <a16:creationId xmlns:a16="http://schemas.microsoft.com/office/drawing/2014/main" id="{32581F66-711F-8E1A-FB35-42A9B61D5760}"/>
+              </a:ext>
+            </a:extLst>
+          </p:cNvPr>
+          <p:cNvPicPr>
+            <a:picLocks noChangeAspect="1"/>
+          </p:cNvPicPr>
+          <p:nvPr/>
+        </p:nvPicPr>
+        <p:blipFill>
+          <a:blip r:embed="rId3"/>
+          <a:stretch>
+            <a:fillRect/>
+          </a:stretch>
+        </p:blipFill>
+        <p:spPr>
+          <a:xfrm>
+            <a:off x="1182296" y="4542324"/>
+            <a:ext cx="1970554" cy="1846767"/>
+          </a:xfrm>
+          <a:prstGeom prst="rect">
+            <a:avLst/>
+          </a:prstGeom>
+        </p:spPr>
+      </p:pic>
+      <p:pic>
+        <p:nvPicPr>
+          <p:cNvPr id="23" name="Picture 22">
+            <a:extLst>
+              <a:ext uri="{FF2B5EF4-FFF2-40B4-BE49-F238E27FC236}">
+                <a16:creationId xmlns:a16="http://schemas.microsoft.com/office/drawing/2014/main" id="{51D539E0-AEC2-9307-5BCE-3C55365181FE}"/>
+              </a:ext>
+            </a:extLst>
+          </p:cNvPr>
+          <p:cNvPicPr>
+            <a:picLocks noChangeAspect="1"/>
+          </p:cNvPicPr>
+          <p:nvPr/>
+        </p:nvPicPr>
+        <p:blipFill>
+          <a:blip r:embed="rId4"/>
+          <a:stretch>
+            <a:fillRect/>
+          </a:stretch>
+        </p:blipFill>
+        <p:spPr>
+          <a:xfrm>
+            <a:off x="350447" y="1255494"/>
+            <a:ext cx="3611954" cy="1223690"/>
+          </a:xfrm>
+          <a:prstGeom prst="rect">
+            <a:avLst/>
+          </a:prstGeom>
+        </p:spPr>
+      </p:pic>
+      <p:pic>
+        <p:nvPicPr>
+          <p:cNvPr id="25" name="Picture 24">
+            <a:extLst>
+              <a:ext uri="{FF2B5EF4-FFF2-40B4-BE49-F238E27FC236}">
+                <a16:creationId xmlns:a16="http://schemas.microsoft.com/office/drawing/2014/main" id="{E82160D3-55D6-69FF-14C3-C607A7EE8EEB}"/>
+              </a:ext>
+            </a:extLst>
+          </p:cNvPr>
+          <p:cNvPicPr>
+            <a:picLocks noChangeAspect="1"/>
+          </p:cNvPicPr>
+          <p:nvPr/>
+        </p:nvPicPr>
+        <p:blipFill>
+          <a:blip r:embed="rId5"/>
+          <a:stretch>
+            <a:fillRect/>
+          </a:stretch>
+        </p:blipFill>
+        <p:spPr>
+          <a:xfrm>
+            <a:off x="5331962" y="0"/>
+            <a:ext cx="1528075" cy="6858000"/>
+          </a:xfrm>
+          <a:prstGeom prst="rect">
+            <a:avLst/>
+          </a:prstGeom>
+        </p:spPr>
+      </p:pic>
+      <p:pic>
+        <p:nvPicPr>
+          <p:cNvPr id="27" name="Picture 26">
+            <a:extLst>
+              <a:ext uri="{FF2B5EF4-FFF2-40B4-BE49-F238E27FC236}">
+                <a16:creationId xmlns:a16="http://schemas.microsoft.com/office/drawing/2014/main" id="{37BD9F3D-3199-F7E1-693B-F84C84A2C2CF}"/>
+              </a:ext>
+            </a:extLst>
+          </p:cNvPr>
+          <p:cNvPicPr>
+            <a:picLocks noChangeAspect="1"/>
+          </p:cNvPicPr>
+          <p:nvPr/>
+        </p:nvPicPr>
+        <p:blipFill>
+          <a:blip r:embed="rId6"/>
+          <a:stretch>
+            <a:fillRect/>
+          </a:stretch>
+        </p:blipFill>
+        <p:spPr>
+          <a:xfrm>
+            <a:off x="6943725" y="0"/>
+            <a:ext cx="1543050" cy="6858000"/>
+          </a:xfrm>
+          <a:prstGeom prst="rect">
+            <a:avLst/>
+          </a:prstGeom>
+        </p:spPr>
+      </p:pic>
+      <p:pic>
+        <p:nvPicPr>
+          <p:cNvPr id="29" name="Picture 28">
+            <a:extLst>
+              <a:ext uri="{FF2B5EF4-FFF2-40B4-BE49-F238E27FC236}">
+                <a16:creationId xmlns:a16="http://schemas.microsoft.com/office/drawing/2014/main" id="{93EE4C4A-95EF-54CC-BB52-8B5BB1E71A56}"/>
+              </a:ext>
+            </a:extLst>
+          </p:cNvPr>
+          <p:cNvPicPr>
+            <a:picLocks noChangeAspect="1"/>
+          </p:cNvPicPr>
+          <p:nvPr/>
+        </p:nvPicPr>
+        <p:blipFill>
+          <a:blip r:embed="rId7"/>
+          <a:stretch>
+            <a:fillRect/>
+          </a:stretch>
+        </p:blipFill>
+        <p:spPr>
+          <a:xfrm>
+            <a:off x="8570463" y="0"/>
+            <a:ext cx="1510356" cy="6858000"/>
+          </a:xfrm>
+          <a:prstGeom prst="rect">
+            <a:avLst/>
+          </a:prstGeom>
+        </p:spPr>
+      </p:pic>
+      <p:pic>
+        <p:nvPicPr>
+          <p:cNvPr id="31" name="Picture 30">
+            <a:extLst>
+              <a:ext uri="{FF2B5EF4-FFF2-40B4-BE49-F238E27FC236}">
+                <a16:creationId xmlns:a16="http://schemas.microsoft.com/office/drawing/2014/main" id="{5700D302-264E-64B4-4030-52C82AAD27DD}"/>
+              </a:ext>
+            </a:extLst>
+          </p:cNvPr>
+          <p:cNvPicPr>
+            <a:picLocks noChangeAspect="1"/>
+          </p:cNvPicPr>
+          <p:nvPr/>
+        </p:nvPicPr>
+        <p:blipFill>
+          <a:blip r:embed="rId8"/>
+          <a:stretch>
+            <a:fillRect/>
+          </a:stretch>
+        </p:blipFill>
+        <p:spPr>
+          <a:xfrm>
+            <a:off x="10258619" y="2798721"/>
+            <a:ext cx="1717482" cy="441638"/>
+          </a:xfrm>
+          <a:prstGeom prst="rect">
+            <a:avLst/>
+          </a:prstGeom>
+        </p:spPr>
+      </p:pic>
+    </p:spTree>
+    <p:extLst>
+      <p:ext uri="{BB962C8B-B14F-4D97-AF65-F5344CB8AC3E}">
+        <p14:creationId xmlns:p14="http://schemas.microsoft.com/office/powerpoint/2010/main" val="4139802702"/>
+      </p:ext>
+    </p:extLst>
+  </p:cSld>
+  <p:clrMapOvr>
+    <a:masterClrMapping/>
+  </p:clrMapOvr>
+</p:sld>
+</file>
+
+<file path=ppt/slides/slide19.xml><?xml version="1.0" encoding="utf-8"?>
+<p:sld xmlns:a="http://schemas.openxmlformats.org/drawingml/2006/main" xmlns:r="http://schemas.openxmlformats.org/officeDocument/2006/relationships" xmlns:p="http://schemas.openxmlformats.org/presentationml/2006/main">
+  <p:cSld>
+    <p:spTree>
+      <p:nvGrpSpPr>
+        <p:cNvPr id="1" name="">
+          <a:extLst>
+            <a:ext uri="{FF2B5EF4-FFF2-40B4-BE49-F238E27FC236}">
+              <a16:creationId xmlns:a16="http://schemas.microsoft.com/office/drawing/2014/main" id="{E10C690A-4596-E686-6059-D309C75A47A0}"/>
+            </a:ext>
+          </a:extLst>
+        </p:cNvPr>
+        <p:cNvGrpSpPr/>
+        <p:nvPr/>
+      </p:nvGrpSpPr>
+      <p:grpSpPr>
+        <a:xfrm>
+          <a:off x="0" y="0"/>
+          <a:ext cx="0" cy="0"/>
+          <a:chOff x="0" y="0"/>
+          <a:chExt cx="0" cy="0"/>
+        </a:xfrm>
+      </p:grpSpPr>
+      <p:sp>
+        <p:nvSpPr>
+          <p:cNvPr id="2" name="Title 1">
+            <a:extLst>
+              <a:ext uri="{FF2B5EF4-FFF2-40B4-BE49-F238E27FC236}">
+                <a16:creationId xmlns:a16="http://schemas.microsoft.com/office/drawing/2014/main" id="{262CDD4C-6FC6-76B9-4382-9C4718F679B8}"/>
+              </a:ext>
+            </a:extLst>
+          </p:cNvPr>
+          <p:cNvSpPr>
+            <a:spLocks noGrp="1"/>
+          </p:cNvSpPr>
+          <p:nvPr>
+            <p:ph type="title"/>
+          </p:nvPr>
+        </p:nvSpPr>
+        <p:spPr>
+          <a:xfrm>
+            <a:off x="206914" y="344654"/>
+            <a:ext cx="3300561" cy="1325563"/>
+          </a:xfrm>
+        </p:spPr>
+        <p:txBody>
+          <a:bodyPr/>
+          <a:lstStyle/>
+          <a:p>
+            <a:r>
+              <a:rPr lang="en-AU" dirty="0"/>
+              <a:t>XGB Model 2</a:t>
+            </a:r>
+          </a:p>
+        </p:txBody>
+      </p:sp>
+      <p:pic>
+        <p:nvPicPr>
+          <p:cNvPr id="4" name="Picture 3">
+            <a:extLst>
+              <a:ext uri="{FF2B5EF4-FFF2-40B4-BE49-F238E27FC236}">
+                <a16:creationId xmlns:a16="http://schemas.microsoft.com/office/drawing/2014/main" id="{E9F50768-6799-4A54-63B2-C5691E3EB269}"/>
+              </a:ext>
+            </a:extLst>
+          </p:cNvPr>
+          <p:cNvPicPr>
+            <a:picLocks noChangeAspect="1"/>
+          </p:cNvPicPr>
+          <p:nvPr/>
+        </p:nvPicPr>
+        <p:blipFill>
+          <a:blip r:embed="rId2"/>
+          <a:stretch>
+            <a:fillRect/>
+          </a:stretch>
+        </p:blipFill>
+        <p:spPr>
+          <a:xfrm>
+            <a:off x="206914" y="2527300"/>
+            <a:ext cx="2177639" cy="2054588"/>
+          </a:xfrm>
+          <a:prstGeom prst="rect">
+            <a:avLst/>
+          </a:prstGeom>
+        </p:spPr>
+      </p:pic>
+      <p:pic>
+        <p:nvPicPr>
+          <p:cNvPr id="6" name="Picture 5">
+            <a:extLst>
+              <a:ext uri="{FF2B5EF4-FFF2-40B4-BE49-F238E27FC236}">
+                <a16:creationId xmlns:a16="http://schemas.microsoft.com/office/drawing/2014/main" id="{9119BECF-185E-D7BE-C577-82F97E8525A5}"/>
+              </a:ext>
+            </a:extLst>
+          </p:cNvPr>
+          <p:cNvPicPr>
+            <a:picLocks noChangeAspect="1"/>
+          </p:cNvPicPr>
+          <p:nvPr/>
+        </p:nvPicPr>
+        <p:blipFill>
+          <a:blip r:embed="rId3"/>
+          <a:stretch>
+            <a:fillRect/>
+          </a:stretch>
+        </p:blipFill>
+        <p:spPr>
+          <a:xfrm>
+            <a:off x="206914" y="4686300"/>
+            <a:ext cx="2156189" cy="2054588"/>
+          </a:xfrm>
+          <a:prstGeom prst="rect">
+            <a:avLst/>
+          </a:prstGeom>
+        </p:spPr>
+      </p:pic>
+      <p:pic>
+        <p:nvPicPr>
+          <p:cNvPr id="8" name="Picture 7">
+            <a:extLst>
+              <a:ext uri="{FF2B5EF4-FFF2-40B4-BE49-F238E27FC236}">
+                <a16:creationId xmlns:a16="http://schemas.microsoft.com/office/drawing/2014/main" id="{ECE6AE80-3F19-CCC6-F0AC-C01D860B7D0B}"/>
+              </a:ext>
+            </a:extLst>
+          </p:cNvPr>
+          <p:cNvPicPr>
+            <a:picLocks noChangeAspect="1"/>
+          </p:cNvPicPr>
+          <p:nvPr/>
+        </p:nvPicPr>
+        <p:blipFill>
+          <a:blip r:embed="rId4"/>
+          <a:stretch>
+            <a:fillRect/>
+          </a:stretch>
+        </p:blipFill>
+        <p:spPr>
+          <a:xfrm>
+            <a:off x="206914" y="1292088"/>
+            <a:ext cx="3482436" cy="1168374"/>
+          </a:xfrm>
+          <a:prstGeom prst="rect">
+            <a:avLst/>
+          </a:prstGeom>
+        </p:spPr>
+      </p:pic>
+      <p:pic>
+        <p:nvPicPr>
+          <p:cNvPr id="10" name="Picture 9">
+            <a:extLst>
+              <a:ext uri="{FF2B5EF4-FFF2-40B4-BE49-F238E27FC236}">
+                <a16:creationId xmlns:a16="http://schemas.microsoft.com/office/drawing/2014/main" id="{79823171-E320-AE26-F2B8-17716067C339}"/>
+              </a:ext>
+            </a:extLst>
+          </p:cNvPr>
+          <p:cNvPicPr>
+            <a:picLocks noChangeAspect="1"/>
+          </p:cNvPicPr>
+          <p:nvPr/>
+        </p:nvPicPr>
+        <p:blipFill>
+          <a:blip r:embed="rId5"/>
+          <a:stretch>
+            <a:fillRect/>
+          </a:stretch>
+        </p:blipFill>
+        <p:spPr>
+          <a:xfrm>
+            <a:off x="5378803" y="0"/>
+            <a:ext cx="1434393" cy="6858000"/>
+          </a:xfrm>
+          <a:prstGeom prst="rect">
+            <a:avLst/>
+          </a:prstGeom>
+        </p:spPr>
+      </p:pic>
+      <p:pic>
+        <p:nvPicPr>
+          <p:cNvPr id="14" name="Picture 13">
+            <a:extLst>
+              <a:ext uri="{FF2B5EF4-FFF2-40B4-BE49-F238E27FC236}">
+                <a16:creationId xmlns:a16="http://schemas.microsoft.com/office/drawing/2014/main" id="{4587CB42-F6A0-D31A-9C89-276867F34375}"/>
+              </a:ext>
+            </a:extLst>
+          </p:cNvPr>
+          <p:cNvPicPr>
+            <a:picLocks noChangeAspect="1"/>
+          </p:cNvPicPr>
+          <p:nvPr/>
+        </p:nvPicPr>
+        <p:blipFill>
+          <a:blip r:embed="rId6"/>
+          <a:stretch>
+            <a:fillRect/>
+          </a:stretch>
+        </p:blipFill>
+        <p:spPr>
+          <a:xfrm>
+            <a:off x="7471600" y="0"/>
+            <a:ext cx="1452499" cy="6858000"/>
+          </a:xfrm>
+          <a:prstGeom prst="rect">
+            <a:avLst/>
+          </a:prstGeom>
+        </p:spPr>
+      </p:pic>
+      <p:pic>
+        <p:nvPicPr>
+          <p:cNvPr id="16" name="Picture 15">
+            <a:extLst>
+              <a:ext uri="{FF2B5EF4-FFF2-40B4-BE49-F238E27FC236}">
+                <a16:creationId xmlns:a16="http://schemas.microsoft.com/office/drawing/2014/main" id="{75634E41-B956-EDEB-DC8A-ED777FB17081}"/>
+              </a:ext>
+            </a:extLst>
+          </p:cNvPr>
+          <p:cNvPicPr>
+            <a:picLocks noChangeAspect="1"/>
+          </p:cNvPicPr>
+          <p:nvPr/>
+        </p:nvPicPr>
+        <p:blipFill>
+          <a:blip r:embed="rId7"/>
+          <a:stretch>
+            <a:fillRect/>
+          </a:stretch>
+        </p:blipFill>
+        <p:spPr>
+          <a:xfrm>
+            <a:off x="9693122" y="790228"/>
+            <a:ext cx="2191056" cy="4972744"/>
+          </a:xfrm>
+          <a:prstGeom prst="rect">
+            <a:avLst/>
+          </a:prstGeom>
+        </p:spPr>
+      </p:pic>
+    </p:spTree>
+    <p:extLst>
+      <p:ext uri="{BB962C8B-B14F-4D97-AF65-F5344CB8AC3E}">
+        <p14:creationId xmlns:p14="http://schemas.microsoft.com/office/powerpoint/2010/main" val="3294159094"/>
+      </p:ext>
+    </p:extLst>
+  </p:cSld>
+  <p:clrMapOvr>
+    <a:masterClrMapping/>
+  </p:clrMapOvr>
+</p:sld>
+</file>
+
 <file path=ppt/slides/slide2.xml><?xml version="1.0" encoding="utf-8"?>
 <p:sld xmlns:a="http://schemas.openxmlformats.org/drawingml/2006/main" xmlns:r="http://schemas.openxmlformats.org/officeDocument/2006/relationships" xmlns:p="http://schemas.openxmlformats.org/presentationml/2006/main">
   <p:cSld>
@@ -4898,6 +7094,633 @@
     <p:extLst>
       <p:ext uri="{BB962C8B-B14F-4D97-AF65-F5344CB8AC3E}">
         <p14:creationId xmlns:p14="http://schemas.microsoft.com/office/powerpoint/2010/main" val="1969437762"/>
+      </p:ext>
+    </p:extLst>
+  </p:cSld>
+  <p:clrMapOvr>
+    <a:masterClrMapping/>
+  </p:clrMapOvr>
+</p:sld>
+</file>
+
+<file path=ppt/slides/slide20.xml><?xml version="1.0" encoding="utf-8"?>
+<p:sld xmlns:a="http://schemas.openxmlformats.org/drawingml/2006/main" xmlns:r="http://schemas.openxmlformats.org/officeDocument/2006/relationships" xmlns:p="http://schemas.openxmlformats.org/presentationml/2006/main">
+  <p:cSld>
+    <p:spTree>
+      <p:nvGrpSpPr>
+        <p:cNvPr id="1" name="">
+          <a:extLst>
+            <a:ext uri="{FF2B5EF4-FFF2-40B4-BE49-F238E27FC236}">
+              <a16:creationId xmlns:a16="http://schemas.microsoft.com/office/drawing/2014/main" id="{7A401E7E-06CC-6DC7-2D26-068F7F72503A}"/>
+            </a:ext>
+          </a:extLst>
+        </p:cNvPr>
+        <p:cNvGrpSpPr/>
+        <p:nvPr/>
+      </p:nvGrpSpPr>
+      <p:grpSpPr>
+        <a:xfrm>
+          <a:off x="0" y="0"/>
+          <a:ext cx="0" cy="0"/>
+          <a:chOff x="0" y="0"/>
+          <a:chExt cx="0" cy="0"/>
+        </a:xfrm>
+      </p:grpSpPr>
+      <p:sp>
+        <p:nvSpPr>
+          <p:cNvPr id="2" name="Title 1">
+            <a:extLst>
+              <a:ext uri="{FF2B5EF4-FFF2-40B4-BE49-F238E27FC236}">
+                <a16:creationId xmlns:a16="http://schemas.microsoft.com/office/drawing/2014/main" id="{5FBE89E3-D607-20A6-052B-6B9FA1840448}"/>
+              </a:ext>
+            </a:extLst>
+          </p:cNvPr>
+          <p:cNvSpPr>
+            <a:spLocks noGrp="1"/>
+          </p:cNvSpPr>
+          <p:nvPr>
+            <p:ph type="title"/>
+          </p:nvPr>
+        </p:nvSpPr>
+        <p:spPr>
+          <a:xfrm>
+            <a:off x="206914" y="344654"/>
+            <a:ext cx="3300561" cy="1325563"/>
+          </a:xfrm>
+        </p:spPr>
+        <p:txBody>
+          <a:bodyPr/>
+          <a:lstStyle/>
+          <a:p>
+            <a:r>
+              <a:rPr lang="en-AU" dirty="0"/>
+              <a:t>XGB Model 3</a:t>
+            </a:r>
+          </a:p>
+        </p:txBody>
+      </p:sp>
+      <p:pic>
+        <p:nvPicPr>
+          <p:cNvPr id="5" name="Picture 4">
+            <a:extLst>
+              <a:ext uri="{FF2B5EF4-FFF2-40B4-BE49-F238E27FC236}">
+                <a16:creationId xmlns:a16="http://schemas.microsoft.com/office/drawing/2014/main" id="{354426C8-CA7F-B716-6ED4-DA78D16685A5}"/>
+              </a:ext>
+            </a:extLst>
+          </p:cNvPr>
+          <p:cNvPicPr>
+            <a:picLocks noChangeAspect="1"/>
+          </p:cNvPicPr>
+          <p:nvPr/>
+        </p:nvPicPr>
+        <p:blipFill>
+          <a:blip r:embed="rId2"/>
+          <a:stretch>
+            <a:fillRect/>
+          </a:stretch>
+        </p:blipFill>
+        <p:spPr>
+          <a:xfrm>
+            <a:off x="241790" y="1313086"/>
+            <a:ext cx="3265685" cy="1109802"/>
+          </a:xfrm>
+          <a:prstGeom prst="rect">
+            <a:avLst/>
+          </a:prstGeom>
+        </p:spPr>
+      </p:pic>
+      <p:pic>
+        <p:nvPicPr>
+          <p:cNvPr id="9" name="Picture 8">
+            <a:extLst>
+              <a:ext uri="{FF2B5EF4-FFF2-40B4-BE49-F238E27FC236}">
+                <a16:creationId xmlns:a16="http://schemas.microsoft.com/office/drawing/2014/main" id="{3A10A73E-7DE7-E133-19DF-BE8FCDAF3130}"/>
+              </a:ext>
+            </a:extLst>
+          </p:cNvPr>
+          <p:cNvPicPr>
+            <a:picLocks noChangeAspect="1"/>
+          </p:cNvPicPr>
+          <p:nvPr/>
+        </p:nvPicPr>
+        <p:blipFill>
+          <a:blip r:embed="rId3"/>
+          <a:stretch>
+            <a:fillRect/>
+          </a:stretch>
+        </p:blipFill>
+        <p:spPr>
+          <a:xfrm>
+            <a:off x="241791" y="2509591"/>
+            <a:ext cx="2138598" cy="2017959"/>
+          </a:xfrm>
+          <a:prstGeom prst="rect">
+            <a:avLst/>
+          </a:prstGeom>
+        </p:spPr>
+      </p:pic>
+      <p:pic>
+        <p:nvPicPr>
+          <p:cNvPr id="12" name="Picture 11">
+            <a:extLst>
+              <a:ext uri="{FF2B5EF4-FFF2-40B4-BE49-F238E27FC236}">
+                <a16:creationId xmlns:a16="http://schemas.microsoft.com/office/drawing/2014/main" id="{2ACB8EC5-F22B-E91B-789D-B1A7EE770F43}"/>
+              </a:ext>
+            </a:extLst>
+          </p:cNvPr>
+          <p:cNvPicPr>
+            <a:picLocks noChangeAspect="1"/>
+          </p:cNvPicPr>
+          <p:nvPr/>
+        </p:nvPicPr>
+        <p:blipFill>
+          <a:blip r:embed="rId4"/>
+          <a:stretch>
+            <a:fillRect/>
+          </a:stretch>
+        </p:blipFill>
+        <p:spPr>
+          <a:xfrm>
+            <a:off x="241790" y="4610515"/>
+            <a:ext cx="2138598" cy="2045615"/>
+          </a:xfrm>
+          <a:prstGeom prst="rect">
+            <a:avLst/>
+          </a:prstGeom>
+        </p:spPr>
+      </p:pic>
+      <p:pic>
+        <p:nvPicPr>
+          <p:cNvPr id="15" name="Picture 14">
+            <a:extLst>
+              <a:ext uri="{FF2B5EF4-FFF2-40B4-BE49-F238E27FC236}">
+                <a16:creationId xmlns:a16="http://schemas.microsoft.com/office/drawing/2014/main" id="{C384A4D8-1E66-2666-636D-37B93779702C}"/>
+              </a:ext>
+            </a:extLst>
+          </p:cNvPr>
+          <p:cNvPicPr>
+            <a:picLocks noChangeAspect="1"/>
+          </p:cNvPicPr>
+          <p:nvPr/>
+        </p:nvPicPr>
+        <p:blipFill>
+          <a:blip r:embed="rId5"/>
+          <a:stretch>
+            <a:fillRect/>
+          </a:stretch>
+        </p:blipFill>
+        <p:spPr>
+          <a:xfrm>
+            <a:off x="5350698" y="0"/>
+            <a:ext cx="1490603" cy="6858000"/>
+          </a:xfrm>
+          <a:prstGeom prst="rect">
+            <a:avLst/>
+          </a:prstGeom>
+        </p:spPr>
+      </p:pic>
+      <p:pic>
+        <p:nvPicPr>
+          <p:cNvPr id="18" name="Picture 17">
+            <a:extLst>
+              <a:ext uri="{FF2B5EF4-FFF2-40B4-BE49-F238E27FC236}">
+                <a16:creationId xmlns:a16="http://schemas.microsoft.com/office/drawing/2014/main" id="{3042E0C0-52F6-E26F-9AA2-924F04627D55}"/>
+              </a:ext>
+            </a:extLst>
+          </p:cNvPr>
+          <p:cNvPicPr>
+            <a:picLocks noChangeAspect="1"/>
+          </p:cNvPicPr>
+          <p:nvPr/>
+        </p:nvPicPr>
+        <p:blipFill>
+          <a:blip r:embed="rId6"/>
+          <a:stretch>
+            <a:fillRect/>
+          </a:stretch>
+        </p:blipFill>
+        <p:spPr>
+          <a:xfrm>
+            <a:off x="7637301" y="772765"/>
+            <a:ext cx="2314898" cy="4982270"/>
+          </a:xfrm>
+          <a:prstGeom prst="rect">
+            <a:avLst/>
+          </a:prstGeom>
+        </p:spPr>
+      </p:pic>
+    </p:spTree>
+    <p:extLst>
+      <p:ext uri="{BB962C8B-B14F-4D97-AF65-F5344CB8AC3E}">
+        <p14:creationId xmlns:p14="http://schemas.microsoft.com/office/powerpoint/2010/main" val="56286589"/>
+      </p:ext>
+    </p:extLst>
+  </p:cSld>
+  <p:clrMapOvr>
+    <a:masterClrMapping/>
+  </p:clrMapOvr>
+</p:sld>
+</file>
+
+<file path=ppt/slides/slide21.xml><?xml version="1.0" encoding="utf-8"?>
+<p:sld xmlns:a="http://schemas.openxmlformats.org/drawingml/2006/main" xmlns:r="http://schemas.openxmlformats.org/officeDocument/2006/relationships" xmlns:p="http://schemas.openxmlformats.org/presentationml/2006/main">
+  <p:cSld>
+    <p:spTree>
+      <p:nvGrpSpPr>
+        <p:cNvPr id="1" name="">
+          <a:extLst>
+            <a:ext uri="{FF2B5EF4-FFF2-40B4-BE49-F238E27FC236}">
+              <a16:creationId xmlns:a16="http://schemas.microsoft.com/office/drawing/2014/main" id="{091D1550-C255-B668-2A53-95ACBDD1E2E9}"/>
+            </a:ext>
+          </a:extLst>
+        </p:cNvPr>
+        <p:cNvGrpSpPr/>
+        <p:nvPr/>
+      </p:nvGrpSpPr>
+      <p:grpSpPr>
+        <a:xfrm>
+          <a:off x="0" y="0"/>
+          <a:ext cx="0" cy="0"/>
+          <a:chOff x="0" y="0"/>
+          <a:chExt cx="0" cy="0"/>
+        </a:xfrm>
+      </p:grpSpPr>
+      <p:sp>
+        <p:nvSpPr>
+          <p:cNvPr id="2" name="Title 1">
+            <a:extLst>
+              <a:ext uri="{FF2B5EF4-FFF2-40B4-BE49-F238E27FC236}">
+                <a16:creationId xmlns:a16="http://schemas.microsoft.com/office/drawing/2014/main" id="{9DBFAC5B-B282-5B20-E8A6-932852798C62}"/>
+              </a:ext>
+            </a:extLst>
+          </p:cNvPr>
+          <p:cNvSpPr>
+            <a:spLocks noGrp="1"/>
+          </p:cNvSpPr>
+          <p:nvPr>
+            <p:ph type="title"/>
+          </p:nvPr>
+        </p:nvSpPr>
+        <p:spPr>
+          <a:xfrm>
+            <a:off x="206914" y="344654"/>
+            <a:ext cx="3300561" cy="1325563"/>
+          </a:xfrm>
+        </p:spPr>
+        <p:txBody>
+          <a:bodyPr/>
+          <a:lstStyle/>
+          <a:p>
+            <a:r>
+              <a:rPr lang="en-AU" dirty="0"/>
+              <a:t>XGB Model 4</a:t>
+            </a:r>
+          </a:p>
+        </p:txBody>
+      </p:sp>
+      <p:pic>
+        <p:nvPicPr>
+          <p:cNvPr id="4" name="Picture 3">
+            <a:extLst>
+              <a:ext uri="{FF2B5EF4-FFF2-40B4-BE49-F238E27FC236}">
+                <a16:creationId xmlns:a16="http://schemas.microsoft.com/office/drawing/2014/main" id="{13967056-D28F-30A2-BB73-38E511074B4B}"/>
+              </a:ext>
+            </a:extLst>
+          </p:cNvPr>
+          <p:cNvPicPr>
+            <a:picLocks noChangeAspect="1"/>
+          </p:cNvPicPr>
+          <p:nvPr/>
+        </p:nvPicPr>
+        <p:blipFill>
+          <a:blip r:embed="rId2"/>
+          <a:stretch>
+            <a:fillRect/>
+          </a:stretch>
+        </p:blipFill>
+        <p:spPr>
+          <a:xfrm>
+            <a:off x="241790" y="1291950"/>
+            <a:ext cx="3349213" cy="1134676"/>
+          </a:xfrm>
+          <a:prstGeom prst="rect">
+            <a:avLst/>
+          </a:prstGeom>
+        </p:spPr>
+      </p:pic>
+      <p:pic>
+        <p:nvPicPr>
+          <p:cNvPr id="7" name="Picture 6">
+            <a:extLst>
+              <a:ext uri="{FF2B5EF4-FFF2-40B4-BE49-F238E27FC236}">
+                <a16:creationId xmlns:a16="http://schemas.microsoft.com/office/drawing/2014/main" id="{54E9097A-8445-B51C-D237-E7636AB5443D}"/>
+              </a:ext>
+            </a:extLst>
+          </p:cNvPr>
+          <p:cNvPicPr>
+            <a:picLocks noChangeAspect="1"/>
+          </p:cNvPicPr>
+          <p:nvPr/>
+        </p:nvPicPr>
+        <p:blipFill>
+          <a:blip r:embed="rId3"/>
+          <a:stretch>
+            <a:fillRect/>
+          </a:stretch>
+        </p:blipFill>
+        <p:spPr>
+          <a:xfrm>
+            <a:off x="241790" y="2548654"/>
+            <a:ext cx="2212381" cy="2076002"/>
+          </a:xfrm>
+          <a:prstGeom prst="rect">
+            <a:avLst/>
+          </a:prstGeom>
+        </p:spPr>
+      </p:pic>
+      <p:pic>
+        <p:nvPicPr>
+          <p:cNvPr id="10" name="Picture 9">
+            <a:extLst>
+              <a:ext uri="{FF2B5EF4-FFF2-40B4-BE49-F238E27FC236}">
+                <a16:creationId xmlns:a16="http://schemas.microsoft.com/office/drawing/2014/main" id="{E94241EB-BAD5-C185-348F-6F75788546D8}"/>
+              </a:ext>
+            </a:extLst>
+          </p:cNvPr>
+          <p:cNvPicPr>
+            <a:picLocks noChangeAspect="1"/>
+          </p:cNvPicPr>
+          <p:nvPr/>
+        </p:nvPicPr>
+        <p:blipFill>
+          <a:blip r:embed="rId4"/>
+          <a:stretch>
+            <a:fillRect/>
+          </a:stretch>
+        </p:blipFill>
+        <p:spPr>
+          <a:xfrm>
+            <a:off x="241791" y="4636878"/>
+            <a:ext cx="2212382" cy="2115856"/>
+          </a:xfrm>
+          <a:prstGeom prst="rect">
+            <a:avLst/>
+          </a:prstGeom>
+        </p:spPr>
+      </p:pic>
+      <p:pic>
+        <p:nvPicPr>
+          <p:cNvPr id="13" name="Picture 12">
+            <a:extLst>
+              <a:ext uri="{FF2B5EF4-FFF2-40B4-BE49-F238E27FC236}">
+                <a16:creationId xmlns:a16="http://schemas.microsoft.com/office/drawing/2014/main" id="{B2AAEA27-D0F5-F2A4-B9CA-217A8DC1B574}"/>
+              </a:ext>
+            </a:extLst>
+          </p:cNvPr>
+          <p:cNvPicPr>
+            <a:picLocks noChangeAspect="1"/>
+          </p:cNvPicPr>
+          <p:nvPr/>
+        </p:nvPicPr>
+        <p:blipFill>
+          <a:blip r:embed="rId5"/>
+          <a:stretch>
+            <a:fillRect/>
+          </a:stretch>
+        </p:blipFill>
+        <p:spPr>
+          <a:xfrm>
+            <a:off x="5140512" y="0"/>
+            <a:ext cx="1910975" cy="6858000"/>
+          </a:xfrm>
+          <a:prstGeom prst="rect">
+            <a:avLst/>
+          </a:prstGeom>
+        </p:spPr>
+      </p:pic>
+    </p:spTree>
+    <p:extLst>
+      <p:ext uri="{BB962C8B-B14F-4D97-AF65-F5344CB8AC3E}">
+        <p14:creationId xmlns:p14="http://schemas.microsoft.com/office/powerpoint/2010/main" val="4262127971"/>
+      </p:ext>
+    </p:extLst>
+  </p:cSld>
+  <p:clrMapOvr>
+    <a:masterClrMapping/>
+  </p:clrMapOvr>
+</p:sld>
+</file>
+
+<file path=ppt/slides/slide22.xml><?xml version="1.0" encoding="utf-8"?>
+<p:sld xmlns:a="http://schemas.openxmlformats.org/drawingml/2006/main" xmlns:r="http://schemas.openxmlformats.org/officeDocument/2006/relationships" xmlns:p="http://schemas.openxmlformats.org/presentationml/2006/main">
+  <p:cSld>
+    <p:spTree>
+      <p:nvGrpSpPr>
+        <p:cNvPr id="1" name="">
+          <a:extLst>
+            <a:ext uri="{FF2B5EF4-FFF2-40B4-BE49-F238E27FC236}">
+              <a16:creationId xmlns:a16="http://schemas.microsoft.com/office/drawing/2014/main" id="{077BFD6B-0442-9296-EAE9-C8D82D3C3F0A}"/>
+            </a:ext>
+          </a:extLst>
+        </p:cNvPr>
+        <p:cNvGrpSpPr/>
+        <p:nvPr/>
+      </p:nvGrpSpPr>
+      <p:grpSpPr>
+        <a:xfrm>
+          <a:off x="0" y="0"/>
+          <a:ext cx="0" cy="0"/>
+          <a:chOff x="0" y="0"/>
+          <a:chExt cx="0" cy="0"/>
+        </a:xfrm>
+      </p:grpSpPr>
+      <p:sp>
+        <p:nvSpPr>
+          <p:cNvPr id="2" name="Title 1">
+            <a:extLst>
+              <a:ext uri="{FF2B5EF4-FFF2-40B4-BE49-F238E27FC236}">
+                <a16:creationId xmlns:a16="http://schemas.microsoft.com/office/drawing/2014/main" id="{FD2E5C85-1145-4179-6CE7-1B7ECD323635}"/>
+              </a:ext>
+            </a:extLst>
+          </p:cNvPr>
+          <p:cNvSpPr>
+            <a:spLocks noGrp="1"/>
+          </p:cNvSpPr>
+          <p:nvPr>
+            <p:ph type="title"/>
+          </p:nvPr>
+        </p:nvSpPr>
+        <p:spPr>
+          <a:xfrm>
+            <a:off x="206914" y="344654"/>
+            <a:ext cx="3300561" cy="1325563"/>
+          </a:xfrm>
+        </p:spPr>
+        <p:txBody>
+          <a:bodyPr/>
+          <a:lstStyle/>
+          <a:p>
+            <a:r>
+              <a:rPr lang="en-AU" dirty="0"/>
+              <a:t>XGB Model 1</a:t>
+            </a:r>
+          </a:p>
+        </p:txBody>
+      </p:sp>
+      <p:pic>
+        <p:nvPicPr>
+          <p:cNvPr id="5" name="Picture 4">
+            <a:extLst>
+              <a:ext uri="{FF2B5EF4-FFF2-40B4-BE49-F238E27FC236}">
+                <a16:creationId xmlns:a16="http://schemas.microsoft.com/office/drawing/2014/main" id="{FB760F3A-65E4-C787-8B84-B12F934A2655}"/>
+              </a:ext>
+            </a:extLst>
+          </p:cNvPr>
+          <p:cNvPicPr>
+            <a:picLocks noChangeAspect="1"/>
+          </p:cNvPicPr>
+          <p:nvPr/>
+        </p:nvPicPr>
+        <p:blipFill>
+          <a:blip r:embed="rId2"/>
+          <a:stretch>
+            <a:fillRect/>
+          </a:stretch>
+        </p:blipFill>
+        <p:spPr>
+          <a:xfrm>
+            <a:off x="298063" y="2373156"/>
+            <a:ext cx="2187812" cy="2064186"/>
+          </a:xfrm>
+          <a:prstGeom prst="rect">
+            <a:avLst/>
+          </a:prstGeom>
+        </p:spPr>
+      </p:pic>
+      <p:pic>
+        <p:nvPicPr>
+          <p:cNvPr id="8" name="Picture 7">
+            <a:extLst>
+              <a:ext uri="{FF2B5EF4-FFF2-40B4-BE49-F238E27FC236}">
+                <a16:creationId xmlns:a16="http://schemas.microsoft.com/office/drawing/2014/main" id="{6F447E60-9BB6-26BA-0C5C-C52BD1F88047}"/>
+              </a:ext>
+            </a:extLst>
+          </p:cNvPr>
+          <p:cNvPicPr>
+            <a:picLocks noChangeAspect="1"/>
+          </p:cNvPicPr>
+          <p:nvPr/>
+        </p:nvPicPr>
+        <p:blipFill>
+          <a:blip r:embed="rId3"/>
+          <a:stretch>
+            <a:fillRect/>
+          </a:stretch>
+        </p:blipFill>
+        <p:spPr>
+          <a:xfrm>
+            <a:off x="298063" y="4502150"/>
+            <a:ext cx="2187812" cy="2092690"/>
+          </a:xfrm>
+          <a:prstGeom prst="rect">
+            <a:avLst/>
+          </a:prstGeom>
+        </p:spPr>
+      </p:pic>
+      <p:pic>
+        <p:nvPicPr>
+          <p:cNvPr id="11" name="Picture 10">
+            <a:extLst>
+              <a:ext uri="{FF2B5EF4-FFF2-40B4-BE49-F238E27FC236}">
+                <a16:creationId xmlns:a16="http://schemas.microsoft.com/office/drawing/2014/main" id="{68A495A5-6363-9B2E-64BD-AEF158815488}"/>
+              </a:ext>
+            </a:extLst>
+          </p:cNvPr>
+          <p:cNvPicPr>
+            <a:picLocks noChangeAspect="1"/>
+          </p:cNvPicPr>
+          <p:nvPr/>
+        </p:nvPicPr>
+        <p:blipFill>
+          <a:blip r:embed="rId4"/>
+          <a:stretch>
+            <a:fillRect/>
+          </a:stretch>
+        </p:blipFill>
+        <p:spPr>
+          <a:xfrm>
+            <a:off x="5406539" y="0"/>
+            <a:ext cx="1378921" cy="6858000"/>
+          </a:xfrm>
+          <a:prstGeom prst="rect">
+            <a:avLst/>
+          </a:prstGeom>
+        </p:spPr>
+      </p:pic>
+      <p:pic>
+        <p:nvPicPr>
+          <p:cNvPr id="14" name="Picture 13">
+            <a:extLst>
+              <a:ext uri="{FF2B5EF4-FFF2-40B4-BE49-F238E27FC236}">
+                <a16:creationId xmlns:a16="http://schemas.microsoft.com/office/drawing/2014/main" id="{04456895-17CB-48FA-CD56-DA99B7494BA1}"/>
+              </a:ext>
+            </a:extLst>
+          </p:cNvPr>
+          <p:cNvPicPr>
+            <a:picLocks noChangeAspect="1"/>
+          </p:cNvPicPr>
+          <p:nvPr/>
+        </p:nvPicPr>
+        <p:blipFill>
+          <a:blip r:embed="rId5"/>
+          <a:stretch>
+            <a:fillRect/>
+          </a:stretch>
+        </p:blipFill>
+        <p:spPr>
+          <a:xfrm>
+            <a:off x="7672235" y="3152736"/>
+            <a:ext cx="2181529" cy="552527"/>
+          </a:xfrm>
+          <a:prstGeom prst="rect">
+            <a:avLst/>
+          </a:prstGeom>
+        </p:spPr>
+      </p:pic>
+      <p:pic>
+        <p:nvPicPr>
+          <p:cNvPr id="16" name="Picture 15">
+            <a:extLst>
+              <a:ext uri="{FF2B5EF4-FFF2-40B4-BE49-F238E27FC236}">
+                <a16:creationId xmlns:a16="http://schemas.microsoft.com/office/drawing/2014/main" id="{38948D4B-DBBC-932F-0C05-B5756E2D274D}"/>
+              </a:ext>
+            </a:extLst>
+          </p:cNvPr>
+          <p:cNvPicPr>
+            <a:picLocks noChangeAspect="1"/>
+          </p:cNvPicPr>
+          <p:nvPr/>
+        </p:nvPicPr>
+        <p:blipFill>
+          <a:blip r:embed="rId6"/>
+          <a:stretch>
+            <a:fillRect/>
+          </a:stretch>
+        </p:blipFill>
+        <p:spPr>
+          <a:xfrm>
+            <a:off x="298063" y="1285980"/>
+            <a:ext cx="3032532" cy="1022368"/>
+          </a:xfrm>
+          <a:prstGeom prst="rect">
+            <a:avLst/>
+          </a:prstGeom>
+        </p:spPr>
+      </p:pic>
+    </p:spTree>
+    <p:extLst>
+      <p:ext uri="{BB962C8B-B14F-4D97-AF65-F5344CB8AC3E}">
+        <p14:creationId xmlns:p14="http://schemas.microsoft.com/office/powerpoint/2010/main" val="3453003941"/>
       </p:ext>
     </p:extLst>
   </p:cSld>

</xml_diff>